<commit_message>
Rename lesson one to Gemini Notebook
</commit_message>
<xml_diff>
--- a/class/ppt/lesson-01.pptx
+++ b/class/ppt/lesson-01.pptx
@@ -2,20 +2,20 @@
 <file path=ppt/presentation.xml><?xml version="1.0" encoding="utf-8"?>
 <p:presentation xmlns:p="http://schemas.openxmlformats.org/presentationml/2006/main">
   <p:sldMasterIdLst>
-    <p:sldMasterId xmlns:r="http://schemas.openxmlformats.org/officeDocument/2006/relationships" id="2147483648" r:id="R679c83b8b98f4743"/>
+    <p:sldMasterId xmlns:r="http://schemas.openxmlformats.org/officeDocument/2006/relationships" id="2147483648" r:id="R35be1b7238f344b0"/>
   </p:sldMasterIdLst>
   <p:notesMasterIdLst>
-    <p:notesMasterId xmlns:r="http://schemas.openxmlformats.org/officeDocument/2006/relationships" r:id="Re8d115a358094dda"/>
+    <p:notesMasterId xmlns:r="http://schemas.openxmlformats.org/officeDocument/2006/relationships" r:id="Rca91b37715164f50"/>
   </p:notesMasterIdLst>
   <p:sldIdLst>
-    <p:sldId xmlns:r="http://schemas.openxmlformats.org/officeDocument/2006/relationships" id="256" r:id="R7400a13c609e4ea1"/>
-    <p:sldId xmlns:r="http://schemas.openxmlformats.org/officeDocument/2006/relationships" id="257" r:id="Rc2312a039a08408f"/>
-    <p:sldId xmlns:r="http://schemas.openxmlformats.org/officeDocument/2006/relationships" id="258" r:id="Ra4da73d5e6bf4da0"/>
-    <p:sldId xmlns:r="http://schemas.openxmlformats.org/officeDocument/2006/relationships" id="259" r:id="R00391e85ccc0459c"/>
-    <p:sldId xmlns:r="http://schemas.openxmlformats.org/officeDocument/2006/relationships" id="260" r:id="R35bc2a2efcbe4e4a"/>
-    <p:sldId xmlns:r="http://schemas.openxmlformats.org/officeDocument/2006/relationships" id="261" r:id="R075cb0f3bf9b44d2"/>
-    <p:sldId xmlns:r="http://schemas.openxmlformats.org/officeDocument/2006/relationships" id="262" r:id="Rb5673afa12c748a5"/>
-    <p:sldId xmlns:r="http://schemas.openxmlformats.org/officeDocument/2006/relationships" id="263" r:id="R2115c4b2b9274423"/>
+    <p:sldId xmlns:r="http://schemas.openxmlformats.org/officeDocument/2006/relationships" id="256" r:id="R3f280e3981924491"/>
+    <p:sldId xmlns:r="http://schemas.openxmlformats.org/officeDocument/2006/relationships" id="257" r:id="Rb5a55effa1d748df"/>
+    <p:sldId xmlns:r="http://schemas.openxmlformats.org/officeDocument/2006/relationships" id="258" r:id="R9dbebcf2a92f4d13"/>
+    <p:sldId xmlns:r="http://schemas.openxmlformats.org/officeDocument/2006/relationships" id="259" r:id="R010f8f7c4d3f40d8"/>
+    <p:sldId xmlns:r="http://schemas.openxmlformats.org/officeDocument/2006/relationships" id="260" r:id="Rb2b8ad08206e413d"/>
+    <p:sldId xmlns:r="http://schemas.openxmlformats.org/officeDocument/2006/relationships" id="261" r:id="R295662d1ea3d46ea"/>
+    <p:sldId xmlns:r="http://schemas.openxmlformats.org/officeDocument/2006/relationships" id="262" r:id="Rd1f62dac82624405"/>
+    <p:sldId xmlns:r="http://schemas.openxmlformats.org/officeDocument/2006/relationships" id="263" r:id="Rb12f8bd87c854f19"/>
   </p:sldIdLst>
   <p:sldSz cx="12192000" cy="6858000"/>
   <p:notesSz cx="6858000" cy="9144000"/>
@@ -1127,7 +1127,7 @@
   </p:cSld>
   <p:clrMap bg1="lt1" tx1="dk1" bg2="lt2" tx2="dk2" accent1="accent1" accent2="accent2" accent3="accent3" accent4="accent4" accent5="accent5" accent6="accent6" hlink="hlink" folHlink="folHlink"/>
   <p:sldLayoutIdLst>
-    <p:sldLayoutId xmlns:r="http://schemas.openxmlformats.org/officeDocument/2006/relationships" id="2147483649" r:id="R1a5013706fd04467"/>
+    <p:sldLayoutId xmlns:r="http://schemas.openxmlformats.org/officeDocument/2006/relationships" id="2147483649" r:id="R692ee9321813448b"/>
   </p:sldLayoutIdLst>
   <p:txStyles>
     <p:titleStyle>
@@ -1678,7 +1678,7 @@
           <p:cNvPr id="8" name="">
             <a:extLst xmlns:a="http://schemas.openxmlformats.org/drawingml/2006/main">
               <a:ext uri="{FF2B5EF4-FFF2-40B4-BE49-F238E27FC236}">
-                <a16:creationId xmlns:a16="http://schemas.microsoft.com/office/drawing/2014/main" id="{FA2BBC6F-3241-4B88-9FEC-645B0A369B16}"/>
+                <a16:creationId xmlns:a16="http://schemas.microsoft.com/office/drawing/2014/main" id="{7E2FFBFC-6BAC-43E2-B99E-E718CCD9A310}"/>
               </a:ext>
             </a:extLst>
           </p:cNvPr>
@@ -1711,7 +1711,7 @@
           <p:cNvPr id="2" name="">
             <a:extLst xmlns:a="http://schemas.openxmlformats.org/drawingml/2006/main">
               <a:ext uri="{FF2B5EF4-FFF2-40B4-BE49-F238E27FC236}">
-                <a16:creationId xmlns:a16="http://schemas.microsoft.com/office/drawing/2014/main" id="{E442798D-6784-400A-B951-94E568B6D227}"/>
+                <a16:creationId xmlns:a16="http://schemas.microsoft.com/office/drawing/2014/main" id="{BF73B1A7-3449-4B11-B745-A511438852B6}"/>
               </a:ext>
             </a:extLst>
           </p:cNvPr>
@@ -1761,7 +1761,7 @@
           <p:cNvPr id="3" name="">
             <a:extLst xmlns:a="http://schemas.openxmlformats.org/drawingml/2006/main">
               <a:ext uri="{FF2B5EF4-FFF2-40B4-BE49-F238E27FC236}">
-                <a16:creationId xmlns:a16="http://schemas.microsoft.com/office/drawing/2014/main" id="{2BCBD997-C46D-4412-93C8-A235EED5F369}"/>
+                <a16:creationId xmlns:a16="http://schemas.microsoft.com/office/drawing/2014/main" id="{319E3025-018F-416F-AABE-429C2386C62D}"/>
               </a:ext>
             </a:extLst>
           </p:cNvPr>
@@ -1801,7 +1801,7 @@
                   <a:srgbClr val="111827"/>
                 </a:solidFill>
               </a:rPr>
-              <a:t>NotebookLM 遊戲化 RPG 簡報</a:t>
+              <a:t>Gemini Notebook 遊戲化 RPG 簡報</a:t>
             </a:r>
           </a:p>
         </p:txBody>
@@ -1811,7 +1811,7 @@
           <p:cNvPr id="4" name="">
             <a:extLst xmlns:a="http://schemas.openxmlformats.org/drawingml/2006/main">
               <a:ext uri="{FF2B5EF4-FFF2-40B4-BE49-F238E27FC236}">
-                <a16:creationId xmlns:a16="http://schemas.microsoft.com/office/drawing/2014/main" id="{38165F1C-126E-45F9-B4E5-EB360B8CF3A2}"/>
+                <a16:creationId xmlns:a16="http://schemas.microsoft.com/office/drawing/2014/main" id="{C88FC641-4D0D-4C02-B430-ED4423336BA5}"/>
               </a:ext>
             </a:extLst>
           </p:cNvPr>
@@ -1861,7 +1861,7 @@
           <p:cNvPr id="5" name="">
             <a:extLst xmlns:a="http://schemas.openxmlformats.org/drawingml/2006/main">
               <a:ext uri="{FF2B5EF4-FFF2-40B4-BE49-F238E27FC236}">
-                <a16:creationId xmlns:a16="http://schemas.microsoft.com/office/drawing/2014/main" id="{7DD20B58-DE30-428B-99A5-F5DBDA3E6C6E}"/>
+                <a16:creationId xmlns:a16="http://schemas.microsoft.com/office/drawing/2014/main" id="{6828A3D4-487A-446A-832A-D58994DE8CC4}"/>
               </a:ext>
             </a:extLst>
           </p:cNvPr>
@@ -1896,7 +1896,7 @@
           <p:cNvPr id="6" name="">
             <a:extLst xmlns:a="http://schemas.openxmlformats.org/drawingml/2006/main">
               <a:ext uri="{FF2B5EF4-FFF2-40B4-BE49-F238E27FC236}">
-                <a16:creationId xmlns:a16="http://schemas.microsoft.com/office/drawing/2014/main" id="{0CD3B888-3C20-42A7-A9E1-935C9060E4B9}"/>
+                <a16:creationId xmlns:a16="http://schemas.microsoft.com/office/drawing/2014/main" id="{D72D055B-1064-43B0-A4BA-F5AF5284CEAC}"/>
               </a:ext>
             </a:extLst>
           </p:cNvPr>
@@ -1946,7 +1946,7 @@
           <p:cNvPr id="7" name="">
             <a:extLst xmlns:a="http://schemas.openxmlformats.org/drawingml/2006/main">
               <a:ext uri="{FF2B5EF4-FFF2-40B4-BE49-F238E27FC236}">
-                <a16:creationId xmlns:a16="http://schemas.microsoft.com/office/drawing/2014/main" id="{FF37799B-82BB-4892-AC7C-7847AC93A2D2}"/>
+                <a16:creationId xmlns:a16="http://schemas.microsoft.com/office/drawing/2014/main" id="{B7FB236B-2A73-4B58-85A6-70C6E7D14EDB}"/>
               </a:ext>
             </a:extLst>
           </p:cNvPr>
@@ -2003,7 +2003,7 @@
                   <a:srgbClr val="111827"/>
                 </a:solidFill>
               </a:rPr>
-              <a:t>NotebookLM 遊戲化 RPG 簡報 v1</a:t>
+              <a:t>Gemini Notebook 遊戲化 RPG 簡報 v1</a:t>
             </a:r>
           </a:p>
         </p:txBody>
@@ -2011,7 +2011,7 @@
     </p:spTree>
     <p:extLst>
       <p:ext uri="{BB962C8B-B14F-4D97-AF65-F5344CB8AC3E}">
-        <p14:creationId xmlns:p14="http://schemas.microsoft.com/office/powerpoint/2010/main" val="1539635730"/>
+        <p14:creationId xmlns:p14="http://schemas.microsoft.com/office/powerpoint/2010/main" val="2137554253"/>
       </p:ext>
     </p:extLst>
   </p:cSld>
@@ -2042,7 +2042,7 @@
           <p:cNvPr id="12" name="">
             <a:extLst xmlns:a="http://schemas.openxmlformats.org/drawingml/2006/main">
               <a:ext uri="{FF2B5EF4-FFF2-40B4-BE49-F238E27FC236}">
-                <a16:creationId xmlns:a16="http://schemas.microsoft.com/office/drawing/2014/main" id="{63156731-6641-424A-A604-E1DA222F6690}"/>
+                <a16:creationId xmlns:a16="http://schemas.microsoft.com/office/drawing/2014/main" id="{89FE527B-DFFC-40AF-801F-B8AB7E0EAD6C}"/>
               </a:ext>
             </a:extLst>
           </p:cNvPr>
@@ -2092,7 +2092,7 @@
           <p:cNvPr id="2" name="">
             <a:extLst xmlns:a="http://schemas.openxmlformats.org/drawingml/2006/main">
               <a:ext uri="{FF2B5EF4-FFF2-40B4-BE49-F238E27FC236}">
-                <a16:creationId xmlns:a16="http://schemas.microsoft.com/office/drawing/2014/main" id="{4B75B100-3CDD-46D0-8F6E-84DF21AB1F96}"/>
+                <a16:creationId xmlns:a16="http://schemas.microsoft.com/office/drawing/2014/main" id="{42EF58E2-3649-40D9-8FE9-DD767FB6459C}"/>
               </a:ext>
             </a:extLst>
           </p:cNvPr>
@@ -2142,7 +2142,7 @@
           <p:cNvPr id="3" name="">
             <a:extLst xmlns:a="http://schemas.openxmlformats.org/drawingml/2006/main">
               <a:ext uri="{FF2B5EF4-FFF2-40B4-BE49-F238E27FC236}">
-                <a16:creationId xmlns:a16="http://schemas.microsoft.com/office/drawing/2014/main" id="{6FAA7DC4-47FD-4CB7-AE37-41DFE1276337}"/>
+                <a16:creationId xmlns:a16="http://schemas.microsoft.com/office/drawing/2014/main" id="{BAB9C7A1-449D-45CB-8BE5-973B535B6CFD}"/>
               </a:ext>
             </a:extLst>
           </p:cNvPr>
@@ -2192,7 +2192,7 @@
           <p:cNvPr id="4" name="">
             <a:extLst xmlns:a="http://schemas.openxmlformats.org/drawingml/2006/main">
               <a:ext uri="{FF2B5EF4-FFF2-40B4-BE49-F238E27FC236}">
-                <a16:creationId xmlns:a16="http://schemas.microsoft.com/office/drawing/2014/main" id="{1504C657-A416-43D4-ACC2-E7C7CFC1B967}"/>
+                <a16:creationId xmlns:a16="http://schemas.microsoft.com/office/drawing/2014/main" id="{6925241A-57C2-41FF-83A7-5635CB72226D}"/>
               </a:ext>
             </a:extLst>
           </p:cNvPr>
@@ -2223,7 +2223,7 @@
           <p:cNvPr id="5" name="">
             <a:extLst xmlns:a="http://schemas.openxmlformats.org/drawingml/2006/main">
               <a:ext uri="{FF2B5EF4-FFF2-40B4-BE49-F238E27FC236}">
-                <a16:creationId xmlns:a16="http://schemas.microsoft.com/office/drawing/2014/main" id="{B0938679-5CB5-41DB-AEA3-AAA22C2C7CEB}"/>
+                <a16:creationId xmlns:a16="http://schemas.microsoft.com/office/drawing/2014/main" id="{2740FA2C-9A99-4190-A5BC-B49A3ADDE381}"/>
               </a:ext>
             </a:extLst>
           </p:cNvPr>
@@ -2273,7 +2273,7 @@
           <p:cNvPr id="6" name="">
             <a:extLst xmlns:a="http://schemas.openxmlformats.org/drawingml/2006/main">
               <a:ext uri="{FF2B5EF4-FFF2-40B4-BE49-F238E27FC236}">
-                <a16:creationId xmlns:a16="http://schemas.microsoft.com/office/drawing/2014/main" id="{A30C7260-1AB6-49AE-A52E-02537ED9BFA4}"/>
+                <a16:creationId xmlns:a16="http://schemas.microsoft.com/office/drawing/2014/main" id="{A082D0F0-AC13-4E5E-93D2-4F67F9C31405}"/>
               </a:ext>
             </a:extLst>
           </p:cNvPr>
@@ -2323,7 +2323,7 @@
           <p:cNvPr id="7" name="">
             <a:extLst xmlns:a="http://schemas.openxmlformats.org/drawingml/2006/main">
               <a:ext uri="{FF2B5EF4-FFF2-40B4-BE49-F238E27FC236}">
-                <a16:creationId xmlns:a16="http://schemas.microsoft.com/office/drawing/2014/main" id="{6AE86A9A-E851-4F04-8F25-08D73B0E8263}"/>
+                <a16:creationId xmlns:a16="http://schemas.microsoft.com/office/drawing/2014/main" id="{D8CF7597-C680-426F-B781-5A29008DDC61}"/>
               </a:ext>
             </a:extLst>
           </p:cNvPr>
@@ -2363,7 +2363,7 @@
                   <a:srgbClr val="111827"/>
                 </a:solidFill>
               </a:rPr>
-              <a:t>• 用 NotebookLM 整理教材與來源</a:t>
+              <a:t>• 用 Gemini Notebook 整理教材與來源</a:t>
             </a:r>
           </a:p>
         </p:txBody>
@@ -2373,7 +2373,7 @@
           <p:cNvPr id="8" name="">
             <a:extLst xmlns:a="http://schemas.openxmlformats.org/drawingml/2006/main">
               <a:ext uri="{FF2B5EF4-FFF2-40B4-BE49-F238E27FC236}">
-                <a16:creationId xmlns:a16="http://schemas.microsoft.com/office/drawing/2014/main" id="{1DF5DD5D-D462-4660-83BB-CEF3C456C24C}"/>
+                <a16:creationId xmlns:a16="http://schemas.microsoft.com/office/drawing/2014/main" id="{345CE4B4-24BC-4DCF-8BDD-F3E3682F05F6}"/>
               </a:ext>
             </a:extLst>
           </p:cNvPr>
@@ -2423,7 +2423,7 @@
           <p:cNvPr id="9" name="">
             <a:extLst xmlns:a="http://schemas.openxmlformats.org/drawingml/2006/main">
               <a:ext uri="{FF2B5EF4-FFF2-40B4-BE49-F238E27FC236}">
-                <a16:creationId xmlns:a16="http://schemas.microsoft.com/office/drawing/2014/main" id="{0B2498E5-044A-47C2-956A-8C5B2AA1440C}"/>
+                <a16:creationId xmlns:a16="http://schemas.microsoft.com/office/drawing/2014/main" id="{81CF7748-0674-4C04-900F-6CFBE38A596D}"/>
               </a:ext>
             </a:extLst>
           </p:cNvPr>
@@ -2460,7 +2460,7 @@
           <p:cNvPr id="10" name="">
             <a:extLst xmlns:a="http://schemas.openxmlformats.org/drawingml/2006/main">
               <a:ext uri="{FF2B5EF4-FFF2-40B4-BE49-F238E27FC236}">
-                <a16:creationId xmlns:a16="http://schemas.microsoft.com/office/drawing/2014/main" id="{66B3D816-9459-4AA7-8F5F-0A76C47AFDBC}"/>
+                <a16:creationId xmlns:a16="http://schemas.microsoft.com/office/drawing/2014/main" id="{010BE5BD-245E-4083-977E-79A781AD4735}"/>
               </a:ext>
             </a:extLst>
           </p:cNvPr>
@@ -2510,7 +2510,7 @@
           <p:cNvPr id="11" name="">
             <a:extLst xmlns:a="http://schemas.openxmlformats.org/drawingml/2006/main">
               <a:ext uri="{FF2B5EF4-FFF2-40B4-BE49-F238E27FC236}">
-                <a16:creationId xmlns:a16="http://schemas.microsoft.com/office/drawing/2014/main" id="{C273E72F-81BB-4C27-A21B-030037754CF5}"/>
+                <a16:creationId xmlns:a16="http://schemas.microsoft.com/office/drawing/2014/main" id="{C75651DF-2CD0-4E68-8B70-465E31F86624}"/>
               </a:ext>
             </a:extLst>
           </p:cNvPr>
@@ -2550,7 +2550,7 @@
                   <a:srgbClr val="111827"/>
                 </a:solidFill>
               </a:rPr>
-              <a:t>NotebookLM 遊戲化 RPG 簡報 v1</a:t>
+              <a:t>Gemini Notebook 遊戲化 RPG 簡報 v1</a:t>
             </a:r>
           </a:p>
         </p:txBody>
@@ -2558,7 +2558,7 @@
     </p:spTree>
     <p:extLst>
       <p:ext uri="{BB962C8B-B14F-4D97-AF65-F5344CB8AC3E}">
-        <p14:creationId xmlns:p14="http://schemas.microsoft.com/office/powerpoint/2010/main" val="1156886276"/>
+        <p14:creationId xmlns:p14="http://schemas.microsoft.com/office/powerpoint/2010/main" val="213545437"/>
       </p:ext>
     </p:extLst>
   </p:cSld>
@@ -2589,7 +2589,7 @@
           <p:cNvPr id="15" name="">
             <a:extLst xmlns:a="http://schemas.openxmlformats.org/drawingml/2006/main">
               <a:ext uri="{FF2B5EF4-FFF2-40B4-BE49-F238E27FC236}">
-                <a16:creationId xmlns:a16="http://schemas.microsoft.com/office/drawing/2014/main" id="{52214335-BE73-46EE-8B73-3CC66AED1B0B}"/>
+                <a16:creationId xmlns:a16="http://schemas.microsoft.com/office/drawing/2014/main" id="{6F492CDE-0944-4972-9FE6-692ABDC4D298}"/>
               </a:ext>
             </a:extLst>
           </p:cNvPr>
@@ -2639,7 +2639,7 @@
           <p:cNvPr id="2" name="">
             <a:extLst xmlns:a="http://schemas.openxmlformats.org/drawingml/2006/main">
               <a:ext uri="{FF2B5EF4-FFF2-40B4-BE49-F238E27FC236}">
-                <a16:creationId xmlns:a16="http://schemas.microsoft.com/office/drawing/2014/main" id="{5CC8B43B-8BFD-4701-88AC-B08602A87F6B}"/>
+                <a16:creationId xmlns:a16="http://schemas.microsoft.com/office/drawing/2014/main" id="{EEE7DFFD-8402-4D73-A107-E3554631C08B}"/>
               </a:ext>
             </a:extLst>
           </p:cNvPr>
@@ -2689,7 +2689,7 @@
           <p:cNvPr id="3" name="">
             <a:extLst xmlns:a="http://schemas.openxmlformats.org/drawingml/2006/main">
               <a:ext uri="{FF2B5EF4-FFF2-40B4-BE49-F238E27FC236}">
-                <a16:creationId xmlns:a16="http://schemas.microsoft.com/office/drawing/2014/main" id="{A8719EEC-5EDE-40FC-89A8-AF7FD74ED2B5}"/>
+                <a16:creationId xmlns:a16="http://schemas.microsoft.com/office/drawing/2014/main" id="{8B6032C5-9CE7-4D60-87E7-C366D63DAD6F}"/>
               </a:ext>
             </a:extLst>
           </p:cNvPr>
@@ -2739,7 +2739,7 @@
           <p:cNvPr id="4" name="">
             <a:extLst xmlns:a="http://schemas.openxmlformats.org/drawingml/2006/main">
               <a:ext uri="{FF2B5EF4-FFF2-40B4-BE49-F238E27FC236}">
-                <a16:creationId xmlns:a16="http://schemas.microsoft.com/office/drawing/2014/main" id="{565EBBDD-5E6B-4939-BE81-7CDC7A0D041D}"/>
+                <a16:creationId xmlns:a16="http://schemas.microsoft.com/office/drawing/2014/main" id="{97D208CE-1A68-4CCD-BDA3-EAB6CB831778}"/>
               </a:ext>
             </a:extLst>
           </p:cNvPr>
@@ -2770,7 +2770,7 @@
           <p:cNvPr id="5" name="">
             <a:extLst xmlns:a="http://schemas.openxmlformats.org/drawingml/2006/main">
               <a:ext uri="{FF2B5EF4-FFF2-40B4-BE49-F238E27FC236}">
-                <a16:creationId xmlns:a16="http://schemas.microsoft.com/office/drawing/2014/main" id="{CC1310F5-68DC-4855-85C5-4E94F1CACCAA}"/>
+                <a16:creationId xmlns:a16="http://schemas.microsoft.com/office/drawing/2014/main" id="{435B21DF-86F7-4231-B681-9788EAF36D72}"/>
               </a:ext>
             </a:extLst>
           </p:cNvPr>
@@ -2820,7 +2820,7 @@
           <p:cNvPr id="6" name="">
             <a:extLst xmlns:a="http://schemas.openxmlformats.org/drawingml/2006/main">
               <a:ext uri="{FF2B5EF4-FFF2-40B4-BE49-F238E27FC236}">
-                <a16:creationId xmlns:a16="http://schemas.microsoft.com/office/drawing/2014/main" id="{DDBD9CA5-C8FB-4155-A9D5-46673AA80214}"/>
+                <a16:creationId xmlns:a16="http://schemas.microsoft.com/office/drawing/2014/main" id="{F450FA52-1065-435C-A9B9-39A615A53578}"/>
               </a:ext>
             </a:extLst>
           </p:cNvPr>
@@ -2857,7 +2857,7 @@
           <p:cNvPr id="7" name="">
             <a:extLst xmlns:a="http://schemas.openxmlformats.org/drawingml/2006/main">
               <a:ext uri="{FF2B5EF4-FFF2-40B4-BE49-F238E27FC236}">
-                <a16:creationId xmlns:a16="http://schemas.microsoft.com/office/drawing/2014/main" id="{082E6710-CA6E-4E0F-B6FE-AE4D69BD9D9E}"/>
+                <a16:creationId xmlns:a16="http://schemas.microsoft.com/office/drawing/2014/main" id="{7F48A3FA-CE6B-4983-A3A0-B1D5E9D9C455}"/>
               </a:ext>
             </a:extLst>
           </p:cNvPr>
@@ -2907,7 +2907,7 @@
           <p:cNvPr id="8" name="">
             <a:extLst xmlns:a="http://schemas.openxmlformats.org/drawingml/2006/main">
               <a:ext uri="{FF2B5EF4-FFF2-40B4-BE49-F238E27FC236}">
-                <a16:creationId xmlns:a16="http://schemas.microsoft.com/office/drawing/2014/main" id="{1FB6F0D7-5A40-468D-87B0-34E5B47B8CFB}"/>
+                <a16:creationId xmlns:a16="http://schemas.microsoft.com/office/drawing/2014/main" id="{AF844666-A278-46E0-9BD7-A95FFC400573}"/>
               </a:ext>
             </a:extLst>
           </p:cNvPr>
@@ -2957,7 +2957,7 @@
           <p:cNvPr id="9" name="">
             <a:extLst xmlns:a="http://schemas.openxmlformats.org/drawingml/2006/main">
               <a:ext uri="{FF2B5EF4-FFF2-40B4-BE49-F238E27FC236}">
-                <a16:creationId xmlns:a16="http://schemas.microsoft.com/office/drawing/2014/main" id="{83546BC5-927F-45E4-8194-BC5A77B9523F}"/>
+                <a16:creationId xmlns:a16="http://schemas.microsoft.com/office/drawing/2014/main" id="{8231B05F-425B-48D4-BFCC-AC9325EDCAF5}"/>
               </a:ext>
             </a:extLst>
           </p:cNvPr>
@@ -2992,7 +2992,7 @@
           <p:cNvPr id="10" name="">
             <a:extLst xmlns:a="http://schemas.openxmlformats.org/drawingml/2006/main">
               <a:ext uri="{FF2B5EF4-FFF2-40B4-BE49-F238E27FC236}">
-                <a16:creationId xmlns:a16="http://schemas.microsoft.com/office/drawing/2014/main" id="{FCD38734-70D4-45CD-918D-2785BB0731D7}"/>
+                <a16:creationId xmlns:a16="http://schemas.microsoft.com/office/drawing/2014/main" id="{3B16A4B9-DB9F-4B24-8E71-8C83A0C4AEBF}"/>
               </a:ext>
             </a:extLst>
           </p:cNvPr>
@@ -3042,7 +3042,7 @@
           <p:cNvPr id="11" name="">
             <a:extLst xmlns:a="http://schemas.openxmlformats.org/drawingml/2006/main">
               <a:ext uri="{FF2B5EF4-FFF2-40B4-BE49-F238E27FC236}">
-                <a16:creationId xmlns:a16="http://schemas.microsoft.com/office/drawing/2014/main" id="{17F53FEF-9CF0-4BA5-A06A-DF06B3F8B408}"/>
+                <a16:creationId xmlns:a16="http://schemas.microsoft.com/office/drawing/2014/main" id="{8A0899D8-84EA-42DB-A6BC-F0FFCA702F6F}"/>
               </a:ext>
             </a:extLst>
           </p:cNvPr>
@@ -3092,7 +3092,7 @@
           <p:cNvPr id="12" name="">
             <a:extLst xmlns:a="http://schemas.openxmlformats.org/drawingml/2006/main">
               <a:ext uri="{FF2B5EF4-FFF2-40B4-BE49-F238E27FC236}">
-                <a16:creationId xmlns:a16="http://schemas.microsoft.com/office/drawing/2014/main" id="{A6F6D2F9-8B0D-4AC2-A3CB-01E4C844C90D}"/>
+                <a16:creationId xmlns:a16="http://schemas.microsoft.com/office/drawing/2014/main" id="{794367E3-07AE-4A51-9D23-7FD065C296DE}"/>
               </a:ext>
             </a:extLst>
           </p:cNvPr>
@@ -3129,7 +3129,7 @@
           <p:cNvPr id="13" name="">
             <a:extLst xmlns:a="http://schemas.openxmlformats.org/drawingml/2006/main">
               <a:ext uri="{FF2B5EF4-FFF2-40B4-BE49-F238E27FC236}">
-                <a16:creationId xmlns:a16="http://schemas.microsoft.com/office/drawing/2014/main" id="{34A87F86-D7C2-42F4-9809-39977C7C4E95}"/>
+                <a16:creationId xmlns:a16="http://schemas.microsoft.com/office/drawing/2014/main" id="{80BDDDB8-F505-4262-AAB6-B2D7F727B76E}"/>
               </a:ext>
             </a:extLst>
           </p:cNvPr>
@@ -3179,7 +3179,7 @@
           <p:cNvPr id="14" name="">
             <a:extLst xmlns:a="http://schemas.openxmlformats.org/drawingml/2006/main">
               <a:ext uri="{FF2B5EF4-FFF2-40B4-BE49-F238E27FC236}">
-                <a16:creationId xmlns:a16="http://schemas.microsoft.com/office/drawing/2014/main" id="{158079CE-B33F-4988-AFDA-07A72AE2C434}"/>
+                <a16:creationId xmlns:a16="http://schemas.microsoft.com/office/drawing/2014/main" id="{82014E26-A543-421C-B90C-8AA0ECCD0AAA}"/>
               </a:ext>
             </a:extLst>
           </p:cNvPr>
@@ -3227,7 +3227,7 @@
     </p:spTree>
     <p:extLst>
       <p:ext uri="{BB962C8B-B14F-4D97-AF65-F5344CB8AC3E}">
-        <p14:creationId xmlns:p14="http://schemas.microsoft.com/office/powerpoint/2010/main" val="1577674113"/>
+        <p14:creationId xmlns:p14="http://schemas.microsoft.com/office/powerpoint/2010/main" val="2081729822"/>
       </p:ext>
     </p:extLst>
   </p:cSld>
@@ -3258,7 +3258,7 @@
           <p:cNvPr id="21" name="">
             <a:extLst xmlns:a="http://schemas.openxmlformats.org/drawingml/2006/main">
               <a:ext uri="{FF2B5EF4-FFF2-40B4-BE49-F238E27FC236}">
-                <a16:creationId xmlns:a16="http://schemas.microsoft.com/office/drawing/2014/main" id="{CD53EBDD-6951-403D-822E-56FA1FB5D7CC}"/>
+                <a16:creationId xmlns:a16="http://schemas.microsoft.com/office/drawing/2014/main" id="{62EBA6D7-DD56-4438-86C3-3C1BCC097894}"/>
               </a:ext>
             </a:extLst>
           </p:cNvPr>
@@ -3308,7 +3308,7 @@
           <p:cNvPr id="2" name="">
             <a:extLst xmlns:a="http://schemas.openxmlformats.org/drawingml/2006/main">
               <a:ext uri="{FF2B5EF4-FFF2-40B4-BE49-F238E27FC236}">
-                <a16:creationId xmlns:a16="http://schemas.microsoft.com/office/drawing/2014/main" id="{3BE2F5AF-3030-418A-9D15-F4BC3E2EBDA0}"/>
+                <a16:creationId xmlns:a16="http://schemas.microsoft.com/office/drawing/2014/main" id="{CBF38891-C358-4D67-BE13-8BEE641D0F63}"/>
               </a:ext>
             </a:extLst>
           </p:cNvPr>
@@ -3358,7 +3358,7 @@
           <p:cNvPr id="3" name="">
             <a:extLst xmlns:a="http://schemas.openxmlformats.org/drawingml/2006/main">
               <a:ext uri="{FF2B5EF4-FFF2-40B4-BE49-F238E27FC236}">
-                <a16:creationId xmlns:a16="http://schemas.microsoft.com/office/drawing/2014/main" id="{A43EB124-2C9A-4FF4-BD05-7BD850E8B59C}"/>
+                <a16:creationId xmlns:a16="http://schemas.microsoft.com/office/drawing/2014/main" id="{E0CD4031-612C-43AE-ACB3-9EB6CC4EDE7D}"/>
               </a:ext>
             </a:extLst>
           </p:cNvPr>
@@ -3408,7 +3408,7 @@
           <p:cNvPr id="4" name="">
             <a:extLst xmlns:a="http://schemas.openxmlformats.org/drawingml/2006/main">
               <a:ext uri="{FF2B5EF4-FFF2-40B4-BE49-F238E27FC236}">
-                <a16:creationId xmlns:a16="http://schemas.microsoft.com/office/drawing/2014/main" id="{7D3782AC-1211-45BB-BFC6-1130AB82346F}"/>
+                <a16:creationId xmlns:a16="http://schemas.microsoft.com/office/drawing/2014/main" id="{41B61934-5EF3-40E3-8E55-9F2CD0601243}"/>
               </a:ext>
             </a:extLst>
           </p:cNvPr>
@@ -3439,7 +3439,7 @@
           <p:cNvPr id="5" name="">
             <a:extLst xmlns:a="http://schemas.openxmlformats.org/drawingml/2006/main">
               <a:ext uri="{FF2B5EF4-FFF2-40B4-BE49-F238E27FC236}">
-                <a16:creationId xmlns:a16="http://schemas.microsoft.com/office/drawing/2014/main" id="{A198099F-64CC-47A9-B689-57BFB8CEAF83}"/>
+                <a16:creationId xmlns:a16="http://schemas.microsoft.com/office/drawing/2014/main" id="{CD53E199-5C3C-4890-B0C9-81367B6849D4}"/>
               </a:ext>
             </a:extLst>
           </p:cNvPr>
@@ -3489,7 +3489,7 @@
           <p:cNvPr id="6" name="">
             <a:extLst xmlns:a="http://schemas.openxmlformats.org/drawingml/2006/main">
               <a:ext uri="{FF2B5EF4-FFF2-40B4-BE49-F238E27FC236}">
-                <a16:creationId xmlns:a16="http://schemas.microsoft.com/office/drawing/2014/main" id="{7339D72C-8A77-4315-92FC-A7BD546A9B79}"/>
+                <a16:creationId xmlns:a16="http://schemas.microsoft.com/office/drawing/2014/main" id="{EC5DC1F9-862D-4E88-9534-128A157A00C3}"/>
               </a:ext>
             </a:extLst>
           </p:cNvPr>
@@ -3526,7 +3526,7 @@
           <p:cNvPr id="7" name="">
             <a:extLst xmlns:a="http://schemas.openxmlformats.org/drawingml/2006/main">
               <a:ext uri="{FF2B5EF4-FFF2-40B4-BE49-F238E27FC236}">
-                <a16:creationId xmlns:a16="http://schemas.microsoft.com/office/drawing/2014/main" id="{4EA2D387-64E9-43AC-AEA0-8903D774ECDC}"/>
+                <a16:creationId xmlns:a16="http://schemas.microsoft.com/office/drawing/2014/main" id="{4FBC67CC-0BCA-4F4C-8AE9-B7E4C11789BC}"/>
               </a:ext>
             </a:extLst>
           </p:cNvPr>
@@ -3576,7 +3576,7 @@
           <p:cNvPr id="8" name="">
             <a:extLst xmlns:a="http://schemas.openxmlformats.org/drawingml/2006/main">
               <a:ext uri="{FF2B5EF4-FFF2-40B4-BE49-F238E27FC236}">
-                <a16:creationId xmlns:a16="http://schemas.microsoft.com/office/drawing/2014/main" id="{E4095869-6D90-4853-9F9A-3EC42918F574}"/>
+                <a16:creationId xmlns:a16="http://schemas.microsoft.com/office/drawing/2014/main" id="{202FDACA-8B91-4445-AF0E-2C48425FDC18}"/>
               </a:ext>
             </a:extLst>
           </p:cNvPr>
@@ -3626,7 +3626,7 @@
           <p:cNvPr id="9" name="">
             <a:extLst xmlns:a="http://schemas.openxmlformats.org/drawingml/2006/main">
               <a:ext uri="{FF2B5EF4-FFF2-40B4-BE49-F238E27FC236}">
-                <a16:creationId xmlns:a16="http://schemas.microsoft.com/office/drawing/2014/main" id="{3D7FD384-30E3-4897-B08F-060FC2764CC0}"/>
+                <a16:creationId xmlns:a16="http://schemas.microsoft.com/office/drawing/2014/main" id="{9FDBC391-F562-465A-824D-616FF6400473}"/>
               </a:ext>
             </a:extLst>
           </p:cNvPr>
@@ -3663,7 +3663,7 @@
           <p:cNvPr id="10" name="">
             <a:extLst xmlns:a="http://schemas.openxmlformats.org/drawingml/2006/main">
               <a:ext uri="{FF2B5EF4-FFF2-40B4-BE49-F238E27FC236}">
-                <a16:creationId xmlns:a16="http://schemas.microsoft.com/office/drawing/2014/main" id="{FD18EF99-F9F9-443F-B227-465DDEAF997D}"/>
+                <a16:creationId xmlns:a16="http://schemas.microsoft.com/office/drawing/2014/main" id="{DE0B64D0-82D2-4710-A73B-AE792BA3F368}"/>
               </a:ext>
             </a:extLst>
           </p:cNvPr>
@@ -3713,7 +3713,7 @@
           <p:cNvPr id="11" name="">
             <a:extLst xmlns:a="http://schemas.openxmlformats.org/drawingml/2006/main">
               <a:ext uri="{FF2B5EF4-FFF2-40B4-BE49-F238E27FC236}">
-                <a16:creationId xmlns:a16="http://schemas.microsoft.com/office/drawing/2014/main" id="{1E355939-B75F-4650-9174-CB1CC07AD3FD}"/>
+                <a16:creationId xmlns:a16="http://schemas.microsoft.com/office/drawing/2014/main" id="{78EFE522-0AE3-41C6-893B-C9BAA4019DA6}"/>
               </a:ext>
             </a:extLst>
           </p:cNvPr>
@@ -3753,7 +3753,7 @@
                   <a:srgbClr val="111827"/>
                 </a:solidFill>
               </a:rPr>
-              <a:t>請 NotebookLM 整理資料</a:t>
+              <a:t>請 Gemini Notebook 整理資料</a:t>
             </a:r>
           </a:p>
         </p:txBody>
@@ -3763,7 +3763,7 @@
           <p:cNvPr id="12" name="">
             <a:extLst xmlns:a="http://schemas.openxmlformats.org/drawingml/2006/main">
               <a:ext uri="{FF2B5EF4-FFF2-40B4-BE49-F238E27FC236}">
-                <a16:creationId xmlns:a16="http://schemas.microsoft.com/office/drawing/2014/main" id="{6AE17E99-D31B-41E8-B6D0-0ED4875D9316}"/>
+                <a16:creationId xmlns:a16="http://schemas.microsoft.com/office/drawing/2014/main" id="{D0B73998-F61F-45B6-B872-8A41E4AF0865}"/>
               </a:ext>
             </a:extLst>
           </p:cNvPr>
@@ -3800,7 +3800,7 @@
           <p:cNvPr id="13" name="">
             <a:extLst xmlns:a="http://schemas.openxmlformats.org/drawingml/2006/main">
               <a:ext uri="{FF2B5EF4-FFF2-40B4-BE49-F238E27FC236}">
-                <a16:creationId xmlns:a16="http://schemas.microsoft.com/office/drawing/2014/main" id="{0BFEC9AB-C91E-4382-92A3-33C75A3CF9A4}"/>
+                <a16:creationId xmlns:a16="http://schemas.microsoft.com/office/drawing/2014/main" id="{CA554E22-67B3-4500-8EF9-2EDF882B0003}"/>
               </a:ext>
             </a:extLst>
           </p:cNvPr>
@@ -3850,7 +3850,7 @@
           <p:cNvPr id="14" name="">
             <a:extLst xmlns:a="http://schemas.openxmlformats.org/drawingml/2006/main">
               <a:ext uri="{FF2B5EF4-FFF2-40B4-BE49-F238E27FC236}">
-                <a16:creationId xmlns:a16="http://schemas.microsoft.com/office/drawing/2014/main" id="{62EA9E04-77C4-44AC-AB87-5AA412852AE3}"/>
+                <a16:creationId xmlns:a16="http://schemas.microsoft.com/office/drawing/2014/main" id="{3DA57204-BD4D-4300-9194-3A728904C661}"/>
               </a:ext>
             </a:extLst>
           </p:cNvPr>
@@ -3900,7 +3900,7 @@
           <p:cNvPr id="15" name="">
             <a:extLst xmlns:a="http://schemas.openxmlformats.org/drawingml/2006/main">
               <a:ext uri="{FF2B5EF4-FFF2-40B4-BE49-F238E27FC236}">
-                <a16:creationId xmlns:a16="http://schemas.microsoft.com/office/drawing/2014/main" id="{F36D6E26-5F6E-4485-9331-4EFB49650A67}"/>
+                <a16:creationId xmlns:a16="http://schemas.microsoft.com/office/drawing/2014/main" id="{27C80065-4FA6-4BB5-BC58-E09F0C42437A}"/>
               </a:ext>
             </a:extLst>
           </p:cNvPr>
@@ -3937,7 +3937,7 @@
           <p:cNvPr id="16" name="">
             <a:extLst xmlns:a="http://schemas.openxmlformats.org/drawingml/2006/main">
               <a:ext uri="{FF2B5EF4-FFF2-40B4-BE49-F238E27FC236}">
-                <a16:creationId xmlns:a16="http://schemas.microsoft.com/office/drawing/2014/main" id="{E147F345-246A-4A03-B770-57D823CEBEFC}"/>
+                <a16:creationId xmlns:a16="http://schemas.microsoft.com/office/drawing/2014/main" id="{3954F5C8-FE01-4314-B6BA-D7AD19C87E7B}"/>
               </a:ext>
             </a:extLst>
           </p:cNvPr>
@@ -3987,7 +3987,7 @@
           <p:cNvPr id="17" name="">
             <a:extLst xmlns:a="http://schemas.openxmlformats.org/drawingml/2006/main">
               <a:ext uri="{FF2B5EF4-FFF2-40B4-BE49-F238E27FC236}">
-                <a16:creationId xmlns:a16="http://schemas.microsoft.com/office/drawing/2014/main" id="{1C6D5C20-BC05-4658-9350-BCD16CD02BD0}"/>
+                <a16:creationId xmlns:a16="http://schemas.microsoft.com/office/drawing/2014/main" id="{31349DA6-6477-4389-B78C-FD4A8CD91352}"/>
               </a:ext>
             </a:extLst>
           </p:cNvPr>
@@ -4037,7 +4037,7 @@
           <p:cNvPr id="18" name="">
             <a:extLst xmlns:a="http://schemas.openxmlformats.org/drawingml/2006/main">
               <a:ext uri="{FF2B5EF4-FFF2-40B4-BE49-F238E27FC236}">
-                <a16:creationId xmlns:a16="http://schemas.microsoft.com/office/drawing/2014/main" id="{BE710841-B09D-4E60-A833-83E8DC88C6A1}"/>
+                <a16:creationId xmlns:a16="http://schemas.microsoft.com/office/drawing/2014/main" id="{F74EFF85-7E21-4D03-807A-9578CB50E194}"/>
               </a:ext>
             </a:extLst>
           </p:cNvPr>
@@ -4074,7 +4074,7 @@
           <p:cNvPr id="19" name="">
             <a:extLst xmlns:a="http://schemas.openxmlformats.org/drawingml/2006/main">
               <a:ext uri="{FF2B5EF4-FFF2-40B4-BE49-F238E27FC236}">
-                <a16:creationId xmlns:a16="http://schemas.microsoft.com/office/drawing/2014/main" id="{31C134DB-D147-44E8-9AEC-FB5C6885DF50}"/>
+                <a16:creationId xmlns:a16="http://schemas.microsoft.com/office/drawing/2014/main" id="{5B780CF7-AA85-4650-B570-D3152A4CCE40}"/>
               </a:ext>
             </a:extLst>
           </p:cNvPr>
@@ -4124,7 +4124,7 @@
           <p:cNvPr id="20" name="">
             <a:extLst xmlns:a="http://schemas.openxmlformats.org/drawingml/2006/main">
               <a:ext uri="{FF2B5EF4-FFF2-40B4-BE49-F238E27FC236}">
-                <a16:creationId xmlns:a16="http://schemas.microsoft.com/office/drawing/2014/main" id="{99F53C2E-7DF4-469E-9A66-C13C4E718FAB}"/>
+                <a16:creationId xmlns:a16="http://schemas.microsoft.com/office/drawing/2014/main" id="{40EB888A-9CEB-4805-A9FE-AEA1696A4F2E}"/>
               </a:ext>
             </a:extLst>
           </p:cNvPr>
@@ -4172,7 +4172,7 @@
     </p:spTree>
     <p:extLst>
       <p:ext uri="{BB962C8B-B14F-4D97-AF65-F5344CB8AC3E}">
-        <p14:creationId xmlns:p14="http://schemas.microsoft.com/office/powerpoint/2010/main" val="699600742"/>
+        <p14:creationId xmlns:p14="http://schemas.microsoft.com/office/powerpoint/2010/main" val="1326497406"/>
       </p:ext>
     </p:extLst>
   </p:cSld>
@@ -4203,7 +4203,7 @@
           <p:cNvPr id="8" name="">
             <a:extLst xmlns:a="http://schemas.openxmlformats.org/drawingml/2006/main">
               <a:ext uri="{FF2B5EF4-FFF2-40B4-BE49-F238E27FC236}">
-                <a16:creationId xmlns:a16="http://schemas.microsoft.com/office/drawing/2014/main" id="{8E59D5DC-7AF3-48AA-BF6D-165B4C065080}"/>
+                <a16:creationId xmlns:a16="http://schemas.microsoft.com/office/drawing/2014/main" id="{F1D41511-FDEB-4C6A-8F96-A175B3F45BB1}"/>
               </a:ext>
             </a:extLst>
           </p:cNvPr>
@@ -4253,7 +4253,7 @@
           <p:cNvPr id="2" name="">
             <a:extLst xmlns:a="http://schemas.openxmlformats.org/drawingml/2006/main">
               <a:ext uri="{FF2B5EF4-FFF2-40B4-BE49-F238E27FC236}">
-                <a16:creationId xmlns:a16="http://schemas.microsoft.com/office/drawing/2014/main" id="{1C85E31D-E4CD-41E1-B005-D07BCCB10EFB}"/>
+                <a16:creationId xmlns:a16="http://schemas.microsoft.com/office/drawing/2014/main" id="{F1D03EFB-B7D6-48FB-B935-BBF51CD731E8}"/>
               </a:ext>
             </a:extLst>
           </p:cNvPr>
@@ -4303,7 +4303,7 @@
           <p:cNvPr id="3" name="">
             <a:extLst xmlns:a="http://schemas.openxmlformats.org/drawingml/2006/main">
               <a:ext uri="{FF2B5EF4-FFF2-40B4-BE49-F238E27FC236}">
-                <a16:creationId xmlns:a16="http://schemas.microsoft.com/office/drawing/2014/main" id="{43996969-65EE-48EB-89DA-3F873D8FB787}"/>
+                <a16:creationId xmlns:a16="http://schemas.microsoft.com/office/drawing/2014/main" id="{BC9393E8-1FFA-4500-AB37-961800707283}"/>
               </a:ext>
             </a:extLst>
           </p:cNvPr>
@@ -4353,7 +4353,7 @@
           <p:cNvPr id="4" name="">
             <a:extLst xmlns:a="http://schemas.openxmlformats.org/drawingml/2006/main">
               <a:ext uri="{FF2B5EF4-FFF2-40B4-BE49-F238E27FC236}">
-                <a16:creationId xmlns:a16="http://schemas.microsoft.com/office/drawing/2014/main" id="{36500992-027C-4A42-AF2E-155EF21D15FC}"/>
+                <a16:creationId xmlns:a16="http://schemas.microsoft.com/office/drawing/2014/main" id="{2E93F901-DD7F-489B-8926-0F699BCFDC6E}"/>
               </a:ext>
             </a:extLst>
           </p:cNvPr>
@@ -4384,7 +4384,7 @@
           <p:cNvPr id="5" name="">
             <a:extLst xmlns:a="http://schemas.openxmlformats.org/drawingml/2006/main">
               <a:ext uri="{FF2B5EF4-FFF2-40B4-BE49-F238E27FC236}">
-                <a16:creationId xmlns:a16="http://schemas.microsoft.com/office/drawing/2014/main" id="{CB3E10AA-3CB1-48F1-BA0C-0A97F06E6C50}"/>
+                <a16:creationId xmlns:a16="http://schemas.microsoft.com/office/drawing/2014/main" id="{798EB82E-36F2-4EB4-9E01-3B47F65A086D}"/>
               </a:ext>
             </a:extLst>
           </p:cNvPr>
@@ -4419,7 +4419,7 @@
           <p:cNvPr id="6" name="">
             <a:extLst xmlns:a="http://schemas.openxmlformats.org/drawingml/2006/main">
               <a:ext uri="{FF2B5EF4-FFF2-40B4-BE49-F238E27FC236}">
-                <a16:creationId xmlns:a16="http://schemas.microsoft.com/office/drawing/2014/main" id="{725F0749-EB9F-424F-93C9-A24B243DC359}"/>
+                <a16:creationId xmlns:a16="http://schemas.microsoft.com/office/drawing/2014/main" id="{655A9E9E-01B1-4FCD-82B4-03DA01AA5DB0}"/>
               </a:ext>
             </a:extLst>
           </p:cNvPr>
@@ -4469,7 +4469,7 @@
           <p:cNvPr id="7" name="">
             <a:extLst xmlns:a="http://schemas.openxmlformats.org/drawingml/2006/main">
               <a:ext uri="{FF2B5EF4-FFF2-40B4-BE49-F238E27FC236}">
-                <a16:creationId xmlns:a16="http://schemas.microsoft.com/office/drawing/2014/main" id="{19CD2F7F-D012-4403-9705-17ED9542DA4A}"/>
+                <a16:creationId xmlns:a16="http://schemas.microsoft.com/office/drawing/2014/main" id="{8E8AC762-9543-4D9D-9D8B-F6C2F6CBD003}"/>
               </a:ext>
             </a:extLst>
           </p:cNvPr>
@@ -4517,7 +4517,7 @@
     </p:spTree>
     <p:extLst>
       <p:ext uri="{BB962C8B-B14F-4D97-AF65-F5344CB8AC3E}">
-        <p14:creationId xmlns:p14="http://schemas.microsoft.com/office/powerpoint/2010/main" val="668232608"/>
+        <p14:creationId xmlns:p14="http://schemas.microsoft.com/office/powerpoint/2010/main" val="1140204513"/>
       </p:ext>
     </p:extLst>
   </p:cSld>
@@ -4548,7 +4548,7 @@
           <p:cNvPr id="14" name="">
             <a:extLst xmlns:a="http://schemas.openxmlformats.org/drawingml/2006/main">
               <a:ext uri="{FF2B5EF4-FFF2-40B4-BE49-F238E27FC236}">
-                <a16:creationId xmlns:a16="http://schemas.microsoft.com/office/drawing/2014/main" id="{6B3B5D1A-7C6B-40AC-BEB6-7A803DE8B850}"/>
+                <a16:creationId xmlns:a16="http://schemas.microsoft.com/office/drawing/2014/main" id="{3C24262B-4D29-44DC-B96B-20831EF1D7C9}"/>
               </a:ext>
             </a:extLst>
           </p:cNvPr>
@@ -4598,7 +4598,7 @@
           <p:cNvPr id="2" name="">
             <a:extLst xmlns:a="http://schemas.openxmlformats.org/drawingml/2006/main">
               <a:ext uri="{FF2B5EF4-FFF2-40B4-BE49-F238E27FC236}">
-                <a16:creationId xmlns:a16="http://schemas.microsoft.com/office/drawing/2014/main" id="{35EBEE89-1E71-4AEC-AFAC-C46AD35C31DD}"/>
+                <a16:creationId xmlns:a16="http://schemas.microsoft.com/office/drawing/2014/main" id="{D8F6C2F6-1961-4D49-9B86-E7A3C2C5525F}"/>
               </a:ext>
             </a:extLst>
           </p:cNvPr>
@@ -4648,7 +4648,7 @@
           <p:cNvPr id="3" name="">
             <a:extLst xmlns:a="http://schemas.openxmlformats.org/drawingml/2006/main">
               <a:ext uri="{FF2B5EF4-FFF2-40B4-BE49-F238E27FC236}">
-                <a16:creationId xmlns:a16="http://schemas.microsoft.com/office/drawing/2014/main" id="{82F443A0-4EB9-4A59-82EC-75083F52D75D}"/>
+                <a16:creationId xmlns:a16="http://schemas.microsoft.com/office/drawing/2014/main" id="{EBDEF039-F7B7-4F2B-95D6-23CC180A75E6}"/>
               </a:ext>
             </a:extLst>
           </p:cNvPr>
@@ -4698,7 +4698,7 @@
           <p:cNvPr id="4" name="">
             <a:extLst xmlns:a="http://schemas.openxmlformats.org/drawingml/2006/main">
               <a:ext uri="{FF2B5EF4-FFF2-40B4-BE49-F238E27FC236}">
-                <a16:creationId xmlns:a16="http://schemas.microsoft.com/office/drawing/2014/main" id="{17F712B7-9D8D-4C8F-BDF6-3A9EFB7A094D}"/>
+                <a16:creationId xmlns:a16="http://schemas.microsoft.com/office/drawing/2014/main" id="{DDD4099F-57D6-43FC-98F7-92709E6CDC04}"/>
               </a:ext>
             </a:extLst>
           </p:cNvPr>
@@ -4729,7 +4729,7 @@
           <p:cNvPr id="5" name="">
             <a:extLst xmlns:a="http://schemas.openxmlformats.org/drawingml/2006/main">
               <a:ext uri="{FF2B5EF4-FFF2-40B4-BE49-F238E27FC236}">
-                <a16:creationId xmlns:a16="http://schemas.microsoft.com/office/drawing/2014/main" id="{D15EC9B6-6D7D-47C2-A97D-490FD04315FC}"/>
+                <a16:creationId xmlns:a16="http://schemas.microsoft.com/office/drawing/2014/main" id="{2205AC5F-CD71-4EFD-A171-84D6949846A4}"/>
               </a:ext>
             </a:extLst>
           </p:cNvPr>
@@ -4779,7 +4779,7 @@
           <p:cNvPr id="6" name="">
             <a:extLst xmlns:a="http://schemas.openxmlformats.org/drawingml/2006/main">
               <a:ext uri="{FF2B5EF4-FFF2-40B4-BE49-F238E27FC236}">
-                <a16:creationId xmlns:a16="http://schemas.microsoft.com/office/drawing/2014/main" id="{F8B92906-62F2-430F-BB44-A150DDC1A3B7}"/>
+                <a16:creationId xmlns:a16="http://schemas.microsoft.com/office/drawing/2014/main" id="{15DEE216-C306-4531-91A2-1435F098DB58}"/>
               </a:ext>
             </a:extLst>
           </p:cNvPr>
@@ -4814,7 +4814,7 @@
           <p:cNvPr id="7" name="">
             <a:extLst xmlns:a="http://schemas.openxmlformats.org/drawingml/2006/main">
               <a:ext uri="{FF2B5EF4-FFF2-40B4-BE49-F238E27FC236}">
-                <a16:creationId xmlns:a16="http://schemas.microsoft.com/office/drawing/2014/main" id="{638C065C-5783-442D-8C41-0BF815055326}"/>
+                <a16:creationId xmlns:a16="http://schemas.microsoft.com/office/drawing/2014/main" id="{C7306628-A211-49E9-95D5-B7714E76BF4C}"/>
               </a:ext>
             </a:extLst>
           </p:cNvPr>
@@ -4864,7 +4864,7 @@
           <p:cNvPr id="8" name="">
             <a:extLst xmlns:a="http://schemas.openxmlformats.org/drawingml/2006/main">
               <a:ext uri="{FF2B5EF4-FFF2-40B4-BE49-F238E27FC236}">
-                <a16:creationId xmlns:a16="http://schemas.microsoft.com/office/drawing/2014/main" id="{F8B3F81E-B80F-415A-9274-237AD66CBFC7}"/>
+                <a16:creationId xmlns:a16="http://schemas.microsoft.com/office/drawing/2014/main" id="{9CF90CD7-4CC2-412A-BAE2-DDEA098DACC5}"/>
               </a:ext>
             </a:extLst>
           </p:cNvPr>
@@ -4901,7 +4901,7 @@
           <p:cNvPr id="9" name="">
             <a:extLst xmlns:a="http://schemas.openxmlformats.org/drawingml/2006/main">
               <a:ext uri="{FF2B5EF4-FFF2-40B4-BE49-F238E27FC236}">
-                <a16:creationId xmlns:a16="http://schemas.microsoft.com/office/drawing/2014/main" id="{3D7E6DAE-35A4-4AE1-8841-C1BEC1C8C04F}"/>
+                <a16:creationId xmlns:a16="http://schemas.microsoft.com/office/drawing/2014/main" id="{E9E77401-67C3-4AE6-9D37-9BE4C42F79DB}"/>
               </a:ext>
             </a:extLst>
           </p:cNvPr>
@@ -4951,7 +4951,7 @@
           <p:cNvPr id="10" name="">
             <a:extLst xmlns:a="http://schemas.openxmlformats.org/drawingml/2006/main">
               <a:ext uri="{FF2B5EF4-FFF2-40B4-BE49-F238E27FC236}">
-                <a16:creationId xmlns:a16="http://schemas.microsoft.com/office/drawing/2014/main" id="{3FE68AA8-DE02-42E8-9DB5-F7A8CAD7E996}"/>
+                <a16:creationId xmlns:a16="http://schemas.microsoft.com/office/drawing/2014/main" id="{2584ECFD-58B1-4C95-991B-E47F67C50591}"/>
               </a:ext>
             </a:extLst>
           </p:cNvPr>
@@ -5001,7 +5001,7 @@
           <p:cNvPr id="11" name="">
             <a:extLst xmlns:a="http://schemas.openxmlformats.org/drawingml/2006/main">
               <a:ext uri="{FF2B5EF4-FFF2-40B4-BE49-F238E27FC236}">
-                <a16:creationId xmlns:a16="http://schemas.microsoft.com/office/drawing/2014/main" id="{00816168-26C2-4A35-BBF2-1134B9CD79E4}"/>
+                <a16:creationId xmlns:a16="http://schemas.microsoft.com/office/drawing/2014/main" id="{3004CAEB-6E40-443E-8EC3-F0BB1B22346E}"/>
               </a:ext>
             </a:extLst>
           </p:cNvPr>
@@ -5051,7 +5051,7 @@
           <p:cNvPr id="12" name="">
             <a:extLst xmlns:a="http://schemas.openxmlformats.org/drawingml/2006/main">
               <a:ext uri="{FF2B5EF4-FFF2-40B4-BE49-F238E27FC236}">
-                <a16:creationId xmlns:a16="http://schemas.microsoft.com/office/drawing/2014/main" id="{76FD1F79-92A2-4186-AB78-425B09F48E89}"/>
+                <a16:creationId xmlns:a16="http://schemas.microsoft.com/office/drawing/2014/main" id="{C1161884-0F9D-4D74-98BE-C213AE809528}"/>
               </a:ext>
             </a:extLst>
           </p:cNvPr>
@@ -5101,7 +5101,7 @@
           <p:cNvPr id="13" name="">
             <a:extLst xmlns:a="http://schemas.openxmlformats.org/drawingml/2006/main">
               <a:ext uri="{FF2B5EF4-FFF2-40B4-BE49-F238E27FC236}">
-                <a16:creationId xmlns:a16="http://schemas.microsoft.com/office/drawing/2014/main" id="{836D8152-5794-4431-89BF-D41D238ABA7A}"/>
+                <a16:creationId xmlns:a16="http://schemas.microsoft.com/office/drawing/2014/main" id="{66E59F1A-50D5-49A3-A207-A68AD486E97A}"/>
               </a:ext>
             </a:extLst>
           </p:cNvPr>
@@ -5149,7 +5149,7 @@
     </p:spTree>
     <p:extLst>
       <p:ext uri="{BB962C8B-B14F-4D97-AF65-F5344CB8AC3E}">
-        <p14:creationId xmlns:p14="http://schemas.microsoft.com/office/powerpoint/2010/main" val="1193485201"/>
+        <p14:creationId xmlns:p14="http://schemas.microsoft.com/office/powerpoint/2010/main" val="464114478"/>
       </p:ext>
     </p:extLst>
   </p:cSld>
@@ -5180,7 +5180,7 @@
           <p:cNvPr id="16" name="">
             <a:extLst xmlns:a="http://schemas.openxmlformats.org/drawingml/2006/main">
               <a:ext uri="{FF2B5EF4-FFF2-40B4-BE49-F238E27FC236}">
-                <a16:creationId xmlns:a16="http://schemas.microsoft.com/office/drawing/2014/main" id="{5B640E3A-3226-49B6-8570-0074EC5570CE}"/>
+                <a16:creationId xmlns:a16="http://schemas.microsoft.com/office/drawing/2014/main" id="{2198F458-73E8-427C-888B-9DDA2678DB7A}"/>
               </a:ext>
             </a:extLst>
           </p:cNvPr>
@@ -5230,7 +5230,7 @@
           <p:cNvPr id="2" name="">
             <a:extLst xmlns:a="http://schemas.openxmlformats.org/drawingml/2006/main">
               <a:ext uri="{FF2B5EF4-FFF2-40B4-BE49-F238E27FC236}">
-                <a16:creationId xmlns:a16="http://schemas.microsoft.com/office/drawing/2014/main" id="{6EF4AF07-AA2B-486B-A1E6-7E05507BF879}"/>
+                <a16:creationId xmlns:a16="http://schemas.microsoft.com/office/drawing/2014/main" id="{046073BD-1E67-4088-9040-EDC72FF8D2EA}"/>
               </a:ext>
             </a:extLst>
           </p:cNvPr>
@@ -5280,7 +5280,7 @@
           <p:cNvPr id="3" name="">
             <a:extLst xmlns:a="http://schemas.openxmlformats.org/drawingml/2006/main">
               <a:ext uri="{FF2B5EF4-FFF2-40B4-BE49-F238E27FC236}">
-                <a16:creationId xmlns:a16="http://schemas.microsoft.com/office/drawing/2014/main" id="{91422204-0BA2-49E2-A933-5576CDC27610}"/>
+                <a16:creationId xmlns:a16="http://schemas.microsoft.com/office/drawing/2014/main" id="{343763F3-B38C-4DE8-BD2A-96030E8BF08F}"/>
               </a:ext>
             </a:extLst>
           </p:cNvPr>
@@ -5330,7 +5330,7 @@
           <p:cNvPr id="4" name="">
             <a:extLst xmlns:a="http://schemas.openxmlformats.org/drawingml/2006/main">
               <a:ext uri="{FF2B5EF4-FFF2-40B4-BE49-F238E27FC236}">
-                <a16:creationId xmlns:a16="http://schemas.microsoft.com/office/drawing/2014/main" id="{1634AFAE-EDA4-4C20-B82C-774D44E06FE9}"/>
+                <a16:creationId xmlns:a16="http://schemas.microsoft.com/office/drawing/2014/main" id="{61C76B04-F61B-4E02-B242-ED4C060C05DE}"/>
               </a:ext>
             </a:extLst>
           </p:cNvPr>
@@ -5361,7 +5361,7 @@
           <p:cNvPr id="5" name="">
             <a:extLst xmlns:a="http://schemas.openxmlformats.org/drawingml/2006/main">
               <a:ext uri="{FF2B5EF4-FFF2-40B4-BE49-F238E27FC236}">
-                <a16:creationId xmlns:a16="http://schemas.microsoft.com/office/drawing/2014/main" id="{9D1F2DB5-A85C-4E2C-B442-87AB32850931}"/>
+                <a16:creationId xmlns:a16="http://schemas.microsoft.com/office/drawing/2014/main" id="{25CC6F5B-009E-4984-AB8C-4E13BF918CCA}"/>
               </a:ext>
             </a:extLst>
           </p:cNvPr>
@@ -5411,7 +5411,7 @@
           <p:cNvPr id="6" name="">
             <a:extLst xmlns:a="http://schemas.openxmlformats.org/drawingml/2006/main">
               <a:ext uri="{FF2B5EF4-FFF2-40B4-BE49-F238E27FC236}">
-                <a16:creationId xmlns:a16="http://schemas.microsoft.com/office/drawing/2014/main" id="{94183798-93C0-4268-A166-FFF5690BF501}"/>
+                <a16:creationId xmlns:a16="http://schemas.microsoft.com/office/drawing/2014/main" id="{1D1BC681-5AF9-43A7-95B3-E77477744DCB}"/>
               </a:ext>
             </a:extLst>
           </p:cNvPr>
@@ -5461,7 +5461,7 @@
           <p:cNvPr id="7" name="">
             <a:extLst xmlns:a="http://schemas.openxmlformats.org/drawingml/2006/main">
               <a:ext uri="{FF2B5EF4-FFF2-40B4-BE49-F238E27FC236}">
-                <a16:creationId xmlns:a16="http://schemas.microsoft.com/office/drawing/2014/main" id="{3CE0DDB4-A6AD-4C79-9C04-2900591DB98D}"/>
+                <a16:creationId xmlns:a16="http://schemas.microsoft.com/office/drawing/2014/main" id="{CB43D991-EE72-4DFE-B915-6F2171D9941D}"/>
               </a:ext>
             </a:extLst>
           </p:cNvPr>
@@ -5492,7 +5492,7 @@
           <p:cNvPr id="8" name="">
             <a:extLst xmlns:a="http://schemas.openxmlformats.org/drawingml/2006/main">
               <a:ext uri="{FF2B5EF4-FFF2-40B4-BE49-F238E27FC236}">
-                <a16:creationId xmlns:a16="http://schemas.microsoft.com/office/drawing/2014/main" id="{04C536FC-BF16-4A6F-B965-29708B506063}"/>
+                <a16:creationId xmlns:a16="http://schemas.microsoft.com/office/drawing/2014/main" id="{CA535B8A-3FC3-49AC-A1E3-93D024BE06AF}"/>
               </a:ext>
             </a:extLst>
           </p:cNvPr>
@@ -5542,7 +5542,7 @@
           <p:cNvPr id="9" name="">
             <a:extLst xmlns:a="http://schemas.openxmlformats.org/drawingml/2006/main">
               <a:ext uri="{FF2B5EF4-FFF2-40B4-BE49-F238E27FC236}">
-                <a16:creationId xmlns:a16="http://schemas.microsoft.com/office/drawing/2014/main" id="{304F8AFE-8E49-4045-B45F-5AB04DEF492D}"/>
+                <a16:creationId xmlns:a16="http://schemas.microsoft.com/office/drawing/2014/main" id="{5043B20D-EA16-43C7-9DE9-19ACE0EFF88A}"/>
               </a:ext>
             </a:extLst>
           </p:cNvPr>
@@ -5573,7 +5573,7 @@
           <p:cNvPr id="10" name="">
             <a:extLst xmlns:a="http://schemas.openxmlformats.org/drawingml/2006/main">
               <a:ext uri="{FF2B5EF4-FFF2-40B4-BE49-F238E27FC236}">
-                <a16:creationId xmlns:a16="http://schemas.microsoft.com/office/drawing/2014/main" id="{BE3E661C-0B18-46EE-B8B0-BB014426E4FA}"/>
+                <a16:creationId xmlns:a16="http://schemas.microsoft.com/office/drawing/2014/main" id="{2371F0CA-55F9-40F5-A3F3-2CED328B0E08}"/>
               </a:ext>
             </a:extLst>
           </p:cNvPr>
@@ -5623,7 +5623,7 @@
           <p:cNvPr id="11" name="">
             <a:extLst xmlns:a="http://schemas.openxmlformats.org/drawingml/2006/main">
               <a:ext uri="{FF2B5EF4-FFF2-40B4-BE49-F238E27FC236}">
-                <a16:creationId xmlns:a16="http://schemas.microsoft.com/office/drawing/2014/main" id="{A9069AA9-09C7-4B66-9B79-C26EA98B387C}"/>
+                <a16:creationId xmlns:a16="http://schemas.microsoft.com/office/drawing/2014/main" id="{1075022F-ED28-4801-8056-AB76A24E245D}"/>
               </a:ext>
             </a:extLst>
           </p:cNvPr>
@@ -5654,7 +5654,7 @@
           <p:cNvPr id="12" name="">
             <a:extLst xmlns:a="http://schemas.openxmlformats.org/drawingml/2006/main">
               <a:ext uri="{FF2B5EF4-FFF2-40B4-BE49-F238E27FC236}">
-                <a16:creationId xmlns:a16="http://schemas.microsoft.com/office/drawing/2014/main" id="{EB931123-6DB8-4DCB-BE31-F6E238CEFC94}"/>
+                <a16:creationId xmlns:a16="http://schemas.microsoft.com/office/drawing/2014/main" id="{847EF550-A1C3-4876-B997-4A84912F1392}"/>
               </a:ext>
             </a:extLst>
           </p:cNvPr>
@@ -5704,7 +5704,7 @@
           <p:cNvPr id="13" name="">
             <a:extLst xmlns:a="http://schemas.openxmlformats.org/drawingml/2006/main">
               <a:ext uri="{FF2B5EF4-FFF2-40B4-BE49-F238E27FC236}">
-                <a16:creationId xmlns:a16="http://schemas.microsoft.com/office/drawing/2014/main" id="{0AA57010-B883-4930-9047-C6B577C36557}"/>
+                <a16:creationId xmlns:a16="http://schemas.microsoft.com/office/drawing/2014/main" id="{ECEEC783-8503-4CFA-AD73-3A052FEBB8EE}"/>
               </a:ext>
             </a:extLst>
           </p:cNvPr>
@@ -5735,7 +5735,7 @@
           <p:cNvPr id="14" name="">
             <a:extLst xmlns:a="http://schemas.openxmlformats.org/drawingml/2006/main">
               <a:ext uri="{FF2B5EF4-FFF2-40B4-BE49-F238E27FC236}">
-                <a16:creationId xmlns:a16="http://schemas.microsoft.com/office/drawing/2014/main" id="{419667B9-0380-416E-9BB2-521A4838CB7D}"/>
+                <a16:creationId xmlns:a16="http://schemas.microsoft.com/office/drawing/2014/main" id="{CC35CE5D-463F-44AA-A5EA-7A8B4280811D}"/>
               </a:ext>
             </a:extLst>
           </p:cNvPr>
@@ -5785,7 +5785,7 @@
           <p:cNvPr id="15" name="">
             <a:extLst xmlns:a="http://schemas.openxmlformats.org/drawingml/2006/main">
               <a:ext uri="{FF2B5EF4-FFF2-40B4-BE49-F238E27FC236}">
-                <a16:creationId xmlns:a16="http://schemas.microsoft.com/office/drawing/2014/main" id="{8A155344-915D-4ABD-9366-F9152969C4E9}"/>
+                <a16:creationId xmlns:a16="http://schemas.microsoft.com/office/drawing/2014/main" id="{E82A22E2-A4E4-4F2E-A629-B5A92CA1653C}"/>
               </a:ext>
             </a:extLst>
           </p:cNvPr>
@@ -5814,7 +5814,7 @@
     </p:spTree>
     <p:extLst>
       <p:ext uri="{BB962C8B-B14F-4D97-AF65-F5344CB8AC3E}">
-        <p14:creationId xmlns:p14="http://schemas.microsoft.com/office/powerpoint/2010/main" val="254865631"/>
+        <p14:creationId xmlns:p14="http://schemas.microsoft.com/office/powerpoint/2010/main" val="937467615"/>
       </p:ext>
     </p:extLst>
   </p:cSld>
@@ -5845,7 +5845,7 @@
           <p:cNvPr id="9" name="">
             <a:extLst xmlns:a="http://schemas.openxmlformats.org/drawingml/2006/main">
               <a:ext uri="{FF2B5EF4-FFF2-40B4-BE49-F238E27FC236}">
-                <a16:creationId xmlns:a16="http://schemas.microsoft.com/office/drawing/2014/main" id="{5C8064A2-4AE4-46F2-BCBA-417D3C87AA5E}"/>
+                <a16:creationId xmlns:a16="http://schemas.microsoft.com/office/drawing/2014/main" id="{AC0BBCD0-CFC4-4873-BC77-B469F2B8BA86}"/>
               </a:ext>
             </a:extLst>
           </p:cNvPr>
@@ -5895,7 +5895,7 @@
           <p:cNvPr id="2" name="">
             <a:extLst xmlns:a="http://schemas.openxmlformats.org/drawingml/2006/main">
               <a:ext uri="{FF2B5EF4-FFF2-40B4-BE49-F238E27FC236}">
-                <a16:creationId xmlns:a16="http://schemas.microsoft.com/office/drawing/2014/main" id="{8492C54D-124B-49B2-9407-84D59205E906}"/>
+                <a16:creationId xmlns:a16="http://schemas.microsoft.com/office/drawing/2014/main" id="{CFA29D1C-A3B2-439A-8574-48CC394AD230}"/>
               </a:ext>
             </a:extLst>
           </p:cNvPr>
@@ -5945,7 +5945,7 @@
           <p:cNvPr id="3" name="">
             <a:extLst xmlns:a="http://schemas.openxmlformats.org/drawingml/2006/main">
               <a:ext uri="{FF2B5EF4-FFF2-40B4-BE49-F238E27FC236}">
-                <a16:creationId xmlns:a16="http://schemas.microsoft.com/office/drawing/2014/main" id="{96E71D6A-C193-4E83-84CC-86D69B17910D}"/>
+                <a16:creationId xmlns:a16="http://schemas.microsoft.com/office/drawing/2014/main" id="{C9327536-F57F-4675-B8D6-45173CB713E7}"/>
               </a:ext>
             </a:extLst>
           </p:cNvPr>
@@ -5995,7 +5995,7 @@
           <p:cNvPr id="4" name="">
             <a:extLst xmlns:a="http://schemas.openxmlformats.org/drawingml/2006/main">
               <a:ext uri="{FF2B5EF4-FFF2-40B4-BE49-F238E27FC236}">
-                <a16:creationId xmlns:a16="http://schemas.microsoft.com/office/drawing/2014/main" id="{711A8BE5-11B2-4E0F-B34F-A5976D512857}"/>
+                <a16:creationId xmlns:a16="http://schemas.microsoft.com/office/drawing/2014/main" id="{064EBDE6-B560-4F8A-AEA6-047995EB9465}"/>
               </a:ext>
             </a:extLst>
           </p:cNvPr>
@@ -6026,7 +6026,7 @@
           <p:cNvPr id="5" name="">
             <a:extLst xmlns:a="http://schemas.openxmlformats.org/drawingml/2006/main">
               <a:ext uri="{FF2B5EF4-FFF2-40B4-BE49-F238E27FC236}">
-                <a16:creationId xmlns:a16="http://schemas.microsoft.com/office/drawing/2014/main" id="{A4F64816-2CC3-402A-9ECC-01069F213107}"/>
+                <a16:creationId xmlns:a16="http://schemas.microsoft.com/office/drawing/2014/main" id="{6BC6362E-8D5F-4746-9B4B-8A1C43CE43E2}"/>
               </a:ext>
             </a:extLst>
           </p:cNvPr>
@@ -6076,7 +6076,7 @@
           <p:cNvPr id="6" name="">
             <a:extLst xmlns:a="http://schemas.openxmlformats.org/drawingml/2006/main">
               <a:ext uri="{FF2B5EF4-FFF2-40B4-BE49-F238E27FC236}">
-                <a16:creationId xmlns:a16="http://schemas.microsoft.com/office/drawing/2014/main" id="{DF5B4A49-20E8-4836-BB65-CC363A4BF356}"/>
+                <a16:creationId xmlns:a16="http://schemas.microsoft.com/office/drawing/2014/main" id="{5B9A789F-8829-48C6-AD71-BA3748DEA618}"/>
               </a:ext>
             </a:extLst>
           </p:cNvPr>
@@ -6126,7 +6126,7 @@
           <p:cNvPr id="7" name="">
             <a:extLst xmlns:a="http://schemas.openxmlformats.org/drawingml/2006/main">
               <a:ext uri="{FF2B5EF4-FFF2-40B4-BE49-F238E27FC236}">
-                <a16:creationId xmlns:a16="http://schemas.microsoft.com/office/drawing/2014/main" id="{E03C8AC9-A70C-4BC5-9585-A7BF3C0DE8EF}"/>
+                <a16:creationId xmlns:a16="http://schemas.microsoft.com/office/drawing/2014/main" id="{9FAE2133-27DC-4D6D-8C82-CD8C7F1CFB22}"/>
               </a:ext>
             </a:extLst>
           </p:cNvPr>
@@ -6161,7 +6161,7 @@
           <p:cNvPr id="8" name="">
             <a:extLst xmlns:a="http://schemas.openxmlformats.org/drawingml/2006/main">
               <a:ext uri="{FF2B5EF4-FFF2-40B4-BE49-F238E27FC236}">
-                <a16:creationId xmlns:a16="http://schemas.microsoft.com/office/drawing/2014/main" id="{B2649F77-6A5A-4A45-801C-B3C92C5AD0A7}"/>
+                <a16:creationId xmlns:a16="http://schemas.microsoft.com/office/drawing/2014/main" id="{83084D8D-87B4-4592-8C5E-D8DED9027A03}"/>
               </a:ext>
             </a:extLst>
           </p:cNvPr>
@@ -6209,7 +6209,7 @@
     </p:spTree>
     <p:extLst>
       <p:ext uri="{BB962C8B-B14F-4D97-AF65-F5344CB8AC3E}">
-        <p14:creationId xmlns:p14="http://schemas.microsoft.com/office/powerpoint/2010/main" val="1961070712"/>
+        <p14:creationId xmlns:p14="http://schemas.microsoft.com/office/powerpoint/2010/main" val="1308931267"/>
       </p:ext>
     </p:extLst>
   </p:cSld>

</xml_diff>

<commit_message>
Expand lesson one game based learning introduction
</commit_message>
<xml_diff>
--- a/class/ppt/lesson-01.pptx
+++ b/class/ppt/lesson-01.pptx
@@ -2,20 +2,20 @@
 <file path=ppt/presentation.xml><?xml version="1.0" encoding="utf-8"?>
 <p:presentation xmlns:p="http://schemas.openxmlformats.org/presentationml/2006/main">
   <p:sldMasterIdLst>
-    <p:sldMasterId xmlns:r="http://schemas.openxmlformats.org/officeDocument/2006/relationships" id="2147483648" r:id="R35be1b7238f344b0"/>
+    <p:sldMasterId xmlns:r="http://schemas.openxmlformats.org/officeDocument/2006/relationships" id="2147483648" r:id="R9a8ae52b499c40e2"/>
   </p:sldMasterIdLst>
   <p:notesMasterIdLst>
-    <p:notesMasterId xmlns:r="http://schemas.openxmlformats.org/officeDocument/2006/relationships" r:id="Rca91b37715164f50"/>
+    <p:notesMasterId xmlns:r="http://schemas.openxmlformats.org/officeDocument/2006/relationships" r:id="R2bffed36800c4cdc"/>
   </p:notesMasterIdLst>
   <p:sldIdLst>
-    <p:sldId xmlns:r="http://schemas.openxmlformats.org/officeDocument/2006/relationships" id="256" r:id="R3f280e3981924491"/>
-    <p:sldId xmlns:r="http://schemas.openxmlformats.org/officeDocument/2006/relationships" id="257" r:id="Rb5a55effa1d748df"/>
-    <p:sldId xmlns:r="http://schemas.openxmlformats.org/officeDocument/2006/relationships" id="258" r:id="R9dbebcf2a92f4d13"/>
-    <p:sldId xmlns:r="http://schemas.openxmlformats.org/officeDocument/2006/relationships" id="259" r:id="R010f8f7c4d3f40d8"/>
-    <p:sldId xmlns:r="http://schemas.openxmlformats.org/officeDocument/2006/relationships" id="260" r:id="Rb2b8ad08206e413d"/>
-    <p:sldId xmlns:r="http://schemas.openxmlformats.org/officeDocument/2006/relationships" id="261" r:id="R295662d1ea3d46ea"/>
-    <p:sldId xmlns:r="http://schemas.openxmlformats.org/officeDocument/2006/relationships" id="262" r:id="Rd1f62dac82624405"/>
-    <p:sldId xmlns:r="http://schemas.openxmlformats.org/officeDocument/2006/relationships" id="263" r:id="Rb12f8bd87c854f19"/>
+    <p:sldId xmlns:r="http://schemas.openxmlformats.org/officeDocument/2006/relationships" id="256" r:id="R93d075a7f68f4198"/>
+    <p:sldId xmlns:r="http://schemas.openxmlformats.org/officeDocument/2006/relationships" id="257" r:id="Redbbfb32f4aa413f"/>
+    <p:sldId xmlns:r="http://schemas.openxmlformats.org/officeDocument/2006/relationships" id="258" r:id="Ra8c78997dedb421a"/>
+    <p:sldId xmlns:r="http://schemas.openxmlformats.org/officeDocument/2006/relationships" id="259" r:id="R8d9c6eea42dc4bf1"/>
+    <p:sldId xmlns:r="http://schemas.openxmlformats.org/officeDocument/2006/relationships" id="260" r:id="Rd9ea312dd90242f6"/>
+    <p:sldId xmlns:r="http://schemas.openxmlformats.org/officeDocument/2006/relationships" id="261" r:id="R7d2a7a1213d947e4"/>
+    <p:sldId xmlns:r="http://schemas.openxmlformats.org/officeDocument/2006/relationships" id="262" r:id="Ra2e601ddf3dd4629"/>
+    <p:sldId xmlns:r="http://schemas.openxmlformats.org/officeDocument/2006/relationships" id="263" r:id="R483e300f1f2f4ee5"/>
   </p:sldIdLst>
   <p:sldSz cx="12192000" cy="6858000"/>
   <p:notesSz cx="6858000" cy="9144000"/>
@@ -1127,7 +1127,7 @@
   </p:cSld>
   <p:clrMap bg1="lt1" tx1="dk1" bg2="lt2" tx2="dk2" accent1="accent1" accent2="accent2" accent3="accent3" accent4="accent4" accent5="accent5" accent6="accent6" hlink="hlink" folHlink="folHlink"/>
   <p:sldLayoutIdLst>
-    <p:sldLayoutId xmlns:r="http://schemas.openxmlformats.org/officeDocument/2006/relationships" id="2147483649" r:id="R692ee9321813448b"/>
+    <p:sldLayoutId xmlns:r="http://schemas.openxmlformats.org/officeDocument/2006/relationships" id="2147483649" r:id="R51990d57ab4745d5"/>
   </p:sldLayoutIdLst>
   <p:txStyles>
     <p:titleStyle>
@@ -1678,7 +1678,7 @@
           <p:cNvPr id="8" name="">
             <a:extLst xmlns:a="http://schemas.openxmlformats.org/drawingml/2006/main">
               <a:ext uri="{FF2B5EF4-FFF2-40B4-BE49-F238E27FC236}">
-                <a16:creationId xmlns:a16="http://schemas.microsoft.com/office/drawing/2014/main" id="{7E2FFBFC-6BAC-43E2-B99E-E718CCD9A310}"/>
+                <a16:creationId xmlns:a16="http://schemas.microsoft.com/office/drawing/2014/main" id="{0CA52429-4107-49D6-9177-7A947905D3F0}"/>
               </a:ext>
             </a:extLst>
           </p:cNvPr>
@@ -1711,7 +1711,7 @@
           <p:cNvPr id="2" name="">
             <a:extLst xmlns:a="http://schemas.openxmlformats.org/drawingml/2006/main">
               <a:ext uri="{FF2B5EF4-FFF2-40B4-BE49-F238E27FC236}">
-                <a16:creationId xmlns:a16="http://schemas.microsoft.com/office/drawing/2014/main" id="{BF73B1A7-3449-4B11-B745-A511438852B6}"/>
+                <a16:creationId xmlns:a16="http://schemas.microsoft.com/office/drawing/2014/main" id="{0629585A-C949-49EC-9BC9-DA7F19997A64}"/>
               </a:ext>
             </a:extLst>
           </p:cNvPr>
@@ -1761,7 +1761,7 @@
           <p:cNvPr id="3" name="">
             <a:extLst xmlns:a="http://schemas.openxmlformats.org/drawingml/2006/main">
               <a:ext uri="{FF2B5EF4-FFF2-40B4-BE49-F238E27FC236}">
-                <a16:creationId xmlns:a16="http://schemas.microsoft.com/office/drawing/2014/main" id="{319E3025-018F-416F-AABE-429C2386C62D}"/>
+                <a16:creationId xmlns:a16="http://schemas.microsoft.com/office/drawing/2014/main" id="{EB5091B8-11BE-4F9E-9529-EE64382BF1B8}"/>
               </a:ext>
             </a:extLst>
           </p:cNvPr>
@@ -1811,7 +1811,7 @@
           <p:cNvPr id="4" name="">
             <a:extLst xmlns:a="http://schemas.openxmlformats.org/drawingml/2006/main">
               <a:ext uri="{FF2B5EF4-FFF2-40B4-BE49-F238E27FC236}">
-                <a16:creationId xmlns:a16="http://schemas.microsoft.com/office/drawing/2014/main" id="{C88FC641-4D0D-4C02-B430-ED4423336BA5}"/>
+                <a16:creationId xmlns:a16="http://schemas.microsoft.com/office/drawing/2014/main" id="{AD93A03E-3C4E-4124-B0C0-93310E99A419}"/>
               </a:ext>
             </a:extLst>
           </p:cNvPr>
@@ -1861,7 +1861,7 @@
           <p:cNvPr id="5" name="">
             <a:extLst xmlns:a="http://schemas.openxmlformats.org/drawingml/2006/main">
               <a:ext uri="{FF2B5EF4-FFF2-40B4-BE49-F238E27FC236}">
-                <a16:creationId xmlns:a16="http://schemas.microsoft.com/office/drawing/2014/main" id="{6828A3D4-487A-446A-832A-D58994DE8CC4}"/>
+                <a16:creationId xmlns:a16="http://schemas.microsoft.com/office/drawing/2014/main" id="{1C484370-7395-404B-9FAE-1EEECB2F99F2}"/>
               </a:ext>
             </a:extLst>
           </p:cNvPr>
@@ -1896,7 +1896,7 @@
           <p:cNvPr id="6" name="">
             <a:extLst xmlns:a="http://schemas.openxmlformats.org/drawingml/2006/main">
               <a:ext uri="{FF2B5EF4-FFF2-40B4-BE49-F238E27FC236}">
-                <a16:creationId xmlns:a16="http://schemas.microsoft.com/office/drawing/2014/main" id="{D72D055B-1064-43B0-A4BA-F5AF5284CEAC}"/>
+                <a16:creationId xmlns:a16="http://schemas.microsoft.com/office/drawing/2014/main" id="{A6764B79-E201-46D2-B8EC-C0F9FE253A1A}"/>
               </a:ext>
             </a:extLst>
           </p:cNvPr>
@@ -1946,7 +1946,7 @@
           <p:cNvPr id="7" name="">
             <a:extLst xmlns:a="http://schemas.openxmlformats.org/drawingml/2006/main">
               <a:ext uri="{FF2B5EF4-FFF2-40B4-BE49-F238E27FC236}">
-                <a16:creationId xmlns:a16="http://schemas.microsoft.com/office/drawing/2014/main" id="{B7FB236B-2A73-4B58-85A6-70C6E7D14EDB}"/>
+                <a16:creationId xmlns:a16="http://schemas.microsoft.com/office/drawing/2014/main" id="{3F5E2360-7988-48E1-94B2-885625AA84DD}"/>
               </a:ext>
             </a:extLst>
           </p:cNvPr>
@@ -2011,7 +2011,7 @@
     </p:spTree>
     <p:extLst>
       <p:ext uri="{BB962C8B-B14F-4D97-AF65-F5344CB8AC3E}">
-        <p14:creationId xmlns:p14="http://schemas.microsoft.com/office/powerpoint/2010/main" val="2137554253"/>
+        <p14:creationId xmlns:p14="http://schemas.microsoft.com/office/powerpoint/2010/main" val="458813383"/>
       </p:ext>
     </p:extLst>
   </p:cSld>
@@ -2042,7 +2042,7 @@
           <p:cNvPr id="12" name="">
             <a:extLst xmlns:a="http://schemas.openxmlformats.org/drawingml/2006/main">
               <a:ext uri="{FF2B5EF4-FFF2-40B4-BE49-F238E27FC236}">
-                <a16:creationId xmlns:a16="http://schemas.microsoft.com/office/drawing/2014/main" id="{89FE527B-DFFC-40AF-801F-B8AB7E0EAD6C}"/>
+                <a16:creationId xmlns:a16="http://schemas.microsoft.com/office/drawing/2014/main" id="{D3A45399-E171-4324-937C-E821411F67A2}"/>
               </a:ext>
             </a:extLst>
           </p:cNvPr>
@@ -2092,7 +2092,7 @@
           <p:cNvPr id="2" name="">
             <a:extLst xmlns:a="http://schemas.openxmlformats.org/drawingml/2006/main">
               <a:ext uri="{FF2B5EF4-FFF2-40B4-BE49-F238E27FC236}">
-                <a16:creationId xmlns:a16="http://schemas.microsoft.com/office/drawing/2014/main" id="{42EF58E2-3649-40D9-8FE9-DD767FB6459C}"/>
+                <a16:creationId xmlns:a16="http://schemas.microsoft.com/office/drawing/2014/main" id="{5D7B9F50-526A-4798-A551-2AB571AEC606}"/>
               </a:ext>
             </a:extLst>
           </p:cNvPr>
@@ -2142,7 +2142,7 @@
           <p:cNvPr id="3" name="">
             <a:extLst xmlns:a="http://schemas.openxmlformats.org/drawingml/2006/main">
               <a:ext uri="{FF2B5EF4-FFF2-40B4-BE49-F238E27FC236}">
-                <a16:creationId xmlns:a16="http://schemas.microsoft.com/office/drawing/2014/main" id="{BAB9C7A1-449D-45CB-8BE5-973B535B6CFD}"/>
+                <a16:creationId xmlns:a16="http://schemas.microsoft.com/office/drawing/2014/main" id="{5A6B1E2B-6CC7-49C8-9A1D-CC71FEE2FBF0}"/>
               </a:ext>
             </a:extLst>
           </p:cNvPr>
@@ -2192,7 +2192,7 @@
           <p:cNvPr id="4" name="">
             <a:extLst xmlns:a="http://schemas.openxmlformats.org/drawingml/2006/main">
               <a:ext uri="{FF2B5EF4-FFF2-40B4-BE49-F238E27FC236}">
-                <a16:creationId xmlns:a16="http://schemas.microsoft.com/office/drawing/2014/main" id="{6925241A-57C2-41FF-83A7-5635CB72226D}"/>
+                <a16:creationId xmlns:a16="http://schemas.microsoft.com/office/drawing/2014/main" id="{3E436826-2A2C-4325-8B0A-212A0ED5ED0A}"/>
               </a:ext>
             </a:extLst>
           </p:cNvPr>
@@ -2223,7 +2223,7 @@
           <p:cNvPr id="5" name="">
             <a:extLst xmlns:a="http://schemas.openxmlformats.org/drawingml/2006/main">
               <a:ext uri="{FF2B5EF4-FFF2-40B4-BE49-F238E27FC236}">
-                <a16:creationId xmlns:a16="http://schemas.microsoft.com/office/drawing/2014/main" id="{2740FA2C-9A99-4190-A5BC-B49A3ADDE381}"/>
+                <a16:creationId xmlns:a16="http://schemas.microsoft.com/office/drawing/2014/main" id="{D3A64789-188B-46E4-982D-C21FA7266F30}"/>
               </a:ext>
             </a:extLst>
           </p:cNvPr>
@@ -2273,7 +2273,7 @@
           <p:cNvPr id="6" name="">
             <a:extLst xmlns:a="http://schemas.openxmlformats.org/drawingml/2006/main">
               <a:ext uri="{FF2B5EF4-FFF2-40B4-BE49-F238E27FC236}">
-                <a16:creationId xmlns:a16="http://schemas.microsoft.com/office/drawing/2014/main" id="{A082D0F0-AC13-4E5E-93D2-4F67F9C31405}"/>
+                <a16:creationId xmlns:a16="http://schemas.microsoft.com/office/drawing/2014/main" id="{74C78636-270F-4F5E-B2DE-5227926BDCB8}"/>
               </a:ext>
             </a:extLst>
           </p:cNvPr>
@@ -2313,7 +2313,7 @@
                   <a:srgbClr val="111827"/>
                 </a:solidFill>
               </a:rPr>
-              <a:t>• 理解遊戲化的 5 個核心規則</a:t>
+              <a:t>• 理解為什麼要做遊戲教學與它的好處</a:t>
             </a:r>
           </a:p>
         </p:txBody>
@@ -2323,7 +2323,7 @@
           <p:cNvPr id="7" name="">
             <a:extLst xmlns:a="http://schemas.openxmlformats.org/drawingml/2006/main">
               <a:ext uri="{FF2B5EF4-FFF2-40B4-BE49-F238E27FC236}">
-                <a16:creationId xmlns:a16="http://schemas.microsoft.com/office/drawing/2014/main" id="{D8CF7597-C680-426F-B781-5A29008DDC61}"/>
+                <a16:creationId xmlns:a16="http://schemas.microsoft.com/office/drawing/2014/main" id="{7DB37B7A-DD68-467E-A71C-CF9075322903}"/>
               </a:ext>
             </a:extLst>
           </p:cNvPr>
@@ -2363,7 +2363,7 @@
                   <a:srgbClr val="111827"/>
                 </a:solidFill>
               </a:rPr>
-              <a:t>• 用 Gemini Notebook 整理教材與來源</a:t>
+              <a:t>• 比較 RPG、卡牌、密室、經營與偵探等遊戲形式</a:t>
             </a:r>
           </a:p>
         </p:txBody>
@@ -2373,7 +2373,7 @@
           <p:cNvPr id="8" name="">
             <a:extLst xmlns:a="http://schemas.openxmlformats.org/drawingml/2006/main">
               <a:ext uri="{FF2B5EF4-FFF2-40B4-BE49-F238E27FC236}">
-                <a16:creationId xmlns:a16="http://schemas.microsoft.com/office/drawing/2014/main" id="{345CE4B4-24BC-4DCF-8BDD-F3E3682F05F6}"/>
+                <a16:creationId xmlns:a16="http://schemas.microsoft.com/office/drawing/2014/main" id="{146E4626-60E5-474F-B732-1325A3033B09}"/>
               </a:ext>
             </a:extLst>
           </p:cNvPr>
@@ -2413,7 +2413,7 @@
                   <a:srgbClr val="111827"/>
                 </a:solidFill>
               </a:rPr>
-              <a:t>• 完成 8–12 張 RPG 簡報初版</a:t>
+              <a:t>• 用 Gemini Notebook 整理教材並完成 8–12 張 RPG 簡報初版</a:t>
             </a:r>
           </a:p>
         </p:txBody>
@@ -2423,7 +2423,7 @@
           <p:cNvPr id="9" name="">
             <a:extLst xmlns:a="http://schemas.openxmlformats.org/drawingml/2006/main">
               <a:ext uri="{FF2B5EF4-FFF2-40B4-BE49-F238E27FC236}">
-                <a16:creationId xmlns:a16="http://schemas.microsoft.com/office/drawing/2014/main" id="{81CF7748-0674-4C04-900F-6CFBE38A596D}"/>
+                <a16:creationId xmlns:a16="http://schemas.microsoft.com/office/drawing/2014/main" id="{0F23AF14-7729-43F0-9C67-957C0D5D27CF}"/>
               </a:ext>
             </a:extLst>
           </p:cNvPr>
@@ -2460,7 +2460,7 @@
           <p:cNvPr id="10" name="">
             <a:extLst xmlns:a="http://schemas.openxmlformats.org/drawingml/2006/main">
               <a:ext uri="{FF2B5EF4-FFF2-40B4-BE49-F238E27FC236}">
-                <a16:creationId xmlns:a16="http://schemas.microsoft.com/office/drawing/2014/main" id="{010BE5BD-245E-4083-977E-79A781AD4735}"/>
+                <a16:creationId xmlns:a16="http://schemas.microsoft.com/office/drawing/2014/main" id="{CCDB1841-0232-4619-B726-396267A2DF45}"/>
               </a:ext>
             </a:extLst>
           </p:cNvPr>
@@ -2510,7 +2510,7 @@
           <p:cNvPr id="11" name="">
             <a:extLst xmlns:a="http://schemas.openxmlformats.org/drawingml/2006/main">
               <a:ext uri="{FF2B5EF4-FFF2-40B4-BE49-F238E27FC236}">
-                <a16:creationId xmlns:a16="http://schemas.microsoft.com/office/drawing/2014/main" id="{C75651DF-2CD0-4E68-8B70-465E31F86624}"/>
+                <a16:creationId xmlns:a16="http://schemas.microsoft.com/office/drawing/2014/main" id="{5BB055DB-BA16-45F8-A423-2D4C01EB707C}"/>
               </a:ext>
             </a:extLst>
           </p:cNvPr>
@@ -2558,7 +2558,7 @@
     </p:spTree>
     <p:extLst>
       <p:ext uri="{BB962C8B-B14F-4D97-AF65-F5344CB8AC3E}">
-        <p14:creationId xmlns:p14="http://schemas.microsoft.com/office/powerpoint/2010/main" val="213545437"/>
+        <p14:creationId xmlns:p14="http://schemas.microsoft.com/office/powerpoint/2010/main" val="208001452"/>
       </p:ext>
     </p:extLst>
   </p:cSld>
@@ -2589,7 +2589,7 @@
           <p:cNvPr id="15" name="">
             <a:extLst xmlns:a="http://schemas.openxmlformats.org/drawingml/2006/main">
               <a:ext uri="{FF2B5EF4-FFF2-40B4-BE49-F238E27FC236}">
-                <a16:creationId xmlns:a16="http://schemas.microsoft.com/office/drawing/2014/main" id="{6F492CDE-0944-4972-9FE6-692ABDC4D298}"/>
+                <a16:creationId xmlns:a16="http://schemas.microsoft.com/office/drawing/2014/main" id="{7CCC0A06-5025-4409-9DD3-03C0ACA876B5}"/>
               </a:ext>
             </a:extLst>
           </p:cNvPr>
@@ -2639,7 +2639,7 @@
           <p:cNvPr id="2" name="">
             <a:extLst xmlns:a="http://schemas.openxmlformats.org/drawingml/2006/main">
               <a:ext uri="{FF2B5EF4-FFF2-40B4-BE49-F238E27FC236}">
-                <a16:creationId xmlns:a16="http://schemas.microsoft.com/office/drawing/2014/main" id="{EEE7DFFD-8402-4D73-A107-E3554631C08B}"/>
+                <a16:creationId xmlns:a16="http://schemas.microsoft.com/office/drawing/2014/main" id="{DAFB49B0-4A5D-40BE-8D9E-0D7D4B95620E}"/>
               </a:ext>
             </a:extLst>
           </p:cNvPr>
@@ -2689,7 +2689,7 @@
           <p:cNvPr id="3" name="">
             <a:extLst xmlns:a="http://schemas.openxmlformats.org/drawingml/2006/main">
               <a:ext uri="{FF2B5EF4-FFF2-40B4-BE49-F238E27FC236}">
-                <a16:creationId xmlns:a16="http://schemas.microsoft.com/office/drawing/2014/main" id="{8B6032C5-9CE7-4D60-87E7-C366D63DAD6F}"/>
+                <a16:creationId xmlns:a16="http://schemas.microsoft.com/office/drawing/2014/main" id="{94FC5770-EA29-40C4-A925-2EB38C3F9AC6}"/>
               </a:ext>
             </a:extLst>
           </p:cNvPr>
@@ -2739,7 +2739,7 @@
           <p:cNvPr id="4" name="">
             <a:extLst xmlns:a="http://schemas.openxmlformats.org/drawingml/2006/main">
               <a:ext uri="{FF2B5EF4-FFF2-40B4-BE49-F238E27FC236}">
-                <a16:creationId xmlns:a16="http://schemas.microsoft.com/office/drawing/2014/main" id="{97D208CE-1A68-4CCD-BDA3-EAB6CB831778}"/>
+                <a16:creationId xmlns:a16="http://schemas.microsoft.com/office/drawing/2014/main" id="{2A96C30D-0F76-43A8-9BDE-58A08AC1254A}"/>
               </a:ext>
             </a:extLst>
           </p:cNvPr>
@@ -2770,7 +2770,7 @@
           <p:cNvPr id="5" name="">
             <a:extLst xmlns:a="http://schemas.openxmlformats.org/drawingml/2006/main">
               <a:ext uri="{FF2B5EF4-FFF2-40B4-BE49-F238E27FC236}">
-                <a16:creationId xmlns:a16="http://schemas.microsoft.com/office/drawing/2014/main" id="{435B21DF-86F7-4231-B681-9788EAF36D72}"/>
+                <a16:creationId xmlns:a16="http://schemas.microsoft.com/office/drawing/2014/main" id="{B363528A-E9AB-470C-B01A-1F953F11F4D8}"/>
               </a:ext>
             </a:extLst>
           </p:cNvPr>
@@ -2820,7 +2820,7 @@
           <p:cNvPr id="6" name="">
             <a:extLst xmlns:a="http://schemas.openxmlformats.org/drawingml/2006/main">
               <a:ext uri="{FF2B5EF4-FFF2-40B4-BE49-F238E27FC236}">
-                <a16:creationId xmlns:a16="http://schemas.microsoft.com/office/drawing/2014/main" id="{F450FA52-1065-435C-A9B9-39A615A53578}"/>
+                <a16:creationId xmlns:a16="http://schemas.microsoft.com/office/drawing/2014/main" id="{FECF48D9-66A8-4232-BA00-EABD319094F4}"/>
               </a:ext>
             </a:extLst>
           </p:cNvPr>
@@ -2857,7 +2857,7 @@
           <p:cNvPr id="7" name="">
             <a:extLst xmlns:a="http://schemas.openxmlformats.org/drawingml/2006/main">
               <a:ext uri="{FF2B5EF4-FFF2-40B4-BE49-F238E27FC236}">
-                <a16:creationId xmlns:a16="http://schemas.microsoft.com/office/drawing/2014/main" id="{7F48A3FA-CE6B-4983-A3A0-B1D5E9D9C455}"/>
+                <a16:creationId xmlns:a16="http://schemas.microsoft.com/office/drawing/2014/main" id="{151C8F2E-CEA6-41B5-AEA6-A04424DF98D4}"/>
               </a:ext>
             </a:extLst>
           </p:cNvPr>
@@ -2907,7 +2907,7 @@
           <p:cNvPr id="8" name="">
             <a:extLst xmlns:a="http://schemas.openxmlformats.org/drawingml/2006/main">
               <a:ext uri="{FF2B5EF4-FFF2-40B4-BE49-F238E27FC236}">
-                <a16:creationId xmlns:a16="http://schemas.microsoft.com/office/drawing/2014/main" id="{AF844666-A278-46E0-9BD7-A95FFC400573}"/>
+                <a16:creationId xmlns:a16="http://schemas.microsoft.com/office/drawing/2014/main" id="{0DFAF4E6-103C-4382-BADD-8C1CF9DFE1AC}"/>
               </a:ext>
             </a:extLst>
           </p:cNvPr>
@@ -2947,7 +2947,7 @@
                   <a:srgbClr val="111827"/>
                 </a:solidFill>
               </a:rPr>
-              <a:t>教材先於故事</a:t>
+              <a:t>遊戲服務學習目標</a:t>
             </a:r>
           </a:p>
         </p:txBody>
@@ -2957,7 +2957,7 @@
           <p:cNvPr id="9" name="">
             <a:extLst xmlns:a="http://schemas.openxmlformats.org/drawingml/2006/main">
               <a:ext uri="{FF2B5EF4-FFF2-40B4-BE49-F238E27FC236}">
-                <a16:creationId xmlns:a16="http://schemas.microsoft.com/office/drawing/2014/main" id="{8231B05F-425B-48D4-BFCC-AC9325EDCAF5}"/>
+                <a16:creationId xmlns:a16="http://schemas.microsoft.com/office/drawing/2014/main" id="{C7F577BF-707E-41B7-9247-0FA26AE6F744}"/>
               </a:ext>
             </a:extLst>
           </p:cNvPr>
@@ -2992,7 +2992,7 @@
           <p:cNvPr id="10" name="">
             <a:extLst xmlns:a="http://schemas.openxmlformats.org/drawingml/2006/main">
               <a:ext uri="{FF2B5EF4-FFF2-40B4-BE49-F238E27FC236}">
-                <a16:creationId xmlns:a16="http://schemas.microsoft.com/office/drawing/2014/main" id="{3B16A4B9-DB9F-4B24-8E71-8C83A0C4AEBF}"/>
+                <a16:creationId xmlns:a16="http://schemas.microsoft.com/office/drawing/2014/main" id="{3B96387D-78A2-4265-BD14-CEA4F2B4570C}"/>
               </a:ext>
             </a:extLst>
           </p:cNvPr>
@@ -3042,7 +3042,7 @@
           <p:cNvPr id="11" name="">
             <a:extLst xmlns:a="http://schemas.openxmlformats.org/drawingml/2006/main">
               <a:ext uri="{FF2B5EF4-FFF2-40B4-BE49-F238E27FC236}">
-                <a16:creationId xmlns:a16="http://schemas.microsoft.com/office/drawing/2014/main" id="{8A0899D8-84EA-42DB-A6BC-F0FFCA702F6F}"/>
+                <a16:creationId xmlns:a16="http://schemas.microsoft.com/office/drawing/2014/main" id="{42824DE9-15C5-4299-BFEE-01AFECA0CA88}"/>
               </a:ext>
             </a:extLst>
           </p:cNvPr>
@@ -3082,7 +3082,7 @@
                   <a:srgbClr val="111827"/>
                 </a:solidFill>
               </a:rPr>
-              <a:t>任務必須使用教材</a:t>
+              <a:t>RPG 用角色、任務與關卡串起成長</a:t>
             </a:r>
           </a:p>
         </p:txBody>
@@ -3092,7 +3092,7 @@
           <p:cNvPr id="12" name="">
             <a:extLst xmlns:a="http://schemas.openxmlformats.org/drawingml/2006/main">
               <a:ext uri="{FF2B5EF4-FFF2-40B4-BE49-F238E27FC236}">
-                <a16:creationId xmlns:a16="http://schemas.microsoft.com/office/drawing/2014/main" id="{794367E3-07AE-4A51-9D23-7FD065C296DE}"/>
+                <a16:creationId xmlns:a16="http://schemas.microsoft.com/office/drawing/2014/main" id="{AD18DE9A-91AE-4369-9E36-280CDE45CA60}"/>
               </a:ext>
             </a:extLst>
           </p:cNvPr>
@@ -3129,7 +3129,7 @@
           <p:cNvPr id="13" name="">
             <a:extLst xmlns:a="http://schemas.openxmlformats.org/drawingml/2006/main">
               <a:ext uri="{FF2B5EF4-FFF2-40B4-BE49-F238E27FC236}">
-                <a16:creationId xmlns:a16="http://schemas.microsoft.com/office/drawing/2014/main" id="{80BDDDB8-F505-4262-AAB6-B2D7F727B76E}"/>
+                <a16:creationId xmlns:a16="http://schemas.microsoft.com/office/drawing/2014/main" id="{01320078-B6D5-467B-8F45-CD4E3BC02F95}"/>
               </a:ext>
             </a:extLst>
           </p:cNvPr>
@@ -3179,7 +3179,7 @@
           <p:cNvPr id="14" name="">
             <a:extLst xmlns:a="http://schemas.openxmlformats.org/drawingml/2006/main">
               <a:ext uri="{FF2B5EF4-FFF2-40B4-BE49-F238E27FC236}">
-                <a16:creationId xmlns:a16="http://schemas.microsoft.com/office/drawing/2014/main" id="{82014E26-A543-421C-B90C-8AA0ECCD0AAA}"/>
+                <a16:creationId xmlns:a16="http://schemas.microsoft.com/office/drawing/2014/main" id="{8313D299-1CC2-44A7-BA02-1240015E1411}"/>
               </a:ext>
             </a:extLst>
           </p:cNvPr>
@@ -3219,7 +3219,7 @@
                   <a:srgbClr val="111827"/>
                 </a:solidFill>
               </a:rPr>
-              <a:t>挑戰、回饋、獎勵與成長</a:t>
+              <a:t>同一教材也能轉成卡牌、密室、經營或偵探遊戲</a:t>
             </a:r>
           </a:p>
         </p:txBody>
@@ -3227,7 +3227,7 @@
     </p:spTree>
     <p:extLst>
       <p:ext uri="{BB962C8B-B14F-4D97-AF65-F5344CB8AC3E}">
-        <p14:creationId xmlns:p14="http://schemas.microsoft.com/office/powerpoint/2010/main" val="2081729822"/>
+        <p14:creationId xmlns:p14="http://schemas.microsoft.com/office/powerpoint/2010/main" val="1157189286"/>
       </p:ext>
     </p:extLst>
   </p:cSld>
@@ -3258,7 +3258,7 @@
           <p:cNvPr id="21" name="">
             <a:extLst xmlns:a="http://schemas.openxmlformats.org/drawingml/2006/main">
               <a:ext uri="{FF2B5EF4-FFF2-40B4-BE49-F238E27FC236}">
-                <a16:creationId xmlns:a16="http://schemas.microsoft.com/office/drawing/2014/main" id="{62EBA6D7-DD56-4438-86C3-3C1BCC097894}"/>
+                <a16:creationId xmlns:a16="http://schemas.microsoft.com/office/drawing/2014/main" id="{C6C2DC65-3C8C-4568-95E2-674BCBB427F6}"/>
               </a:ext>
             </a:extLst>
           </p:cNvPr>
@@ -3308,7 +3308,7 @@
           <p:cNvPr id="2" name="">
             <a:extLst xmlns:a="http://schemas.openxmlformats.org/drawingml/2006/main">
               <a:ext uri="{FF2B5EF4-FFF2-40B4-BE49-F238E27FC236}">
-                <a16:creationId xmlns:a16="http://schemas.microsoft.com/office/drawing/2014/main" id="{CBF38891-C358-4D67-BE13-8BEE641D0F63}"/>
+                <a16:creationId xmlns:a16="http://schemas.microsoft.com/office/drawing/2014/main" id="{38A3EC0B-50C5-4DA7-9C3C-F1E1F79B5464}"/>
               </a:ext>
             </a:extLst>
           </p:cNvPr>
@@ -3358,7 +3358,7 @@
           <p:cNvPr id="3" name="">
             <a:extLst xmlns:a="http://schemas.openxmlformats.org/drawingml/2006/main">
               <a:ext uri="{FF2B5EF4-FFF2-40B4-BE49-F238E27FC236}">
-                <a16:creationId xmlns:a16="http://schemas.microsoft.com/office/drawing/2014/main" id="{E0CD4031-612C-43AE-ACB3-9EB6CC4EDE7D}"/>
+                <a16:creationId xmlns:a16="http://schemas.microsoft.com/office/drawing/2014/main" id="{FA85DE3E-CC40-4CD3-B3BF-FA8DE3C10894}"/>
               </a:ext>
             </a:extLst>
           </p:cNvPr>
@@ -3408,7 +3408,7 @@
           <p:cNvPr id="4" name="">
             <a:extLst xmlns:a="http://schemas.openxmlformats.org/drawingml/2006/main">
               <a:ext uri="{FF2B5EF4-FFF2-40B4-BE49-F238E27FC236}">
-                <a16:creationId xmlns:a16="http://schemas.microsoft.com/office/drawing/2014/main" id="{41B61934-5EF3-40E3-8E55-9F2CD0601243}"/>
+                <a16:creationId xmlns:a16="http://schemas.microsoft.com/office/drawing/2014/main" id="{5FCAC0A7-1B68-48A7-9509-FF74077C61B7}"/>
               </a:ext>
             </a:extLst>
           </p:cNvPr>
@@ -3439,7 +3439,7 @@
           <p:cNvPr id="5" name="">
             <a:extLst xmlns:a="http://schemas.openxmlformats.org/drawingml/2006/main">
               <a:ext uri="{FF2B5EF4-FFF2-40B4-BE49-F238E27FC236}">
-                <a16:creationId xmlns:a16="http://schemas.microsoft.com/office/drawing/2014/main" id="{CD53E199-5C3C-4890-B0C9-81367B6849D4}"/>
+                <a16:creationId xmlns:a16="http://schemas.microsoft.com/office/drawing/2014/main" id="{5FD100F2-9F19-424A-BC00-87521C69F1E1}"/>
               </a:ext>
             </a:extLst>
           </p:cNvPr>
@@ -3489,7 +3489,7 @@
           <p:cNvPr id="6" name="">
             <a:extLst xmlns:a="http://schemas.openxmlformats.org/drawingml/2006/main">
               <a:ext uri="{FF2B5EF4-FFF2-40B4-BE49-F238E27FC236}">
-                <a16:creationId xmlns:a16="http://schemas.microsoft.com/office/drawing/2014/main" id="{EC5DC1F9-862D-4E88-9534-128A157A00C3}"/>
+                <a16:creationId xmlns:a16="http://schemas.microsoft.com/office/drawing/2014/main" id="{95B13D45-3C38-4116-AE8B-096AA0A49138}"/>
               </a:ext>
             </a:extLst>
           </p:cNvPr>
@@ -3526,7 +3526,7 @@
           <p:cNvPr id="7" name="">
             <a:extLst xmlns:a="http://schemas.openxmlformats.org/drawingml/2006/main">
               <a:ext uri="{FF2B5EF4-FFF2-40B4-BE49-F238E27FC236}">
-                <a16:creationId xmlns:a16="http://schemas.microsoft.com/office/drawing/2014/main" id="{4FBC67CC-0BCA-4F4C-8AE9-B7E4C11789BC}"/>
+                <a16:creationId xmlns:a16="http://schemas.microsoft.com/office/drawing/2014/main" id="{A6025796-ABE7-45F0-B436-CFEB0D19720E}"/>
               </a:ext>
             </a:extLst>
           </p:cNvPr>
@@ -3576,7 +3576,7 @@
           <p:cNvPr id="8" name="">
             <a:extLst xmlns:a="http://schemas.openxmlformats.org/drawingml/2006/main">
               <a:ext uri="{FF2B5EF4-FFF2-40B4-BE49-F238E27FC236}">
-                <a16:creationId xmlns:a16="http://schemas.microsoft.com/office/drawing/2014/main" id="{202FDACA-8B91-4445-AF0E-2C48425FDC18}"/>
+                <a16:creationId xmlns:a16="http://schemas.microsoft.com/office/drawing/2014/main" id="{DA60A31C-5FCC-48F6-9054-22EBD5F687CF}"/>
               </a:ext>
             </a:extLst>
           </p:cNvPr>
@@ -3626,7 +3626,7 @@
           <p:cNvPr id="9" name="">
             <a:extLst xmlns:a="http://schemas.openxmlformats.org/drawingml/2006/main">
               <a:ext uri="{FF2B5EF4-FFF2-40B4-BE49-F238E27FC236}">
-                <a16:creationId xmlns:a16="http://schemas.microsoft.com/office/drawing/2014/main" id="{9FDBC391-F562-465A-824D-616FF6400473}"/>
+                <a16:creationId xmlns:a16="http://schemas.microsoft.com/office/drawing/2014/main" id="{7BDD317E-7712-453B-9376-7159D8EE8DE8}"/>
               </a:ext>
             </a:extLst>
           </p:cNvPr>
@@ -3663,7 +3663,7 @@
           <p:cNvPr id="10" name="">
             <a:extLst xmlns:a="http://schemas.openxmlformats.org/drawingml/2006/main">
               <a:ext uri="{FF2B5EF4-FFF2-40B4-BE49-F238E27FC236}">
-                <a16:creationId xmlns:a16="http://schemas.microsoft.com/office/drawing/2014/main" id="{DE0B64D0-82D2-4710-A73B-AE792BA3F368}"/>
+                <a16:creationId xmlns:a16="http://schemas.microsoft.com/office/drawing/2014/main" id="{62F5A64D-AEE3-47EB-8863-A00326BA3A8F}"/>
               </a:ext>
             </a:extLst>
           </p:cNvPr>
@@ -3713,7 +3713,7 @@
           <p:cNvPr id="11" name="">
             <a:extLst xmlns:a="http://schemas.openxmlformats.org/drawingml/2006/main">
               <a:ext uri="{FF2B5EF4-FFF2-40B4-BE49-F238E27FC236}">
-                <a16:creationId xmlns:a16="http://schemas.microsoft.com/office/drawing/2014/main" id="{78EFE522-0AE3-41C6-893B-C9BAA4019DA6}"/>
+                <a16:creationId xmlns:a16="http://schemas.microsoft.com/office/drawing/2014/main" id="{0F585EF4-1967-492B-9421-6D9E4D751BD9}"/>
               </a:ext>
             </a:extLst>
           </p:cNvPr>
@@ -3763,7 +3763,7 @@
           <p:cNvPr id="12" name="">
             <a:extLst xmlns:a="http://schemas.openxmlformats.org/drawingml/2006/main">
               <a:ext uri="{FF2B5EF4-FFF2-40B4-BE49-F238E27FC236}">
-                <a16:creationId xmlns:a16="http://schemas.microsoft.com/office/drawing/2014/main" id="{D0B73998-F61F-45B6-B872-8A41E4AF0865}"/>
+                <a16:creationId xmlns:a16="http://schemas.microsoft.com/office/drawing/2014/main" id="{4F978D32-3E81-4AC7-962F-B19E51BAC358}"/>
               </a:ext>
             </a:extLst>
           </p:cNvPr>
@@ -3800,7 +3800,7 @@
           <p:cNvPr id="13" name="">
             <a:extLst xmlns:a="http://schemas.openxmlformats.org/drawingml/2006/main">
               <a:ext uri="{FF2B5EF4-FFF2-40B4-BE49-F238E27FC236}">
-                <a16:creationId xmlns:a16="http://schemas.microsoft.com/office/drawing/2014/main" id="{CA554E22-67B3-4500-8EF9-2EDF882B0003}"/>
+                <a16:creationId xmlns:a16="http://schemas.microsoft.com/office/drawing/2014/main" id="{88271D63-DCE1-47CB-80E9-D94597C7471B}"/>
               </a:ext>
             </a:extLst>
           </p:cNvPr>
@@ -3850,7 +3850,7 @@
           <p:cNvPr id="14" name="">
             <a:extLst xmlns:a="http://schemas.openxmlformats.org/drawingml/2006/main">
               <a:ext uri="{FF2B5EF4-FFF2-40B4-BE49-F238E27FC236}">
-                <a16:creationId xmlns:a16="http://schemas.microsoft.com/office/drawing/2014/main" id="{3DA57204-BD4D-4300-9194-3A728904C661}"/>
+                <a16:creationId xmlns:a16="http://schemas.microsoft.com/office/drawing/2014/main" id="{9C7B984A-DAB3-4F6B-99BE-DE968FC94978}"/>
               </a:ext>
             </a:extLst>
           </p:cNvPr>
@@ -3900,7 +3900,7 @@
           <p:cNvPr id="15" name="">
             <a:extLst xmlns:a="http://schemas.openxmlformats.org/drawingml/2006/main">
               <a:ext uri="{FF2B5EF4-FFF2-40B4-BE49-F238E27FC236}">
-                <a16:creationId xmlns:a16="http://schemas.microsoft.com/office/drawing/2014/main" id="{27C80065-4FA6-4BB5-BC58-E09F0C42437A}"/>
+                <a16:creationId xmlns:a16="http://schemas.microsoft.com/office/drawing/2014/main" id="{364C26CE-B882-4C50-A23C-67E3E747A8DC}"/>
               </a:ext>
             </a:extLst>
           </p:cNvPr>
@@ -3937,7 +3937,7 @@
           <p:cNvPr id="16" name="">
             <a:extLst xmlns:a="http://schemas.openxmlformats.org/drawingml/2006/main">
               <a:ext uri="{FF2B5EF4-FFF2-40B4-BE49-F238E27FC236}">
-                <a16:creationId xmlns:a16="http://schemas.microsoft.com/office/drawing/2014/main" id="{3954F5C8-FE01-4314-B6BA-D7AD19C87E7B}"/>
+                <a16:creationId xmlns:a16="http://schemas.microsoft.com/office/drawing/2014/main" id="{6B32A4E4-067B-4ADE-A118-BEE72EC5A160}"/>
               </a:ext>
             </a:extLst>
           </p:cNvPr>
@@ -3987,7 +3987,7 @@
           <p:cNvPr id="17" name="">
             <a:extLst xmlns:a="http://schemas.openxmlformats.org/drawingml/2006/main">
               <a:ext uri="{FF2B5EF4-FFF2-40B4-BE49-F238E27FC236}">
-                <a16:creationId xmlns:a16="http://schemas.microsoft.com/office/drawing/2014/main" id="{31349DA6-6477-4389-B78C-FD4A8CD91352}"/>
+                <a16:creationId xmlns:a16="http://schemas.microsoft.com/office/drawing/2014/main" id="{B4C5BCD7-EC87-48CD-8210-1480D999B9D3}"/>
               </a:ext>
             </a:extLst>
           </p:cNvPr>
@@ -4037,7 +4037,7 @@
           <p:cNvPr id="18" name="">
             <a:extLst xmlns:a="http://schemas.openxmlformats.org/drawingml/2006/main">
               <a:ext uri="{FF2B5EF4-FFF2-40B4-BE49-F238E27FC236}">
-                <a16:creationId xmlns:a16="http://schemas.microsoft.com/office/drawing/2014/main" id="{F74EFF85-7E21-4D03-807A-9578CB50E194}"/>
+                <a16:creationId xmlns:a16="http://schemas.microsoft.com/office/drawing/2014/main" id="{99FC352F-733D-46F3-8A77-D33A528B6F4E}"/>
               </a:ext>
             </a:extLst>
           </p:cNvPr>
@@ -4074,7 +4074,7 @@
           <p:cNvPr id="19" name="">
             <a:extLst xmlns:a="http://schemas.openxmlformats.org/drawingml/2006/main">
               <a:ext uri="{FF2B5EF4-FFF2-40B4-BE49-F238E27FC236}">
-                <a16:creationId xmlns:a16="http://schemas.microsoft.com/office/drawing/2014/main" id="{5B780CF7-AA85-4650-B570-D3152A4CCE40}"/>
+                <a16:creationId xmlns:a16="http://schemas.microsoft.com/office/drawing/2014/main" id="{4F91F8A0-6865-474D-9BE3-52301981F9C8}"/>
               </a:ext>
             </a:extLst>
           </p:cNvPr>
@@ -4124,7 +4124,7 @@
           <p:cNvPr id="20" name="">
             <a:extLst xmlns:a="http://schemas.openxmlformats.org/drawingml/2006/main">
               <a:ext uri="{FF2B5EF4-FFF2-40B4-BE49-F238E27FC236}">
-                <a16:creationId xmlns:a16="http://schemas.microsoft.com/office/drawing/2014/main" id="{40EB888A-9CEB-4805-A9FE-AEA1696A4F2E}"/>
+                <a16:creationId xmlns:a16="http://schemas.microsoft.com/office/drawing/2014/main" id="{F09E633D-C7FD-490C-92CE-D8934A2CC469}"/>
               </a:ext>
             </a:extLst>
           </p:cNvPr>
@@ -4172,7 +4172,7 @@
     </p:spTree>
     <p:extLst>
       <p:ext uri="{BB962C8B-B14F-4D97-AF65-F5344CB8AC3E}">
-        <p14:creationId xmlns:p14="http://schemas.microsoft.com/office/powerpoint/2010/main" val="1326497406"/>
+        <p14:creationId xmlns:p14="http://schemas.microsoft.com/office/powerpoint/2010/main" val="1941672565"/>
       </p:ext>
     </p:extLst>
   </p:cSld>
@@ -4203,7 +4203,7 @@
           <p:cNvPr id="8" name="">
             <a:extLst xmlns:a="http://schemas.openxmlformats.org/drawingml/2006/main">
               <a:ext uri="{FF2B5EF4-FFF2-40B4-BE49-F238E27FC236}">
-                <a16:creationId xmlns:a16="http://schemas.microsoft.com/office/drawing/2014/main" id="{F1D41511-FDEB-4C6A-8F96-A175B3F45BB1}"/>
+                <a16:creationId xmlns:a16="http://schemas.microsoft.com/office/drawing/2014/main" id="{3448D259-DB64-4729-B8FD-6DB1F09153BA}"/>
               </a:ext>
             </a:extLst>
           </p:cNvPr>
@@ -4253,7 +4253,7 @@
           <p:cNvPr id="2" name="">
             <a:extLst xmlns:a="http://schemas.openxmlformats.org/drawingml/2006/main">
               <a:ext uri="{FF2B5EF4-FFF2-40B4-BE49-F238E27FC236}">
-                <a16:creationId xmlns:a16="http://schemas.microsoft.com/office/drawing/2014/main" id="{F1D03EFB-B7D6-48FB-B935-BBF51CD731E8}"/>
+                <a16:creationId xmlns:a16="http://schemas.microsoft.com/office/drawing/2014/main" id="{16DFB1E7-64AC-4024-8DE1-47FC370BE4CF}"/>
               </a:ext>
             </a:extLst>
           </p:cNvPr>
@@ -4303,7 +4303,7 @@
           <p:cNvPr id="3" name="">
             <a:extLst xmlns:a="http://schemas.openxmlformats.org/drawingml/2006/main">
               <a:ext uri="{FF2B5EF4-FFF2-40B4-BE49-F238E27FC236}">
-                <a16:creationId xmlns:a16="http://schemas.microsoft.com/office/drawing/2014/main" id="{BC9393E8-1FFA-4500-AB37-961800707283}"/>
+                <a16:creationId xmlns:a16="http://schemas.microsoft.com/office/drawing/2014/main" id="{D0E1B415-4AE2-4335-9EB2-49FAB255DC10}"/>
               </a:ext>
             </a:extLst>
           </p:cNvPr>
@@ -4353,7 +4353,7 @@
           <p:cNvPr id="4" name="">
             <a:extLst xmlns:a="http://schemas.openxmlformats.org/drawingml/2006/main">
               <a:ext uri="{FF2B5EF4-FFF2-40B4-BE49-F238E27FC236}">
-                <a16:creationId xmlns:a16="http://schemas.microsoft.com/office/drawing/2014/main" id="{2E93F901-DD7F-489B-8926-0F699BCFDC6E}"/>
+                <a16:creationId xmlns:a16="http://schemas.microsoft.com/office/drawing/2014/main" id="{83AC19D3-CFF0-45FA-9B17-05430514472A}"/>
               </a:ext>
             </a:extLst>
           </p:cNvPr>
@@ -4384,7 +4384,7 @@
           <p:cNvPr id="5" name="">
             <a:extLst xmlns:a="http://schemas.openxmlformats.org/drawingml/2006/main">
               <a:ext uri="{FF2B5EF4-FFF2-40B4-BE49-F238E27FC236}">
-                <a16:creationId xmlns:a16="http://schemas.microsoft.com/office/drawing/2014/main" id="{798EB82E-36F2-4EB4-9E01-3B47F65A086D}"/>
+                <a16:creationId xmlns:a16="http://schemas.microsoft.com/office/drawing/2014/main" id="{D18993DE-E0CD-487C-ACFB-32C2E7F382D6}"/>
               </a:ext>
             </a:extLst>
           </p:cNvPr>
@@ -4419,7 +4419,7 @@
           <p:cNvPr id="6" name="">
             <a:extLst xmlns:a="http://schemas.openxmlformats.org/drawingml/2006/main">
               <a:ext uri="{FF2B5EF4-FFF2-40B4-BE49-F238E27FC236}">
-                <a16:creationId xmlns:a16="http://schemas.microsoft.com/office/drawing/2014/main" id="{655A9E9E-01B1-4FCD-82B4-03DA01AA5DB0}"/>
+                <a16:creationId xmlns:a16="http://schemas.microsoft.com/office/drawing/2014/main" id="{EF38B81F-467B-414D-9AE7-60F5F12F0550}"/>
               </a:ext>
             </a:extLst>
           </p:cNvPr>
@@ -4469,7 +4469,7 @@
           <p:cNvPr id="7" name="">
             <a:extLst xmlns:a="http://schemas.openxmlformats.org/drawingml/2006/main">
               <a:ext uri="{FF2B5EF4-FFF2-40B4-BE49-F238E27FC236}">
-                <a16:creationId xmlns:a16="http://schemas.microsoft.com/office/drawing/2014/main" id="{8E8AC762-9543-4D9D-9D8B-F6C2F6CBD003}"/>
+                <a16:creationId xmlns:a16="http://schemas.microsoft.com/office/drawing/2014/main" id="{AE58E023-A89E-4792-B508-965F0288A049}"/>
               </a:ext>
             </a:extLst>
           </p:cNvPr>
@@ -4517,7 +4517,7 @@
     </p:spTree>
     <p:extLst>
       <p:ext uri="{BB962C8B-B14F-4D97-AF65-F5344CB8AC3E}">
-        <p14:creationId xmlns:p14="http://schemas.microsoft.com/office/powerpoint/2010/main" val="1140204513"/>
+        <p14:creationId xmlns:p14="http://schemas.microsoft.com/office/powerpoint/2010/main" val="379100227"/>
       </p:ext>
     </p:extLst>
   </p:cSld>
@@ -4548,7 +4548,7 @@
           <p:cNvPr id="14" name="">
             <a:extLst xmlns:a="http://schemas.openxmlformats.org/drawingml/2006/main">
               <a:ext uri="{FF2B5EF4-FFF2-40B4-BE49-F238E27FC236}">
-                <a16:creationId xmlns:a16="http://schemas.microsoft.com/office/drawing/2014/main" id="{3C24262B-4D29-44DC-B96B-20831EF1D7C9}"/>
+                <a16:creationId xmlns:a16="http://schemas.microsoft.com/office/drawing/2014/main" id="{3D11CC6D-47D6-4365-B79F-47C32EE1076E}"/>
               </a:ext>
             </a:extLst>
           </p:cNvPr>
@@ -4598,7 +4598,7 @@
           <p:cNvPr id="2" name="">
             <a:extLst xmlns:a="http://schemas.openxmlformats.org/drawingml/2006/main">
               <a:ext uri="{FF2B5EF4-FFF2-40B4-BE49-F238E27FC236}">
-                <a16:creationId xmlns:a16="http://schemas.microsoft.com/office/drawing/2014/main" id="{D8F6C2F6-1961-4D49-9B86-E7A3C2C5525F}"/>
+                <a16:creationId xmlns:a16="http://schemas.microsoft.com/office/drawing/2014/main" id="{D60BB5DF-02F4-4722-A78D-B369B5F2CB6B}"/>
               </a:ext>
             </a:extLst>
           </p:cNvPr>
@@ -4648,7 +4648,7 @@
           <p:cNvPr id="3" name="">
             <a:extLst xmlns:a="http://schemas.openxmlformats.org/drawingml/2006/main">
               <a:ext uri="{FF2B5EF4-FFF2-40B4-BE49-F238E27FC236}">
-                <a16:creationId xmlns:a16="http://schemas.microsoft.com/office/drawing/2014/main" id="{EBDEF039-F7B7-4F2B-95D6-23CC180A75E6}"/>
+                <a16:creationId xmlns:a16="http://schemas.microsoft.com/office/drawing/2014/main" id="{8AC44379-080B-403C-8603-CD5CB8AB6DC1}"/>
               </a:ext>
             </a:extLst>
           </p:cNvPr>
@@ -4698,7 +4698,7 @@
           <p:cNvPr id="4" name="">
             <a:extLst xmlns:a="http://schemas.openxmlformats.org/drawingml/2006/main">
               <a:ext uri="{FF2B5EF4-FFF2-40B4-BE49-F238E27FC236}">
-                <a16:creationId xmlns:a16="http://schemas.microsoft.com/office/drawing/2014/main" id="{DDD4099F-57D6-43FC-98F7-92709E6CDC04}"/>
+                <a16:creationId xmlns:a16="http://schemas.microsoft.com/office/drawing/2014/main" id="{9A8DD21A-E8EC-4AB7-A351-238B0B5CDB39}"/>
               </a:ext>
             </a:extLst>
           </p:cNvPr>
@@ -4729,7 +4729,7 @@
           <p:cNvPr id="5" name="">
             <a:extLst xmlns:a="http://schemas.openxmlformats.org/drawingml/2006/main">
               <a:ext uri="{FF2B5EF4-FFF2-40B4-BE49-F238E27FC236}">
-                <a16:creationId xmlns:a16="http://schemas.microsoft.com/office/drawing/2014/main" id="{2205AC5F-CD71-4EFD-A171-84D6949846A4}"/>
+                <a16:creationId xmlns:a16="http://schemas.microsoft.com/office/drawing/2014/main" id="{21FE09C6-0100-4A9E-B776-8ECAB6371926}"/>
               </a:ext>
             </a:extLst>
           </p:cNvPr>
@@ -4779,7 +4779,7 @@
           <p:cNvPr id="6" name="">
             <a:extLst xmlns:a="http://schemas.openxmlformats.org/drawingml/2006/main">
               <a:ext uri="{FF2B5EF4-FFF2-40B4-BE49-F238E27FC236}">
-                <a16:creationId xmlns:a16="http://schemas.microsoft.com/office/drawing/2014/main" id="{15DEE216-C306-4531-91A2-1435F098DB58}"/>
+                <a16:creationId xmlns:a16="http://schemas.microsoft.com/office/drawing/2014/main" id="{DAD8E028-CE3F-473D-96E9-5830AAE10F14}"/>
               </a:ext>
             </a:extLst>
           </p:cNvPr>
@@ -4814,7 +4814,7 @@
           <p:cNvPr id="7" name="">
             <a:extLst xmlns:a="http://schemas.openxmlformats.org/drawingml/2006/main">
               <a:ext uri="{FF2B5EF4-FFF2-40B4-BE49-F238E27FC236}">
-                <a16:creationId xmlns:a16="http://schemas.microsoft.com/office/drawing/2014/main" id="{C7306628-A211-49E9-95D5-B7714E76BF4C}"/>
+                <a16:creationId xmlns:a16="http://schemas.microsoft.com/office/drawing/2014/main" id="{DCB12099-C7F3-49C1-A176-063CC5C32A76}"/>
               </a:ext>
             </a:extLst>
           </p:cNvPr>
@@ -4864,7 +4864,7 @@
           <p:cNvPr id="8" name="">
             <a:extLst xmlns:a="http://schemas.openxmlformats.org/drawingml/2006/main">
               <a:ext uri="{FF2B5EF4-FFF2-40B4-BE49-F238E27FC236}">
-                <a16:creationId xmlns:a16="http://schemas.microsoft.com/office/drawing/2014/main" id="{9CF90CD7-4CC2-412A-BAE2-DDEA098DACC5}"/>
+                <a16:creationId xmlns:a16="http://schemas.microsoft.com/office/drawing/2014/main" id="{F0CFB449-8143-4819-A309-6219A92508D6}"/>
               </a:ext>
             </a:extLst>
           </p:cNvPr>
@@ -4901,7 +4901,7 @@
           <p:cNvPr id="9" name="">
             <a:extLst xmlns:a="http://schemas.openxmlformats.org/drawingml/2006/main">
               <a:ext uri="{FF2B5EF4-FFF2-40B4-BE49-F238E27FC236}">
-                <a16:creationId xmlns:a16="http://schemas.microsoft.com/office/drawing/2014/main" id="{E9E77401-67C3-4AE6-9D37-9BE4C42F79DB}"/>
+                <a16:creationId xmlns:a16="http://schemas.microsoft.com/office/drawing/2014/main" id="{52422EA1-248F-48F2-8D35-04A4BA7BA0BD}"/>
               </a:ext>
             </a:extLst>
           </p:cNvPr>
@@ -4951,7 +4951,7 @@
           <p:cNvPr id="10" name="">
             <a:extLst xmlns:a="http://schemas.openxmlformats.org/drawingml/2006/main">
               <a:ext uri="{FF2B5EF4-FFF2-40B4-BE49-F238E27FC236}">
-                <a16:creationId xmlns:a16="http://schemas.microsoft.com/office/drawing/2014/main" id="{2584ECFD-58B1-4C95-991B-E47F67C50591}"/>
+                <a16:creationId xmlns:a16="http://schemas.microsoft.com/office/drawing/2014/main" id="{D15C12D7-2687-432F-8108-30BC097F1DB4}"/>
               </a:ext>
             </a:extLst>
           </p:cNvPr>
@@ -5001,7 +5001,7 @@
           <p:cNvPr id="11" name="">
             <a:extLst xmlns:a="http://schemas.openxmlformats.org/drawingml/2006/main">
               <a:ext uri="{FF2B5EF4-FFF2-40B4-BE49-F238E27FC236}">
-                <a16:creationId xmlns:a16="http://schemas.microsoft.com/office/drawing/2014/main" id="{3004CAEB-6E40-443E-8EC3-F0BB1B22346E}"/>
+                <a16:creationId xmlns:a16="http://schemas.microsoft.com/office/drawing/2014/main" id="{8613042C-741B-4B47-9418-FBCB39F735D1}"/>
               </a:ext>
             </a:extLst>
           </p:cNvPr>
@@ -5051,7 +5051,7 @@
           <p:cNvPr id="12" name="">
             <a:extLst xmlns:a="http://schemas.openxmlformats.org/drawingml/2006/main">
               <a:ext uri="{FF2B5EF4-FFF2-40B4-BE49-F238E27FC236}">
-                <a16:creationId xmlns:a16="http://schemas.microsoft.com/office/drawing/2014/main" id="{C1161884-0F9D-4D74-98BE-C213AE809528}"/>
+                <a16:creationId xmlns:a16="http://schemas.microsoft.com/office/drawing/2014/main" id="{BA457FAB-EAAD-40D0-9F43-BE219E4704B5}"/>
               </a:ext>
             </a:extLst>
           </p:cNvPr>
@@ -5101,7 +5101,7 @@
           <p:cNvPr id="13" name="">
             <a:extLst xmlns:a="http://schemas.openxmlformats.org/drawingml/2006/main">
               <a:ext uri="{FF2B5EF4-FFF2-40B4-BE49-F238E27FC236}">
-                <a16:creationId xmlns:a16="http://schemas.microsoft.com/office/drawing/2014/main" id="{66E59F1A-50D5-49A3-A207-A68AD486E97A}"/>
+                <a16:creationId xmlns:a16="http://schemas.microsoft.com/office/drawing/2014/main" id="{2337862E-6248-4BFA-9B2A-A14FB43AF715}"/>
               </a:ext>
             </a:extLst>
           </p:cNvPr>
@@ -5149,7 +5149,7 @@
     </p:spTree>
     <p:extLst>
       <p:ext uri="{BB962C8B-B14F-4D97-AF65-F5344CB8AC3E}">
-        <p14:creationId xmlns:p14="http://schemas.microsoft.com/office/powerpoint/2010/main" val="464114478"/>
+        <p14:creationId xmlns:p14="http://schemas.microsoft.com/office/powerpoint/2010/main" val="1331215700"/>
       </p:ext>
     </p:extLst>
   </p:cSld>
@@ -5180,7 +5180,7 @@
           <p:cNvPr id="16" name="">
             <a:extLst xmlns:a="http://schemas.openxmlformats.org/drawingml/2006/main">
               <a:ext uri="{FF2B5EF4-FFF2-40B4-BE49-F238E27FC236}">
-                <a16:creationId xmlns:a16="http://schemas.microsoft.com/office/drawing/2014/main" id="{2198F458-73E8-427C-888B-9DDA2678DB7A}"/>
+                <a16:creationId xmlns:a16="http://schemas.microsoft.com/office/drawing/2014/main" id="{83A1C6D4-621C-486E-813D-BC5F06838827}"/>
               </a:ext>
             </a:extLst>
           </p:cNvPr>
@@ -5230,7 +5230,7 @@
           <p:cNvPr id="2" name="">
             <a:extLst xmlns:a="http://schemas.openxmlformats.org/drawingml/2006/main">
               <a:ext uri="{FF2B5EF4-FFF2-40B4-BE49-F238E27FC236}">
-                <a16:creationId xmlns:a16="http://schemas.microsoft.com/office/drawing/2014/main" id="{046073BD-1E67-4088-9040-EDC72FF8D2EA}"/>
+                <a16:creationId xmlns:a16="http://schemas.microsoft.com/office/drawing/2014/main" id="{1A9165C3-20CC-442C-BD5E-2429867BA82A}"/>
               </a:ext>
             </a:extLst>
           </p:cNvPr>
@@ -5280,7 +5280,7 @@
           <p:cNvPr id="3" name="">
             <a:extLst xmlns:a="http://schemas.openxmlformats.org/drawingml/2006/main">
               <a:ext uri="{FF2B5EF4-FFF2-40B4-BE49-F238E27FC236}">
-                <a16:creationId xmlns:a16="http://schemas.microsoft.com/office/drawing/2014/main" id="{343763F3-B38C-4DE8-BD2A-96030E8BF08F}"/>
+                <a16:creationId xmlns:a16="http://schemas.microsoft.com/office/drawing/2014/main" id="{A465C13C-33B8-4667-8411-505FF5E47675}"/>
               </a:ext>
             </a:extLst>
           </p:cNvPr>
@@ -5330,7 +5330,7 @@
           <p:cNvPr id="4" name="">
             <a:extLst xmlns:a="http://schemas.openxmlformats.org/drawingml/2006/main">
               <a:ext uri="{FF2B5EF4-FFF2-40B4-BE49-F238E27FC236}">
-                <a16:creationId xmlns:a16="http://schemas.microsoft.com/office/drawing/2014/main" id="{61C76B04-F61B-4E02-B242-ED4C060C05DE}"/>
+                <a16:creationId xmlns:a16="http://schemas.microsoft.com/office/drawing/2014/main" id="{EE124F9F-130A-477D-AEC5-83AC3BB64A44}"/>
               </a:ext>
             </a:extLst>
           </p:cNvPr>
@@ -5361,7 +5361,7 @@
           <p:cNvPr id="5" name="">
             <a:extLst xmlns:a="http://schemas.openxmlformats.org/drawingml/2006/main">
               <a:ext uri="{FF2B5EF4-FFF2-40B4-BE49-F238E27FC236}">
-                <a16:creationId xmlns:a16="http://schemas.microsoft.com/office/drawing/2014/main" id="{25CC6F5B-009E-4984-AB8C-4E13BF918CCA}"/>
+                <a16:creationId xmlns:a16="http://schemas.microsoft.com/office/drawing/2014/main" id="{E2E8939F-2D6A-4264-96F0-A6C1CA444C86}"/>
               </a:ext>
             </a:extLst>
           </p:cNvPr>
@@ -5411,7 +5411,7 @@
           <p:cNvPr id="6" name="">
             <a:extLst xmlns:a="http://schemas.openxmlformats.org/drawingml/2006/main">
               <a:ext uri="{FF2B5EF4-FFF2-40B4-BE49-F238E27FC236}">
-                <a16:creationId xmlns:a16="http://schemas.microsoft.com/office/drawing/2014/main" id="{1D1BC681-5AF9-43A7-95B3-E77477744DCB}"/>
+                <a16:creationId xmlns:a16="http://schemas.microsoft.com/office/drawing/2014/main" id="{F8B097F2-AF62-4468-8787-E7BF26E1EF4B}"/>
               </a:ext>
             </a:extLst>
           </p:cNvPr>
@@ -5461,7 +5461,7 @@
           <p:cNvPr id="7" name="">
             <a:extLst xmlns:a="http://schemas.openxmlformats.org/drawingml/2006/main">
               <a:ext uri="{FF2B5EF4-FFF2-40B4-BE49-F238E27FC236}">
-                <a16:creationId xmlns:a16="http://schemas.microsoft.com/office/drawing/2014/main" id="{CB43D991-EE72-4DFE-B915-6F2171D9941D}"/>
+                <a16:creationId xmlns:a16="http://schemas.microsoft.com/office/drawing/2014/main" id="{E951CCA3-F37E-40D6-8E99-E62B687DA648}"/>
               </a:ext>
             </a:extLst>
           </p:cNvPr>
@@ -5492,7 +5492,7 @@
           <p:cNvPr id="8" name="">
             <a:extLst xmlns:a="http://schemas.openxmlformats.org/drawingml/2006/main">
               <a:ext uri="{FF2B5EF4-FFF2-40B4-BE49-F238E27FC236}">
-                <a16:creationId xmlns:a16="http://schemas.microsoft.com/office/drawing/2014/main" id="{CA535B8A-3FC3-49AC-A1E3-93D024BE06AF}"/>
+                <a16:creationId xmlns:a16="http://schemas.microsoft.com/office/drawing/2014/main" id="{963FE64D-51A2-4138-811F-CD2E780EC3ED}"/>
               </a:ext>
             </a:extLst>
           </p:cNvPr>
@@ -5542,7 +5542,7 @@
           <p:cNvPr id="9" name="">
             <a:extLst xmlns:a="http://schemas.openxmlformats.org/drawingml/2006/main">
               <a:ext uri="{FF2B5EF4-FFF2-40B4-BE49-F238E27FC236}">
-                <a16:creationId xmlns:a16="http://schemas.microsoft.com/office/drawing/2014/main" id="{5043B20D-EA16-43C7-9DE9-19ACE0EFF88A}"/>
+                <a16:creationId xmlns:a16="http://schemas.microsoft.com/office/drawing/2014/main" id="{699AA7DD-EFD3-4B80-A4A0-D5C0D49519A8}"/>
               </a:ext>
             </a:extLst>
           </p:cNvPr>
@@ -5573,7 +5573,7 @@
           <p:cNvPr id="10" name="">
             <a:extLst xmlns:a="http://schemas.openxmlformats.org/drawingml/2006/main">
               <a:ext uri="{FF2B5EF4-FFF2-40B4-BE49-F238E27FC236}">
-                <a16:creationId xmlns:a16="http://schemas.microsoft.com/office/drawing/2014/main" id="{2371F0CA-55F9-40F5-A3F3-2CED328B0E08}"/>
+                <a16:creationId xmlns:a16="http://schemas.microsoft.com/office/drawing/2014/main" id="{98A5BAE6-E1DF-4902-ABBA-1E461972A8A8}"/>
               </a:ext>
             </a:extLst>
           </p:cNvPr>
@@ -5623,7 +5623,7 @@
           <p:cNvPr id="11" name="">
             <a:extLst xmlns:a="http://schemas.openxmlformats.org/drawingml/2006/main">
               <a:ext uri="{FF2B5EF4-FFF2-40B4-BE49-F238E27FC236}">
-                <a16:creationId xmlns:a16="http://schemas.microsoft.com/office/drawing/2014/main" id="{1075022F-ED28-4801-8056-AB76A24E245D}"/>
+                <a16:creationId xmlns:a16="http://schemas.microsoft.com/office/drawing/2014/main" id="{25449C5C-B325-49B2-9B5B-C04B44FE72FC}"/>
               </a:ext>
             </a:extLst>
           </p:cNvPr>
@@ -5654,7 +5654,7 @@
           <p:cNvPr id="12" name="">
             <a:extLst xmlns:a="http://schemas.openxmlformats.org/drawingml/2006/main">
               <a:ext uri="{FF2B5EF4-FFF2-40B4-BE49-F238E27FC236}">
-                <a16:creationId xmlns:a16="http://schemas.microsoft.com/office/drawing/2014/main" id="{847EF550-A1C3-4876-B997-4A84912F1392}"/>
+                <a16:creationId xmlns:a16="http://schemas.microsoft.com/office/drawing/2014/main" id="{972FEA68-4B2A-47BF-B333-6B82C266037A}"/>
               </a:ext>
             </a:extLst>
           </p:cNvPr>
@@ -5704,7 +5704,7 @@
           <p:cNvPr id="13" name="">
             <a:extLst xmlns:a="http://schemas.openxmlformats.org/drawingml/2006/main">
               <a:ext uri="{FF2B5EF4-FFF2-40B4-BE49-F238E27FC236}">
-                <a16:creationId xmlns:a16="http://schemas.microsoft.com/office/drawing/2014/main" id="{ECEEC783-8503-4CFA-AD73-3A052FEBB8EE}"/>
+                <a16:creationId xmlns:a16="http://schemas.microsoft.com/office/drawing/2014/main" id="{8F23FECA-3C56-4279-B499-FAE14EDB215B}"/>
               </a:ext>
             </a:extLst>
           </p:cNvPr>
@@ -5735,7 +5735,7 @@
           <p:cNvPr id="14" name="">
             <a:extLst xmlns:a="http://schemas.openxmlformats.org/drawingml/2006/main">
               <a:ext uri="{FF2B5EF4-FFF2-40B4-BE49-F238E27FC236}">
-                <a16:creationId xmlns:a16="http://schemas.microsoft.com/office/drawing/2014/main" id="{CC35CE5D-463F-44AA-A5EA-7A8B4280811D}"/>
+                <a16:creationId xmlns:a16="http://schemas.microsoft.com/office/drawing/2014/main" id="{87E1F2C3-4EF2-4FC3-8C68-CC185E98ADB7}"/>
               </a:ext>
             </a:extLst>
           </p:cNvPr>
@@ -5785,7 +5785,7 @@
           <p:cNvPr id="15" name="">
             <a:extLst xmlns:a="http://schemas.openxmlformats.org/drawingml/2006/main">
               <a:ext uri="{FF2B5EF4-FFF2-40B4-BE49-F238E27FC236}">
-                <a16:creationId xmlns:a16="http://schemas.microsoft.com/office/drawing/2014/main" id="{E82A22E2-A4E4-4F2E-A629-B5A92CA1653C}"/>
+                <a16:creationId xmlns:a16="http://schemas.microsoft.com/office/drawing/2014/main" id="{F6D39181-B905-494E-AF4C-EDE45F47AAE0}"/>
               </a:ext>
             </a:extLst>
           </p:cNvPr>
@@ -5814,7 +5814,7 @@
     </p:spTree>
     <p:extLst>
       <p:ext uri="{BB962C8B-B14F-4D97-AF65-F5344CB8AC3E}">
-        <p14:creationId xmlns:p14="http://schemas.microsoft.com/office/powerpoint/2010/main" val="937467615"/>
+        <p14:creationId xmlns:p14="http://schemas.microsoft.com/office/powerpoint/2010/main" val="30325168"/>
       </p:ext>
     </p:extLst>
   </p:cSld>
@@ -5845,7 +5845,7 @@
           <p:cNvPr id="9" name="">
             <a:extLst xmlns:a="http://schemas.openxmlformats.org/drawingml/2006/main">
               <a:ext uri="{FF2B5EF4-FFF2-40B4-BE49-F238E27FC236}">
-                <a16:creationId xmlns:a16="http://schemas.microsoft.com/office/drawing/2014/main" id="{AC0BBCD0-CFC4-4873-BC77-B469F2B8BA86}"/>
+                <a16:creationId xmlns:a16="http://schemas.microsoft.com/office/drawing/2014/main" id="{AD9F45C1-D71E-4D19-95DF-2C9BBCAF9C0A}"/>
               </a:ext>
             </a:extLst>
           </p:cNvPr>
@@ -5895,7 +5895,7 @@
           <p:cNvPr id="2" name="">
             <a:extLst xmlns:a="http://schemas.openxmlformats.org/drawingml/2006/main">
               <a:ext uri="{FF2B5EF4-FFF2-40B4-BE49-F238E27FC236}">
-                <a16:creationId xmlns:a16="http://schemas.microsoft.com/office/drawing/2014/main" id="{CFA29D1C-A3B2-439A-8574-48CC394AD230}"/>
+                <a16:creationId xmlns:a16="http://schemas.microsoft.com/office/drawing/2014/main" id="{5CCE9256-9766-4237-84C3-2C210A919776}"/>
               </a:ext>
             </a:extLst>
           </p:cNvPr>
@@ -5945,7 +5945,7 @@
           <p:cNvPr id="3" name="">
             <a:extLst xmlns:a="http://schemas.openxmlformats.org/drawingml/2006/main">
               <a:ext uri="{FF2B5EF4-FFF2-40B4-BE49-F238E27FC236}">
-                <a16:creationId xmlns:a16="http://schemas.microsoft.com/office/drawing/2014/main" id="{C9327536-F57F-4675-B8D6-45173CB713E7}"/>
+                <a16:creationId xmlns:a16="http://schemas.microsoft.com/office/drawing/2014/main" id="{7457D947-A882-4503-9D92-FB7CFCB685B1}"/>
               </a:ext>
             </a:extLst>
           </p:cNvPr>
@@ -5995,7 +5995,7 @@
           <p:cNvPr id="4" name="">
             <a:extLst xmlns:a="http://schemas.openxmlformats.org/drawingml/2006/main">
               <a:ext uri="{FF2B5EF4-FFF2-40B4-BE49-F238E27FC236}">
-                <a16:creationId xmlns:a16="http://schemas.microsoft.com/office/drawing/2014/main" id="{064EBDE6-B560-4F8A-AEA6-047995EB9465}"/>
+                <a16:creationId xmlns:a16="http://schemas.microsoft.com/office/drawing/2014/main" id="{A24ADDBA-02AD-4967-B3E9-F3D08E924800}"/>
               </a:ext>
             </a:extLst>
           </p:cNvPr>
@@ -6026,7 +6026,7 @@
           <p:cNvPr id="5" name="">
             <a:extLst xmlns:a="http://schemas.openxmlformats.org/drawingml/2006/main">
               <a:ext uri="{FF2B5EF4-FFF2-40B4-BE49-F238E27FC236}">
-                <a16:creationId xmlns:a16="http://schemas.microsoft.com/office/drawing/2014/main" id="{6BC6362E-8D5F-4746-9B4B-8A1C43CE43E2}"/>
+                <a16:creationId xmlns:a16="http://schemas.microsoft.com/office/drawing/2014/main" id="{96186566-C43F-4DA6-9996-D8371D0B9F2D}"/>
               </a:ext>
             </a:extLst>
           </p:cNvPr>
@@ -6076,7 +6076,7 @@
           <p:cNvPr id="6" name="">
             <a:extLst xmlns:a="http://schemas.openxmlformats.org/drawingml/2006/main">
               <a:ext uri="{FF2B5EF4-FFF2-40B4-BE49-F238E27FC236}">
-                <a16:creationId xmlns:a16="http://schemas.microsoft.com/office/drawing/2014/main" id="{5B9A789F-8829-48C6-AD71-BA3748DEA618}"/>
+                <a16:creationId xmlns:a16="http://schemas.microsoft.com/office/drawing/2014/main" id="{C4399061-2D73-48E5-B922-FEEC99F6DC9B}"/>
               </a:ext>
             </a:extLst>
           </p:cNvPr>
@@ -6126,7 +6126,7 @@
           <p:cNvPr id="7" name="">
             <a:extLst xmlns:a="http://schemas.openxmlformats.org/drawingml/2006/main">
               <a:ext uri="{FF2B5EF4-FFF2-40B4-BE49-F238E27FC236}">
-                <a16:creationId xmlns:a16="http://schemas.microsoft.com/office/drawing/2014/main" id="{9FAE2133-27DC-4D6D-8C82-CD8C7F1CFB22}"/>
+                <a16:creationId xmlns:a16="http://schemas.microsoft.com/office/drawing/2014/main" id="{894990AE-1BEE-4B32-B804-CDB90BFBC8FD}"/>
               </a:ext>
             </a:extLst>
           </p:cNvPr>
@@ -6161,7 +6161,7 @@
           <p:cNvPr id="8" name="">
             <a:extLst xmlns:a="http://schemas.openxmlformats.org/drawingml/2006/main">
               <a:ext uri="{FF2B5EF4-FFF2-40B4-BE49-F238E27FC236}">
-                <a16:creationId xmlns:a16="http://schemas.microsoft.com/office/drawing/2014/main" id="{83084D8D-87B4-4592-8C5E-D8DED9027A03}"/>
+                <a16:creationId xmlns:a16="http://schemas.microsoft.com/office/drawing/2014/main" id="{0927BCB0-B333-4C55-9924-3D2C0EE20216}"/>
               </a:ext>
             </a:extLst>
           </p:cNvPr>
@@ -6209,7 +6209,7 @@
     </p:spTree>
     <p:extLst>
       <p:ext uri="{BB962C8B-B14F-4D97-AF65-F5344CB8AC3E}">
-        <p14:creationId xmlns:p14="http://schemas.microsoft.com/office/powerpoint/2010/main" val="1308931267"/>
+        <p14:creationId xmlns:p14="http://schemas.microsoft.com/office/powerpoint/2010/main" val="596404953"/>
       </p:ext>
     </p:extLst>
   </p:cSld>

</xml_diff>

<commit_message>
Revise lesson one summary slide
</commit_message>
<xml_diff>
--- a/class/ppt/lesson-01.pptx
+++ b/class/ppt/lesson-01.pptx
@@ -2,20 +2,20 @@
 <file path=ppt/presentation.xml><?xml version="1.0" encoding="utf-8"?>
 <p:presentation xmlns:p="http://schemas.openxmlformats.org/presentationml/2006/main">
   <p:sldMasterIdLst>
-    <p:sldMasterId xmlns:r="http://schemas.openxmlformats.org/officeDocument/2006/relationships" id="2147483648" r:id="R9a8ae52b499c40e2"/>
+    <p:sldMasterId xmlns:r="http://schemas.openxmlformats.org/officeDocument/2006/relationships" id="2147483648" r:id="R198dbb8d95254504"/>
   </p:sldMasterIdLst>
   <p:notesMasterIdLst>
-    <p:notesMasterId xmlns:r="http://schemas.openxmlformats.org/officeDocument/2006/relationships" r:id="R2bffed36800c4cdc"/>
+    <p:notesMasterId xmlns:r="http://schemas.openxmlformats.org/officeDocument/2006/relationships" r:id="R1e9de1d1048846de"/>
   </p:notesMasterIdLst>
   <p:sldIdLst>
-    <p:sldId xmlns:r="http://schemas.openxmlformats.org/officeDocument/2006/relationships" id="256" r:id="R93d075a7f68f4198"/>
-    <p:sldId xmlns:r="http://schemas.openxmlformats.org/officeDocument/2006/relationships" id="257" r:id="Redbbfb32f4aa413f"/>
-    <p:sldId xmlns:r="http://schemas.openxmlformats.org/officeDocument/2006/relationships" id="258" r:id="Ra8c78997dedb421a"/>
-    <p:sldId xmlns:r="http://schemas.openxmlformats.org/officeDocument/2006/relationships" id="259" r:id="R8d9c6eea42dc4bf1"/>
-    <p:sldId xmlns:r="http://schemas.openxmlformats.org/officeDocument/2006/relationships" id="260" r:id="Rd9ea312dd90242f6"/>
-    <p:sldId xmlns:r="http://schemas.openxmlformats.org/officeDocument/2006/relationships" id="261" r:id="R7d2a7a1213d947e4"/>
-    <p:sldId xmlns:r="http://schemas.openxmlformats.org/officeDocument/2006/relationships" id="262" r:id="Ra2e601ddf3dd4629"/>
-    <p:sldId xmlns:r="http://schemas.openxmlformats.org/officeDocument/2006/relationships" id="263" r:id="R483e300f1f2f4ee5"/>
+    <p:sldId xmlns:r="http://schemas.openxmlformats.org/officeDocument/2006/relationships" id="256" r:id="R7e2b05b67afc4051"/>
+    <p:sldId xmlns:r="http://schemas.openxmlformats.org/officeDocument/2006/relationships" id="257" r:id="R03dc28d89c544117"/>
+    <p:sldId xmlns:r="http://schemas.openxmlformats.org/officeDocument/2006/relationships" id="258" r:id="R82ba9e5ada8b4144"/>
+    <p:sldId xmlns:r="http://schemas.openxmlformats.org/officeDocument/2006/relationships" id="259" r:id="R2f098fedc0374991"/>
+    <p:sldId xmlns:r="http://schemas.openxmlformats.org/officeDocument/2006/relationships" id="260" r:id="Rf7a6b971cc664c04"/>
+    <p:sldId xmlns:r="http://schemas.openxmlformats.org/officeDocument/2006/relationships" id="261" r:id="Rb3a8da30562f44f7"/>
+    <p:sldId xmlns:r="http://schemas.openxmlformats.org/officeDocument/2006/relationships" id="262" r:id="Rfdfcf33edeb44fcf"/>
+    <p:sldId xmlns:r="http://schemas.openxmlformats.org/officeDocument/2006/relationships" id="263" r:id="Rc0e34d672d264011"/>
   </p:sldIdLst>
   <p:sldSz cx="12192000" cy="6858000"/>
   <p:notesSz cx="6858000" cy="9144000"/>
@@ -1127,7 +1127,7 @@
   </p:cSld>
   <p:clrMap bg1="lt1" tx1="dk1" bg2="lt2" tx2="dk2" accent1="accent1" accent2="accent2" accent3="accent3" accent4="accent4" accent5="accent5" accent6="accent6" hlink="hlink" folHlink="folHlink"/>
   <p:sldLayoutIdLst>
-    <p:sldLayoutId xmlns:r="http://schemas.openxmlformats.org/officeDocument/2006/relationships" id="2147483649" r:id="R51990d57ab4745d5"/>
+    <p:sldLayoutId xmlns:r="http://schemas.openxmlformats.org/officeDocument/2006/relationships" id="2147483649" r:id="Rda66842d355a41c5"/>
   </p:sldLayoutIdLst>
   <p:txStyles>
     <p:titleStyle>
@@ -1678,7 +1678,7 @@
           <p:cNvPr id="8" name="">
             <a:extLst xmlns:a="http://schemas.openxmlformats.org/drawingml/2006/main">
               <a:ext uri="{FF2B5EF4-FFF2-40B4-BE49-F238E27FC236}">
-                <a16:creationId xmlns:a16="http://schemas.microsoft.com/office/drawing/2014/main" id="{0CA52429-4107-49D6-9177-7A947905D3F0}"/>
+                <a16:creationId xmlns:a16="http://schemas.microsoft.com/office/drawing/2014/main" id="{B068327F-8E72-4148-980D-1F97FE4C220B}"/>
               </a:ext>
             </a:extLst>
           </p:cNvPr>
@@ -1711,7 +1711,7 @@
           <p:cNvPr id="2" name="">
             <a:extLst xmlns:a="http://schemas.openxmlformats.org/drawingml/2006/main">
               <a:ext uri="{FF2B5EF4-FFF2-40B4-BE49-F238E27FC236}">
-                <a16:creationId xmlns:a16="http://schemas.microsoft.com/office/drawing/2014/main" id="{0629585A-C949-49EC-9BC9-DA7F19997A64}"/>
+                <a16:creationId xmlns:a16="http://schemas.microsoft.com/office/drawing/2014/main" id="{C8D6EBB5-5471-4EAC-A3E1-5C1D2414A085}"/>
               </a:ext>
             </a:extLst>
           </p:cNvPr>
@@ -1761,7 +1761,7 @@
           <p:cNvPr id="3" name="">
             <a:extLst xmlns:a="http://schemas.openxmlformats.org/drawingml/2006/main">
               <a:ext uri="{FF2B5EF4-FFF2-40B4-BE49-F238E27FC236}">
-                <a16:creationId xmlns:a16="http://schemas.microsoft.com/office/drawing/2014/main" id="{EB5091B8-11BE-4F9E-9529-EE64382BF1B8}"/>
+                <a16:creationId xmlns:a16="http://schemas.microsoft.com/office/drawing/2014/main" id="{CE0C1836-7EA8-4F3A-AE2A-C1F32A7CAAE4}"/>
               </a:ext>
             </a:extLst>
           </p:cNvPr>
@@ -1811,7 +1811,7 @@
           <p:cNvPr id="4" name="">
             <a:extLst xmlns:a="http://schemas.openxmlformats.org/drawingml/2006/main">
               <a:ext uri="{FF2B5EF4-FFF2-40B4-BE49-F238E27FC236}">
-                <a16:creationId xmlns:a16="http://schemas.microsoft.com/office/drawing/2014/main" id="{AD93A03E-3C4E-4124-B0C0-93310E99A419}"/>
+                <a16:creationId xmlns:a16="http://schemas.microsoft.com/office/drawing/2014/main" id="{A746C3F0-2795-4117-9428-F00EF596D6E4}"/>
               </a:ext>
             </a:extLst>
           </p:cNvPr>
@@ -1861,7 +1861,7 @@
           <p:cNvPr id="5" name="">
             <a:extLst xmlns:a="http://schemas.openxmlformats.org/drawingml/2006/main">
               <a:ext uri="{FF2B5EF4-FFF2-40B4-BE49-F238E27FC236}">
-                <a16:creationId xmlns:a16="http://schemas.microsoft.com/office/drawing/2014/main" id="{1C484370-7395-404B-9FAE-1EEECB2F99F2}"/>
+                <a16:creationId xmlns:a16="http://schemas.microsoft.com/office/drawing/2014/main" id="{727891FD-B7BE-43F3-86D9-D9F61DD465D1}"/>
               </a:ext>
             </a:extLst>
           </p:cNvPr>
@@ -1896,7 +1896,7 @@
           <p:cNvPr id="6" name="">
             <a:extLst xmlns:a="http://schemas.openxmlformats.org/drawingml/2006/main">
               <a:ext uri="{FF2B5EF4-FFF2-40B4-BE49-F238E27FC236}">
-                <a16:creationId xmlns:a16="http://schemas.microsoft.com/office/drawing/2014/main" id="{A6764B79-E201-46D2-B8EC-C0F9FE253A1A}"/>
+                <a16:creationId xmlns:a16="http://schemas.microsoft.com/office/drawing/2014/main" id="{CFF74D2F-B297-4037-B493-5D87F5CD787D}"/>
               </a:ext>
             </a:extLst>
           </p:cNvPr>
@@ -1946,7 +1946,7 @@
           <p:cNvPr id="7" name="">
             <a:extLst xmlns:a="http://schemas.openxmlformats.org/drawingml/2006/main">
               <a:ext uri="{FF2B5EF4-FFF2-40B4-BE49-F238E27FC236}">
-                <a16:creationId xmlns:a16="http://schemas.microsoft.com/office/drawing/2014/main" id="{3F5E2360-7988-48E1-94B2-885625AA84DD}"/>
+                <a16:creationId xmlns:a16="http://schemas.microsoft.com/office/drawing/2014/main" id="{3F0BD888-1281-465A-B0AA-F13D0A0BF692}"/>
               </a:ext>
             </a:extLst>
           </p:cNvPr>
@@ -2011,7 +2011,7 @@
     </p:spTree>
     <p:extLst>
       <p:ext uri="{BB962C8B-B14F-4D97-AF65-F5344CB8AC3E}">
-        <p14:creationId xmlns:p14="http://schemas.microsoft.com/office/powerpoint/2010/main" val="458813383"/>
+        <p14:creationId xmlns:p14="http://schemas.microsoft.com/office/powerpoint/2010/main" val="164951980"/>
       </p:ext>
     </p:extLst>
   </p:cSld>
@@ -2042,7 +2042,7 @@
           <p:cNvPr id="12" name="">
             <a:extLst xmlns:a="http://schemas.openxmlformats.org/drawingml/2006/main">
               <a:ext uri="{FF2B5EF4-FFF2-40B4-BE49-F238E27FC236}">
-                <a16:creationId xmlns:a16="http://schemas.microsoft.com/office/drawing/2014/main" id="{D3A45399-E171-4324-937C-E821411F67A2}"/>
+                <a16:creationId xmlns:a16="http://schemas.microsoft.com/office/drawing/2014/main" id="{4F57948F-D20F-4540-AEB2-3A0851134559}"/>
               </a:ext>
             </a:extLst>
           </p:cNvPr>
@@ -2092,7 +2092,7 @@
           <p:cNvPr id="2" name="">
             <a:extLst xmlns:a="http://schemas.openxmlformats.org/drawingml/2006/main">
               <a:ext uri="{FF2B5EF4-FFF2-40B4-BE49-F238E27FC236}">
-                <a16:creationId xmlns:a16="http://schemas.microsoft.com/office/drawing/2014/main" id="{5D7B9F50-526A-4798-A551-2AB571AEC606}"/>
+                <a16:creationId xmlns:a16="http://schemas.microsoft.com/office/drawing/2014/main" id="{16CD6040-355E-46CE-8A9D-C1267D549ABC}"/>
               </a:ext>
             </a:extLst>
           </p:cNvPr>
@@ -2142,7 +2142,7 @@
           <p:cNvPr id="3" name="">
             <a:extLst xmlns:a="http://schemas.openxmlformats.org/drawingml/2006/main">
               <a:ext uri="{FF2B5EF4-FFF2-40B4-BE49-F238E27FC236}">
-                <a16:creationId xmlns:a16="http://schemas.microsoft.com/office/drawing/2014/main" id="{5A6B1E2B-6CC7-49C8-9A1D-CC71FEE2FBF0}"/>
+                <a16:creationId xmlns:a16="http://schemas.microsoft.com/office/drawing/2014/main" id="{8F656918-6D80-40CD-AE1A-C7C66BC345CA}"/>
               </a:ext>
             </a:extLst>
           </p:cNvPr>
@@ -2192,7 +2192,7 @@
           <p:cNvPr id="4" name="">
             <a:extLst xmlns:a="http://schemas.openxmlformats.org/drawingml/2006/main">
               <a:ext uri="{FF2B5EF4-FFF2-40B4-BE49-F238E27FC236}">
-                <a16:creationId xmlns:a16="http://schemas.microsoft.com/office/drawing/2014/main" id="{3E436826-2A2C-4325-8B0A-212A0ED5ED0A}"/>
+                <a16:creationId xmlns:a16="http://schemas.microsoft.com/office/drawing/2014/main" id="{BACC5AAC-F00D-42D1-B69A-1B310B17FA03}"/>
               </a:ext>
             </a:extLst>
           </p:cNvPr>
@@ -2223,7 +2223,7 @@
           <p:cNvPr id="5" name="">
             <a:extLst xmlns:a="http://schemas.openxmlformats.org/drawingml/2006/main">
               <a:ext uri="{FF2B5EF4-FFF2-40B4-BE49-F238E27FC236}">
-                <a16:creationId xmlns:a16="http://schemas.microsoft.com/office/drawing/2014/main" id="{D3A64789-188B-46E4-982D-C21FA7266F30}"/>
+                <a16:creationId xmlns:a16="http://schemas.microsoft.com/office/drawing/2014/main" id="{165645F4-E604-42A6-B3A2-99BE6E4F203C}"/>
               </a:ext>
             </a:extLst>
           </p:cNvPr>
@@ -2273,7 +2273,7 @@
           <p:cNvPr id="6" name="">
             <a:extLst xmlns:a="http://schemas.openxmlformats.org/drawingml/2006/main">
               <a:ext uri="{FF2B5EF4-FFF2-40B4-BE49-F238E27FC236}">
-                <a16:creationId xmlns:a16="http://schemas.microsoft.com/office/drawing/2014/main" id="{74C78636-270F-4F5E-B2DE-5227926BDCB8}"/>
+                <a16:creationId xmlns:a16="http://schemas.microsoft.com/office/drawing/2014/main" id="{1C2A499C-4AE4-4FF8-86BA-CC75CF999A0C}"/>
               </a:ext>
             </a:extLst>
           </p:cNvPr>
@@ -2323,7 +2323,7 @@
           <p:cNvPr id="7" name="">
             <a:extLst xmlns:a="http://schemas.openxmlformats.org/drawingml/2006/main">
               <a:ext uri="{FF2B5EF4-FFF2-40B4-BE49-F238E27FC236}">
-                <a16:creationId xmlns:a16="http://schemas.microsoft.com/office/drawing/2014/main" id="{7DB37B7A-DD68-467E-A71C-CF9075322903}"/>
+                <a16:creationId xmlns:a16="http://schemas.microsoft.com/office/drawing/2014/main" id="{7F9C7CE1-E959-4E09-A68A-C97989133511}"/>
               </a:ext>
             </a:extLst>
           </p:cNvPr>
@@ -2373,7 +2373,7 @@
           <p:cNvPr id="8" name="">
             <a:extLst xmlns:a="http://schemas.openxmlformats.org/drawingml/2006/main">
               <a:ext uri="{FF2B5EF4-FFF2-40B4-BE49-F238E27FC236}">
-                <a16:creationId xmlns:a16="http://schemas.microsoft.com/office/drawing/2014/main" id="{146E4626-60E5-474F-B732-1325A3033B09}"/>
+                <a16:creationId xmlns:a16="http://schemas.microsoft.com/office/drawing/2014/main" id="{547462D1-BE65-425C-BCE5-97C72F40FF87}"/>
               </a:ext>
             </a:extLst>
           </p:cNvPr>
@@ -2423,7 +2423,7 @@
           <p:cNvPr id="9" name="">
             <a:extLst xmlns:a="http://schemas.openxmlformats.org/drawingml/2006/main">
               <a:ext uri="{FF2B5EF4-FFF2-40B4-BE49-F238E27FC236}">
-                <a16:creationId xmlns:a16="http://schemas.microsoft.com/office/drawing/2014/main" id="{0F23AF14-7729-43F0-9C67-957C0D5D27CF}"/>
+                <a16:creationId xmlns:a16="http://schemas.microsoft.com/office/drawing/2014/main" id="{E06E9D46-EBF4-40B1-B50A-45E1CEC02BC7}"/>
               </a:ext>
             </a:extLst>
           </p:cNvPr>
@@ -2460,7 +2460,7 @@
           <p:cNvPr id="10" name="">
             <a:extLst xmlns:a="http://schemas.openxmlformats.org/drawingml/2006/main">
               <a:ext uri="{FF2B5EF4-FFF2-40B4-BE49-F238E27FC236}">
-                <a16:creationId xmlns:a16="http://schemas.microsoft.com/office/drawing/2014/main" id="{CCDB1841-0232-4619-B726-396267A2DF45}"/>
+                <a16:creationId xmlns:a16="http://schemas.microsoft.com/office/drawing/2014/main" id="{FD73A021-4EAD-4A78-9A60-73777C952254}"/>
               </a:ext>
             </a:extLst>
           </p:cNvPr>
@@ -2510,7 +2510,7 @@
           <p:cNvPr id="11" name="">
             <a:extLst xmlns:a="http://schemas.openxmlformats.org/drawingml/2006/main">
               <a:ext uri="{FF2B5EF4-FFF2-40B4-BE49-F238E27FC236}">
-                <a16:creationId xmlns:a16="http://schemas.microsoft.com/office/drawing/2014/main" id="{5BB055DB-BA16-45F8-A423-2D4C01EB707C}"/>
+                <a16:creationId xmlns:a16="http://schemas.microsoft.com/office/drawing/2014/main" id="{9A4EB3C2-D939-4113-9F66-47041837906B}"/>
               </a:ext>
             </a:extLst>
           </p:cNvPr>
@@ -2558,7 +2558,7 @@
     </p:spTree>
     <p:extLst>
       <p:ext uri="{BB962C8B-B14F-4D97-AF65-F5344CB8AC3E}">
-        <p14:creationId xmlns:p14="http://schemas.microsoft.com/office/powerpoint/2010/main" val="208001452"/>
+        <p14:creationId xmlns:p14="http://schemas.microsoft.com/office/powerpoint/2010/main" val="1616496519"/>
       </p:ext>
     </p:extLst>
   </p:cSld>
@@ -2589,7 +2589,7 @@
           <p:cNvPr id="15" name="">
             <a:extLst xmlns:a="http://schemas.openxmlformats.org/drawingml/2006/main">
               <a:ext uri="{FF2B5EF4-FFF2-40B4-BE49-F238E27FC236}">
-                <a16:creationId xmlns:a16="http://schemas.microsoft.com/office/drawing/2014/main" id="{7CCC0A06-5025-4409-9DD3-03C0ACA876B5}"/>
+                <a16:creationId xmlns:a16="http://schemas.microsoft.com/office/drawing/2014/main" id="{AB8F92F8-B29A-4892-A0AA-C3E93107382F}"/>
               </a:ext>
             </a:extLst>
           </p:cNvPr>
@@ -2639,7 +2639,7 @@
           <p:cNvPr id="2" name="">
             <a:extLst xmlns:a="http://schemas.openxmlformats.org/drawingml/2006/main">
               <a:ext uri="{FF2B5EF4-FFF2-40B4-BE49-F238E27FC236}">
-                <a16:creationId xmlns:a16="http://schemas.microsoft.com/office/drawing/2014/main" id="{DAFB49B0-4A5D-40BE-8D9E-0D7D4B95620E}"/>
+                <a16:creationId xmlns:a16="http://schemas.microsoft.com/office/drawing/2014/main" id="{FC6AA630-DDF2-4B67-ADB6-F5F36C427227}"/>
               </a:ext>
             </a:extLst>
           </p:cNvPr>
@@ -2689,7 +2689,7 @@
           <p:cNvPr id="3" name="">
             <a:extLst xmlns:a="http://schemas.openxmlformats.org/drawingml/2006/main">
               <a:ext uri="{FF2B5EF4-FFF2-40B4-BE49-F238E27FC236}">
-                <a16:creationId xmlns:a16="http://schemas.microsoft.com/office/drawing/2014/main" id="{94FC5770-EA29-40C4-A925-2EB38C3F9AC6}"/>
+                <a16:creationId xmlns:a16="http://schemas.microsoft.com/office/drawing/2014/main" id="{D03DEF1A-D490-4217-ADCA-AABB1205932C}"/>
               </a:ext>
             </a:extLst>
           </p:cNvPr>
@@ -2739,7 +2739,7 @@
           <p:cNvPr id="4" name="">
             <a:extLst xmlns:a="http://schemas.openxmlformats.org/drawingml/2006/main">
               <a:ext uri="{FF2B5EF4-FFF2-40B4-BE49-F238E27FC236}">
-                <a16:creationId xmlns:a16="http://schemas.microsoft.com/office/drawing/2014/main" id="{2A96C30D-0F76-43A8-9BDE-58A08AC1254A}"/>
+                <a16:creationId xmlns:a16="http://schemas.microsoft.com/office/drawing/2014/main" id="{C63717E6-8694-4CB5-B217-6A6FD9C1B9AE}"/>
               </a:ext>
             </a:extLst>
           </p:cNvPr>
@@ -2770,7 +2770,7 @@
           <p:cNvPr id="5" name="">
             <a:extLst xmlns:a="http://schemas.openxmlformats.org/drawingml/2006/main">
               <a:ext uri="{FF2B5EF4-FFF2-40B4-BE49-F238E27FC236}">
-                <a16:creationId xmlns:a16="http://schemas.microsoft.com/office/drawing/2014/main" id="{B363528A-E9AB-470C-B01A-1F953F11F4D8}"/>
+                <a16:creationId xmlns:a16="http://schemas.microsoft.com/office/drawing/2014/main" id="{CFA5FEAA-44E1-4E5A-A305-DA2CA2E6EBBA}"/>
               </a:ext>
             </a:extLst>
           </p:cNvPr>
@@ -2820,7 +2820,7 @@
           <p:cNvPr id="6" name="">
             <a:extLst xmlns:a="http://schemas.openxmlformats.org/drawingml/2006/main">
               <a:ext uri="{FF2B5EF4-FFF2-40B4-BE49-F238E27FC236}">
-                <a16:creationId xmlns:a16="http://schemas.microsoft.com/office/drawing/2014/main" id="{FECF48D9-66A8-4232-BA00-EABD319094F4}"/>
+                <a16:creationId xmlns:a16="http://schemas.microsoft.com/office/drawing/2014/main" id="{B20D9699-BD52-4C33-B8D7-18DB16CF62CD}"/>
               </a:ext>
             </a:extLst>
           </p:cNvPr>
@@ -2857,7 +2857,7 @@
           <p:cNvPr id="7" name="">
             <a:extLst xmlns:a="http://schemas.openxmlformats.org/drawingml/2006/main">
               <a:ext uri="{FF2B5EF4-FFF2-40B4-BE49-F238E27FC236}">
-                <a16:creationId xmlns:a16="http://schemas.microsoft.com/office/drawing/2014/main" id="{151C8F2E-CEA6-41B5-AEA6-A04424DF98D4}"/>
+                <a16:creationId xmlns:a16="http://schemas.microsoft.com/office/drawing/2014/main" id="{DBA4B84D-400B-4D3C-8F52-F9DCFB45E304}"/>
               </a:ext>
             </a:extLst>
           </p:cNvPr>
@@ -2907,7 +2907,7 @@
           <p:cNvPr id="8" name="">
             <a:extLst xmlns:a="http://schemas.openxmlformats.org/drawingml/2006/main">
               <a:ext uri="{FF2B5EF4-FFF2-40B4-BE49-F238E27FC236}">
-                <a16:creationId xmlns:a16="http://schemas.microsoft.com/office/drawing/2014/main" id="{0DFAF4E6-103C-4382-BADD-8C1CF9DFE1AC}"/>
+                <a16:creationId xmlns:a16="http://schemas.microsoft.com/office/drawing/2014/main" id="{4C9A5503-8773-4A06-8A8C-C4A2CEBBC8FE}"/>
               </a:ext>
             </a:extLst>
           </p:cNvPr>
@@ -2957,7 +2957,7 @@
           <p:cNvPr id="9" name="">
             <a:extLst xmlns:a="http://schemas.openxmlformats.org/drawingml/2006/main">
               <a:ext uri="{FF2B5EF4-FFF2-40B4-BE49-F238E27FC236}">
-                <a16:creationId xmlns:a16="http://schemas.microsoft.com/office/drawing/2014/main" id="{C7F577BF-707E-41B7-9247-0FA26AE6F744}"/>
+                <a16:creationId xmlns:a16="http://schemas.microsoft.com/office/drawing/2014/main" id="{28F2DD5C-C3EA-4FD1-A96F-D1601BE4ED70}"/>
               </a:ext>
             </a:extLst>
           </p:cNvPr>
@@ -2992,7 +2992,7 @@
           <p:cNvPr id="10" name="">
             <a:extLst xmlns:a="http://schemas.openxmlformats.org/drawingml/2006/main">
               <a:ext uri="{FF2B5EF4-FFF2-40B4-BE49-F238E27FC236}">
-                <a16:creationId xmlns:a16="http://schemas.microsoft.com/office/drawing/2014/main" id="{3B96387D-78A2-4265-BD14-CEA4F2B4570C}"/>
+                <a16:creationId xmlns:a16="http://schemas.microsoft.com/office/drawing/2014/main" id="{259D61F9-344F-4898-9B60-9516E198F27B}"/>
               </a:ext>
             </a:extLst>
           </p:cNvPr>
@@ -3042,7 +3042,7 @@
           <p:cNvPr id="11" name="">
             <a:extLst xmlns:a="http://schemas.openxmlformats.org/drawingml/2006/main">
               <a:ext uri="{FF2B5EF4-FFF2-40B4-BE49-F238E27FC236}">
-                <a16:creationId xmlns:a16="http://schemas.microsoft.com/office/drawing/2014/main" id="{42824DE9-15C5-4299-BFEE-01AFECA0CA88}"/>
+                <a16:creationId xmlns:a16="http://schemas.microsoft.com/office/drawing/2014/main" id="{B44E3196-9BC6-41EF-A540-7821FD66FEFA}"/>
               </a:ext>
             </a:extLst>
           </p:cNvPr>
@@ -3092,7 +3092,7 @@
           <p:cNvPr id="12" name="">
             <a:extLst xmlns:a="http://schemas.openxmlformats.org/drawingml/2006/main">
               <a:ext uri="{FF2B5EF4-FFF2-40B4-BE49-F238E27FC236}">
-                <a16:creationId xmlns:a16="http://schemas.microsoft.com/office/drawing/2014/main" id="{AD18DE9A-91AE-4369-9E36-280CDE45CA60}"/>
+                <a16:creationId xmlns:a16="http://schemas.microsoft.com/office/drawing/2014/main" id="{427F7D08-734E-42D4-9E40-D904180422C7}"/>
               </a:ext>
             </a:extLst>
           </p:cNvPr>
@@ -3129,7 +3129,7 @@
           <p:cNvPr id="13" name="">
             <a:extLst xmlns:a="http://schemas.openxmlformats.org/drawingml/2006/main">
               <a:ext uri="{FF2B5EF4-FFF2-40B4-BE49-F238E27FC236}">
-                <a16:creationId xmlns:a16="http://schemas.microsoft.com/office/drawing/2014/main" id="{01320078-B6D5-467B-8F45-CD4E3BC02F95}"/>
+                <a16:creationId xmlns:a16="http://schemas.microsoft.com/office/drawing/2014/main" id="{AD41BF50-CA9B-439E-BF53-B0BFDD81EED6}"/>
               </a:ext>
             </a:extLst>
           </p:cNvPr>
@@ -3179,7 +3179,7 @@
           <p:cNvPr id="14" name="">
             <a:extLst xmlns:a="http://schemas.openxmlformats.org/drawingml/2006/main">
               <a:ext uri="{FF2B5EF4-FFF2-40B4-BE49-F238E27FC236}">
-                <a16:creationId xmlns:a16="http://schemas.microsoft.com/office/drawing/2014/main" id="{8313D299-1CC2-44A7-BA02-1240015E1411}"/>
+                <a16:creationId xmlns:a16="http://schemas.microsoft.com/office/drawing/2014/main" id="{59C831F5-390A-4CA1-8174-412803FC7018}"/>
               </a:ext>
             </a:extLst>
           </p:cNvPr>
@@ -3227,7 +3227,7 @@
     </p:spTree>
     <p:extLst>
       <p:ext uri="{BB962C8B-B14F-4D97-AF65-F5344CB8AC3E}">
-        <p14:creationId xmlns:p14="http://schemas.microsoft.com/office/powerpoint/2010/main" val="1157189286"/>
+        <p14:creationId xmlns:p14="http://schemas.microsoft.com/office/powerpoint/2010/main" val="2045091359"/>
       </p:ext>
     </p:extLst>
   </p:cSld>
@@ -3258,7 +3258,7 @@
           <p:cNvPr id="21" name="">
             <a:extLst xmlns:a="http://schemas.openxmlformats.org/drawingml/2006/main">
               <a:ext uri="{FF2B5EF4-FFF2-40B4-BE49-F238E27FC236}">
-                <a16:creationId xmlns:a16="http://schemas.microsoft.com/office/drawing/2014/main" id="{C6C2DC65-3C8C-4568-95E2-674BCBB427F6}"/>
+                <a16:creationId xmlns:a16="http://schemas.microsoft.com/office/drawing/2014/main" id="{E2D400EF-CBD3-42AB-BAB6-F19BA5F7CCC0}"/>
               </a:ext>
             </a:extLst>
           </p:cNvPr>
@@ -3308,7 +3308,7 @@
           <p:cNvPr id="2" name="">
             <a:extLst xmlns:a="http://schemas.openxmlformats.org/drawingml/2006/main">
               <a:ext uri="{FF2B5EF4-FFF2-40B4-BE49-F238E27FC236}">
-                <a16:creationId xmlns:a16="http://schemas.microsoft.com/office/drawing/2014/main" id="{38A3EC0B-50C5-4DA7-9C3C-F1E1F79B5464}"/>
+                <a16:creationId xmlns:a16="http://schemas.microsoft.com/office/drawing/2014/main" id="{924F3505-0E7C-45C8-949C-35C180BBEB1C}"/>
               </a:ext>
             </a:extLst>
           </p:cNvPr>
@@ -3358,7 +3358,7 @@
           <p:cNvPr id="3" name="">
             <a:extLst xmlns:a="http://schemas.openxmlformats.org/drawingml/2006/main">
               <a:ext uri="{FF2B5EF4-FFF2-40B4-BE49-F238E27FC236}">
-                <a16:creationId xmlns:a16="http://schemas.microsoft.com/office/drawing/2014/main" id="{FA85DE3E-CC40-4CD3-B3BF-FA8DE3C10894}"/>
+                <a16:creationId xmlns:a16="http://schemas.microsoft.com/office/drawing/2014/main" id="{07F3327C-3BA0-4B55-A706-0CC010DA1D31}"/>
               </a:ext>
             </a:extLst>
           </p:cNvPr>
@@ -3408,7 +3408,7 @@
           <p:cNvPr id="4" name="">
             <a:extLst xmlns:a="http://schemas.openxmlformats.org/drawingml/2006/main">
               <a:ext uri="{FF2B5EF4-FFF2-40B4-BE49-F238E27FC236}">
-                <a16:creationId xmlns:a16="http://schemas.microsoft.com/office/drawing/2014/main" id="{5FCAC0A7-1B68-48A7-9509-FF74077C61B7}"/>
+                <a16:creationId xmlns:a16="http://schemas.microsoft.com/office/drawing/2014/main" id="{B1F9B3E4-6AC8-4247-902E-F26AAD63226A}"/>
               </a:ext>
             </a:extLst>
           </p:cNvPr>
@@ -3439,7 +3439,7 @@
           <p:cNvPr id="5" name="">
             <a:extLst xmlns:a="http://schemas.openxmlformats.org/drawingml/2006/main">
               <a:ext uri="{FF2B5EF4-FFF2-40B4-BE49-F238E27FC236}">
-                <a16:creationId xmlns:a16="http://schemas.microsoft.com/office/drawing/2014/main" id="{5FD100F2-9F19-424A-BC00-87521C69F1E1}"/>
+                <a16:creationId xmlns:a16="http://schemas.microsoft.com/office/drawing/2014/main" id="{6F09FB64-5AEB-4570-AF9B-A922B0B7A7BD}"/>
               </a:ext>
             </a:extLst>
           </p:cNvPr>
@@ -3489,7 +3489,7 @@
           <p:cNvPr id="6" name="">
             <a:extLst xmlns:a="http://schemas.openxmlformats.org/drawingml/2006/main">
               <a:ext uri="{FF2B5EF4-FFF2-40B4-BE49-F238E27FC236}">
-                <a16:creationId xmlns:a16="http://schemas.microsoft.com/office/drawing/2014/main" id="{95B13D45-3C38-4116-AE8B-096AA0A49138}"/>
+                <a16:creationId xmlns:a16="http://schemas.microsoft.com/office/drawing/2014/main" id="{102FB240-54EB-4F53-A43B-3A4D4902F181}"/>
               </a:ext>
             </a:extLst>
           </p:cNvPr>
@@ -3526,7 +3526,7 @@
           <p:cNvPr id="7" name="">
             <a:extLst xmlns:a="http://schemas.openxmlformats.org/drawingml/2006/main">
               <a:ext uri="{FF2B5EF4-FFF2-40B4-BE49-F238E27FC236}">
-                <a16:creationId xmlns:a16="http://schemas.microsoft.com/office/drawing/2014/main" id="{A6025796-ABE7-45F0-B436-CFEB0D19720E}"/>
+                <a16:creationId xmlns:a16="http://schemas.microsoft.com/office/drawing/2014/main" id="{B73C371C-F034-42FA-9CAC-2DD80F1E8E6F}"/>
               </a:ext>
             </a:extLst>
           </p:cNvPr>
@@ -3576,7 +3576,7 @@
           <p:cNvPr id="8" name="">
             <a:extLst xmlns:a="http://schemas.openxmlformats.org/drawingml/2006/main">
               <a:ext uri="{FF2B5EF4-FFF2-40B4-BE49-F238E27FC236}">
-                <a16:creationId xmlns:a16="http://schemas.microsoft.com/office/drawing/2014/main" id="{DA60A31C-5FCC-48F6-9054-22EBD5F687CF}"/>
+                <a16:creationId xmlns:a16="http://schemas.microsoft.com/office/drawing/2014/main" id="{0C56F257-E316-486C-90F2-0653243E0E88}"/>
               </a:ext>
             </a:extLst>
           </p:cNvPr>
@@ -3626,7 +3626,7 @@
           <p:cNvPr id="9" name="">
             <a:extLst xmlns:a="http://schemas.openxmlformats.org/drawingml/2006/main">
               <a:ext uri="{FF2B5EF4-FFF2-40B4-BE49-F238E27FC236}">
-                <a16:creationId xmlns:a16="http://schemas.microsoft.com/office/drawing/2014/main" id="{7BDD317E-7712-453B-9376-7159D8EE8DE8}"/>
+                <a16:creationId xmlns:a16="http://schemas.microsoft.com/office/drawing/2014/main" id="{9ABA888D-BF19-4FCC-92C9-11A9674B3A2D}"/>
               </a:ext>
             </a:extLst>
           </p:cNvPr>
@@ -3663,7 +3663,7 @@
           <p:cNvPr id="10" name="">
             <a:extLst xmlns:a="http://schemas.openxmlformats.org/drawingml/2006/main">
               <a:ext uri="{FF2B5EF4-FFF2-40B4-BE49-F238E27FC236}">
-                <a16:creationId xmlns:a16="http://schemas.microsoft.com/office/drawing/2014/main" id="{62F5A64D-AEE3-47EB-8863-A00326BA3A8F}"/>
+                <a16:creationId xmlns:a16="http://schemas.microsoft.com/office/drawing/2014/main" id="{1659277D-D4B0-4FB8-BAEE-8DF6C920C197}"/>
               </a:ext>
             </a:extLst>
           </p:cNvPr>
@@ -3713,7 +3713,7 @@
           <p:cNvPr id="11" name="">
             <a:extLst xmlns:a="http://schemas.openxmlformats.org/drawingml/2006/main">
               <a:ext uri="{FF2B5EF4-FFF2-40B4-BE49-F238E27FC236}">
-                <a16:creationId xmlns:a16="http://schemas.microsoft.com/office/drawing/2014/main" id="{0F585EF4-1967-492B-9421-6D9E4D751BD9}"/>
+                <a16:creationId xmlns:a16="http://schemas.microsoft.com/office/drawing/2014/main" id="{EFB5AB5E-92BF-41E5-B73E-01E3F0F6D615}"/>
               </a:ext>
             </a:extLst>
           </p:cNvPr>
@@ -3763,7 +3763,7 @@
           <p:cNvPr id="12" name="">
             <a:extLst xmlns:a="http://schemas.openxmlformats.org/drawingml/2006/main">
               <a:ext uri="{FF2B5EF4-FFF2-40B4-BE49-F238E27FC236}">
-                <a16:creationId xmlns:a16="http://schemas.microsoft.com/office/drawing/2014/main" id="{4F978D32-3E81-4AC7-962F-B19E51BAC358}"/>
+                <a16:creationId xmlns:a16="http://schemas.microsoft.com/office/drawing/2014/main" id="{28AC9BD5-4AEA-4818-887C-264C0D1E860D}"/>
               </a:ext>
             </a:extLst>
           </p:cNvPr>
@@ -3800,7 +3800,7 @@
           <p:cNvPr id="13" name="">
             <a:extLst xmlns:a="http://schemas.openxmlformats.org/drawingml/2006/main">
               <a:ext uri="{FF2B5EF4-FFF2-40B4-BE49-F238E27FC236}">
-                <a16:creationId xmlns:a16="http://schemas.microsoft.com/office/drawing/2014/main" id="{88271D63-DCE1-47CB-80E9-D94597C7471B}"/>
+                <a16:creationId xmlns:a16="http://schemas.microsoft.com/office/drawing/2014/main" id="{E197CA6E-8F05-4309-AB32-A42FD2E2A457}"/>
               </a:ext>
             </a:extLst>
           </p:cNvPr>
@@ -3850,7 +3850,7 @@
           <p:cNvPr id="14" name="">
             <a:extLst xmlns:a="http://schemas.openxmlformats.org/drawingml/2006/main">
               <a:ext uri="{FF2B5EF4-FFF2-40B4-BE49-F238E27FC236}">
-                <a16:creationId xmlns:a16="http://schemas.microsoft.com/office/drawing/2014/main" id="{9C7B984A-DAB3-4F6B-99BE-DE968FC94978}"/>
+                <a16:creationId xmlns:a16="http://schemas.microsoft.com/office/drawing/2014/main" id="{6971F78C-E738-48D4-9133-7CAC943C8D6E}"/>
               </a:ext>
             </a:extLst>
           </p:cNvPr>
@@ -3900,7 +3900,7 @@
           <p:cNvPr id="15" name="">
             <a:extLst xmlns:a="http://schemas.openxmlformats.org/drawingml/2006/main">
               <a:ext uri="{FF2B5EF4-FFF2-40B4-BE49-F238E27FC236}">
-                <a16:creationId xmlns:a16="http://schemas.microsoft.com/office/drawing/2014/main" id="{364C26CE-B882-4C50-A23C-67E3E747A8DC}"/>
+                <a16:creationId xmlns:a16="http://schemas.microsoft.com/office/drawing/2014/main" id="{6086F9F8-5A20-4B4C-9BF9-EC74AC4BD6EF}"/>
               </a:ext>
             </a:extLst>
           </p:cNvPr>
@@ -3937,7 +3937,7 @@
           <p:cNvPr id="16" name="">
             <a:extLst xmlns:a="http://schemas.openxmlformats.org/drawingml/2006/main">
               <a:ext uri="{FF2B5EF4-FFF2-40B4-BE49-F238E27FC236}">
-                <a16:creationId xmlns:a16="http://schemas.microsoft.com/office/drawing/2014/main" id="{6B32A4E4-067B-4ADE-A118-BEE72EC5A160}"/>
+                <a16:creationId xmlns:a16="http://schemas.microsoft.com/office/drawing/2014/main" id="{0BD4CEAC-8DDE-4B5F-BFB3-6E1821FC4B5A}"/>
               </a:ext>
             </a:extLst>
           </p:cNvPr>
@@ -3987,7 +3987,7 @@
           <p:cNvPr id="17" name="">
             <a:extLst xmlns:a="http://schemas.openxmlformats.org/drawingml/2006/main">
               <a:ext uri="{FF2B5EF4-FFF2-40B4-BE49-F238E27FC236}">
-                <a16:creationId xmlns:a16="http://schemas.microsoft.com/office/drawing/2014/main" id="{B4C5BCD7-EC87-48CD-8210-1480D999B9D3}"/>
+                <a16:creationId xmlns:a16="http://schemas.microsoft.com/office/drawing/2014/main" id="{42B56846-E552-4A85-B1BB-274A7B193A07}"/>
               </a:ext>
             </a:extLst>
           </p:cNvPr>
@@ -4037,7 +4037,7 @@
           <p:cNvPr id="18" name="">
             <a:extLst xmlns:a="http://schemas.openxmlformats.org/drawingml/2006/main">
               <a:ext uri="{FF2B5EF4-FFF2-40B4-BE49-F238E27FC236}">
-                <a16:creationId xmlns:a16="http://schemas.microsoft.com/office/drawing/2014/main" id="{99FC352F-733D-46F3-8A77-D33A528B6F4E}"/>
+                <a16:creationId xmlns:a16="http://schemas.microsoft.com/office/drawing/2014/main" id="{06660057-8156-47D4-9EEB-440CAEBF54A4}"/>
               </a:ext>
             </a:extLst>
           </p:cNvPr>
@@ -4074,7 +4074,7 @@
           <p:cNvPr id="19" name="">
             <a:extLst xmlns:a="http://schemas.openxmlformats.org/drawingml/2006/main">
               <a:ext uri="{FF2B5EF4-FFF2-40B4-BE49-F238E27FC236}">
-                <a16:creationId xmlns:a16="http://schemas.microsoft.com/office/drawing/2014/main" id="{4F91F8A0-6865-474D-9BE3-52301981F9C8}"/>
+                <a16:creationId xmlns:a16="http://schemas.microsoft.com/office/drawing/2014/main" id="{13534E71-4FEB-45A2-9F9F-F2503C4FAB85}"/>
               </a:ext>
             </a:extLst>
           </p:cNvPr>
@@ -4124,7 +4124,7 @@
           <p:cNvPr id="20" name="">
             <a:extLst xmlns:a="http://schemas.openxmlformats.org/drawingml/2006/main">
               <a:ext uri="{FF2B5EF4-FFF2-40B4-BE49-F238E27FC236}">
-                <a16:creationId xmlns:a16="http://schemas.microsoft.com/office/drawing/2014/main" id="{F09E633D-C7FD-490C-92CE-D8934A2CC469}"/>
+                <a16:creationId xmlns:a16="http://schemas.microsoft.com/office/drawing/2014/main" id="{B178F9F2-B959-4BFE-B005-AC5A6A6C43AD}"/>
               </a:ext>
             </a:extLst>
           </p:cNvPr>
@@ -4172,7 +4172,7 @@
     </p:spTree>
     <p:extLst>
       <p:ext uri="{BB962C8B-B14F-4D97-AF65-F5344CB8AC3E}">
-        <p14:creationId xmlns:p14="http://schemas.microsoft.com/office/powerpoint/2010/main" val="1941672565"/>
+        <p14:creationId xmlns:p14="http://schemas.microsoft.com/office/powerpoint/2010/main" val="792222316"/>
       </p:ext>
     </p:extLst>
   </p:cSld>
@@ -4203,7 +4203,7 @@
           <p:cNvPr id="8" name="">
             <a:extLst xmlns:a="http://schemas.openxmlformats.org/drawingml/2006/main">
               <a:ext uri="{FF2B5EF4-FFF2-40B4-BE49-F238E27FC236}">
-                <a16:creationId xmlns:a16="http://schemas.microsoft.com/office/drawing/2014/main" id="{3448D259-DB64-4729-B8FD-6DB1F09153BA}"/>
+                <a16:creationId xmlns:a16="http://schemas.microsoft.com/office/drawing/2014/main" id="{4FE2E68C-A0B1-4169-B453-46DD63BA625A}"/>
               </a:ext>
             </a:extLst>
           </p:cNvPr>
@@ -4253,7 +4253,7 @@
           <p:cNvPr id="2" name="">
             <a:extLst xmlns:a="http://schemas.openxmlformats.org/drawingml/2006/main">
               <a:ext uri="{FF2B5EF4-FFF2-40B4-BE49-F238E27FC236}">
-                <a16:creationId xmlns:a16="http://schemas.microsoft.com/office/drawing/2014/main" id="{16DFB1E7-64AC-4024-8DE1-47FC370BE4CF}"/>
+                <a16:creationId xmlns:a16="http://schemas.microsoft.com/office/drawing/2014/main" id="{7AC51DD2-2701-46C9-8E40-E67C134AC1E1}"/>
               </a:ext>
             </a:extLst>
           </p:cNvPr>
@@ -4303,7 +4303,7 @@
           <p:cNvPr id="3" name="">
             <a:extLst xmlns:a="http://schemas.openxmlformats.org/drawingml/2006/main">
               <a:ext uri="{FF2B5EF4-FFF2-40B4-BE49-F238E27FC236}">
-                <a16:creationId xmlns:a16="http://schemas.microsoft.com/office/drawing/2014/main" id="{D0E1B415-4AE2-4335-9EB2-49FAB255DC10}"/>
+                <a16:creationId xmlns:a16="http://schemas.microsoft.com/office/drawing/2014/main" id="{FF656241-100A-4197-B917-BEB333096B46}"/>
               </a:ext>
             </a:extLst>
           </p:cNvPr>
@@ -4353,7 +4353,7 @@
           <p:cNvPr id="4" name="">
             <a:extLst xmlns:a="http://schemas.openxmlformats.org/drawingml/2006/main">
               <a:ext uri="{FF2B5EF4-FFF2-40B4-BE49-F238E27FC236}">
-                <a16:creationId xmlns:a16="http://schemas.microsoft.com/office/drawing/2014/main" id="{83AC19D3-CFF0-45FA-9B17-05430514472A}"/>
+                <a16:creationId xmlns:a16="http://schemas.microsoft.com/office/drawing/2014/main" id="{B58C8DC3-A5E3-47DE-B33E-C53AB0DA5A13}"/>
               </a:ext>
             </a:extLst>
           </p:cNvPr>
@@ -4384,7 +4384,7 @@
           <p:cNvPr id="5" name="">
             <a:extLst xmlns:a="http://schemas.openxmlformats.org/drawingml/2006/main">
               <a:ext uri="{FF2B5EF4-FFF2-40B4-BE49-F238E27FC236}">
-                <a16:creationId xmlns:a16="http://schemas.microsoft.com/office/drawing/2014/main" id="{D18993DE-E0CD-487C-ACFB-32C2E7F382D6}"/>
+                <a16:creationId xmlns:a16="http://schemas.microsoft.com/office/drawing/2014/main" id="{37317916-0DCF-4D92-BE09-DC70CACC0672}"/>
               </a:ext>
             </a:extLst>
           </p:cNvPr>
@@ -4419,7 +4419,7 @@
           <p:cNvPr id="6" name="">
             <a:extLst xmlns:a="http://schemas.openxmlformats.org/drawingml/2006/main">
               <a:ext uri="{FF2B5EF4-FFF2-40B4-BE49-F238E27FC236}">
-                <a16:creationId xmlns:a16="http://schemas.microsoft.com/office/drawing/2014/main" id="{EF38B81F-467B-414D-9AE7-60F5F12F0550}"/>
+                <a16:creationId xmlns:a16="http://schemas.microsoft.com/office/drawing/2014/main" id="{00EFA389-9C18-40A1-B53C-9561B49B7141}"/>
               </a:ext>
             </a:extLst>
           </p:cNvPr>
@@ -4469,7 +4469,7 @@
           <p:cNvPr id="7" name="">
             <a:extLst xmlns:a="http://schemas.openxmlformats.org/drawingml/2006/main">
               <a:ext uri="{FF2B5EF4-FFF2-40B4-BE49-F238E27FC236}">
-                <a16:creationId xmlns:a16="http://schemas.microsoft.com/office/drawing/2014/main" id="{AE58E023-A89E-4792-B508-965F0288A049}"/>
+                <a16:creationId xmlns:a16="http://schemas.microsoft.com/office/drawing/2014/main" id="{CA236637-956C-4504-85E4-F466C485C16F}"/>
               </a:ext>
             </a:extLst>
           </p:cNvPr>
@@ -4517,7 +4517,7 @@
     </p:spTree>
     <p:extLst>
       <p:ext uri="{BB962C8B-B14F-4D97-AF65-F5344CB8AC3E}">
-        <p14:creationId xmlns:p14="http://schemas.microsoft.com/office/powerpoint/2010/main" val="379100227"/>
+        <p14:creationId xmlns:p14="http://schemas.microsoft.com/office/powerpoint/2010/main" val="400046977"/>
       </p:ext>
     </p:extLst>
   </p:cSld>
@@ -4548,7 +4548,7 @@
           <p:cNvPr id="14" name="">
             <a:extLst xmlns:a="http://schemas.openxmlformats.org/drawingml/2006/main">
               <a:ext uri="{FF2B5EF4-FFF2-40B4-BE49-F238E27FC236}">
-                <a16:creationId xmlns:a16="http://schemas.microsoft.com/office/drawing/2014/main" id="{3D11CC6D-47D6-4365-B79F-47C32EE1076E}"/>
+                <a16:creationId xmlns:a16="http://schemas.microsoft.com/office/drawing/2014/main" id="{32BB0D2D-0B57-4035-84DA-9273CE92C846}"/>
               </a:ext>
             </a:extLst>
           </p:cNvPr>
@@ -4598,7 +4598,7 @@
           <p:cNvPr id="2" name="">
             <a:extLst xmlns:a="http://schemas.openxmlformats.org/drawingml/2006/main">
               <a:ext uri="{FF2B5EF4-FFF2-40B4-BE49-F238E27FC236}">
-                <a16:creationId xmlns:a16="http://schemas.microsoft.com/office/drawing/2014/main" id="{D60BB5DF-02F4-4722-A78D-B369B5F2CB6B}"/>
+                <a16:creationId xmlns:a16="http://schemas.microsoft.com/office/drawing/2014/main" id="{EC9642D8-76AE-4419-8C7F-D36814803E2C}"/>
               </a:ext>
             </a:extLst>
           </p:cNvPr>
@@ -4648,7 +4648,7 @@
           <p:cNvPr id="3" name="">
             <a:extLst xmlns:a="http://schemas.openxmlformats.org/drawingml/2006/main">
               <a:ext uri="{FF2B5EF4-FFF2-40B4-BE49-F238E27FC236}">
-                <a16:creationId xmlns:a16="http://schemas.microsoft.com/office/drawing/2014/main" id="{8AC44379-080B-403C-8603-CD5CB8AB6DC1}"/>
+                <a16:creationId xmlns:a16="http://schemas.microsoft.com/office/drawing/2014/main" id="{509CCCA1-0BCE-4EBE-98BB-120552013B62}"/>
               </a:ext>
             </a:extLst>
           </p:cNvPr>
@@ -4698,7 +4698,7 @@
           <p:cNvPr id="4" name="">
             <a:extLst xmlns:a="http://schemas.openxmlformats.org/drawingml/2006/main">
               <a:ext uri="{FF2B5EF4-FFF2-40B4-BE49-F238E27FC236}">
-                <a16:creationId xmlns:a16="http://schemas.microsoft.com/office/drawing/2014/main" id="{9A8DD21A-E8EC-4AB7-A351-238B0B5CDB39}"/>
+                <a16:creationId xmlns:a16="http://schemas.microsoft.com/office/drawing/2014/main" id="{B6120DFE-69AE-461C-83F1-5930412A2D4D}"/>
               </a:ext>
             </a:extLst>
           </p:cNvPr>
@@ -4729,7 +4729,7 @@
           <p:cNvPr id="5" name="">
             <a:extLst xmlns:a="http://schemas.openxmlformats.org/drawingml/2006/main">
               <a:ext uri="{FF2B5EF4-FFF2-40B4-BE49-F238E27FC236}">
-                <a16:creationId xmlns:a16="http://schemas.microsoft.com/office/drawing/2014/main" id="{21FE09C6-0100-4A9E-B776-8ECAB6371926}"/>
+                <a16:creationId xmlns:a16="http://schemas.microsoft.com/office/drawing/2014/main" id="{79B080BB-734A-411F-834C-AE9E5310F022}"/>
               </a:ext>
             </a:extLst>
           </p:cNvPr>
@@ -4779,7 +4779,7 @@
           <p:cNvPr id="6" name="">
             <a:extLst xmlns:a="http://schemas.openxmlformats.org/drawingml/2006/main">
               <a:ext uri="{FF2B5EF4-FFF2-40B4-BE49-F238E27FC236}">
-                <a16:creationId xmlns:a16="http://schemas.microsoft.com/office/drawing/2014/main" id="{DAD8E028-CE3F-473D-96E9-5830AAE10F14}"/>
+                <a16:creationId xmlns:a16="http://schemas.microsoft.com/office/drawing/2014/main" id="{C2660902-4673-4049-A149-817CEEB5AB5F}"/>
               </a:ext>
             </a:extLst>
           </p:cNvPr>
@@ -4814,7 +4814,7 @@
           <p:cNvPr id="7" name="">
             <a:extLst xmlns:a="http://schemas.openxmlformats.org/drawingml/2006/main">
               <a:ext uri="{FF2B5EF4-FFF2-40B4-BE49-F238E27FC236}">
-                <a16:creationId xmlns:a16="http://schemas.microsoft.com/office/drawing/2014/main" id="{DCB12099-C7F3-49C1-A176-063CC5C32A76}"/>
+                <a16:creationId xmlns:a16="http://schemas.microsoft.com/office/drawing/2014/main" id="{055A31B9-A7A1-4850-B11C-DCC6CAD652A0}"/>
               </a:ext>
             </a:extLst>
           </p:cNvPr>
@@ -4864,7 +4864,7 @@
           <p:cNvPr id="8" name="">
             <a:extLst xmlns:a="http://schemas.openxmlformats.org/drawingml/2006/main">
               <a:ext uri="{FF2B5EF4-FFF2-40B4-BE49-F238E27FC236}">
-                <a16:creationId xmlns:a16="http://schemas.microsoft.com/office/drawing/2014/main" id="{F0CFB449-8143-4819-A309-6219A92508D6}"/>
+                <a16:creationId xmlns:a16="http://schemas.microsoft.com/office/drawing/2014/main" id="{2AE7EBEE-092B-4539-B0E5-2D5E0380A6F8}"/>
               </a:ext>
             </a:extLst>
           </p:cNvPr>
@@ -4901,7 +4901,7 @@
           <p:cNvPr id="9" name="">
             <a:extLst xmlns:a="http://schemas.openxmlformats.org/drawingml/2006/main">
               <a:ext uri="{FF2B5EF4-FFF2-40B4-BE49-F238E27FC236}">
-                <a16:creationId xmlns:a16="http://schemas.microsoft.com/office/drawing/2014/main" id="{52422EA1-248F-48F2-8D35-04A4BA7BA0BD}"/>
+                <a16:creationId xmlns:a16="http://schemas.microsoft.com/office/drawing/2014/main" id="{74060F69-F4EE-49C7-984A-A00D53BD1B7B}"/>
               </a:ext>
             </a:extLst>
           </p:cNvPr>
@@ -4951,7 +4951,7 @@
           <p:cNvPr id="10" name="">
             <a:extLst xmlns:a="http://schemas.openxmlformats.org/drawingml/2006/main">
               <a:ext uri="{FF2B5EF4-FFF2-40B4-BE49-F238E27FC236}">
-                <a16:creationId xmlns:a16="http://schemas.microsoft.com/office/drawing/2014/main" id="{D15C12D7-2687-432F-8108-30BC097F1DB4}"/>
+                <a16:creationId xmlns:a16="http://schemas.microsoft.com/office/drawing/2014/main" id="{EEE19CEB-3729-4484-9E59-F5A09F686FB5}"/>
               </a:ext>
             </a:extLst>
           </p:cNvPr>
@@ -5001,7 +5001,7 @@
           <p:cNvPr id="11" name="">
             <a:extLst xmlns:a="http://schemas.openxmlformats.org/drawingml/2006/main">
               <a:ext uri="{FF2B5EF4-FFF2-40B4-BE49-F238E27FC236}">
-                <a16:creationId xmlns:a16="http://schemas.microsoft.com/office/drawing/2014/main" id="{8613042C-741B-4B47-9418-FBCB39F735D1}"/>
+                <a16:creationId xmlns:a16="http://schemas.microsoft.com/office/drawing/2014/main" id="{F539674C-C79E-44E6-A834-D7F965A93554}"/>
               </a:ext>
             </a:extLst>
           </p:cNvPr>
@@ -5051,7 +5051,7 @@
           <p:cNvPr id="12" name="">
             <a:extLst xmlns:a="http://schemas.openxmlformats.org/drawingml/2006/main">
               <a:ext uri="{FF2B5EF4-FFF2-40B4-BE49-F238E27FC236}">
-                <a16:creationId xmlns:a16="http://schemas.microsoft.com/office/drawing/2014/main" id="{BA457FAB-EAAD-40D0-9F43-BE219E4704B5}"/>
+                <a16:creationId xmlns:a16="http://schemas.microsoft.com/office/drawing/2014/main" id="{618322BB-3FB5-4D25-AF01-886F615D8897}"/>
               </a:ext>
             </a:extLst>
           </p:cNvPr>
@@ -5101,7 +5101,7 @@
           <p:cNvPr id="13" name="">
             <a:extLst xmlns:a="http://schemas.openxmlformats.org/drawingml/2006/main">
               <a:ext uri="{FF2B5EF4-FFF2-40B4-BE49-F238E27FC236}">
-                <a16:creationId xmlns:a16="http://schemas.microsoft.com/office/drawing/2014/main" id="{2337862E-6248-4BFA-9B2A-A14FB43AF715}"/>
+                <a16:creationId xmlns:a16="http://schemas.microsoft.com/office/drawing/2014/main" id="{C6CDE18F-3ABC-4A2C-9D50-D428854B6080}"/>
               </a:ext>
             </a:extLst>
           </p:cNvPr>
@@ -5149,7 +5149,7 @@
     </p:spTree>
     <p:extLst>
       <p:ext uri="{BB962C8B-B14F-4D97-AF65-F5344CB8AC3E}">
-        <p14:creationId xmlns:p14="http://schemas.microsoft.com/office/powerpoint/2010/main" val="1331215700"/>
+        <p14:creationId xmlns:p14="http://schemas.microsoft.com/office/powerpoint/2010/main" val="1126377463"/>
       </p:ext>
     </p:extLst>
   </p:cSld>
@@ -5180,7 +5180,7 @@
           <p:cNvPr id="16" name="">
             <a:extLst xmlns:a="http://schemas.openxmlformats.org/drawingml/2006/main">
               <a:ext uri="{FF2B5EF4-FFF2-40B4-BE49-F238E27FC236}">
-                <a16:creationId xmlns:a16="http://schemas.microsoft.com/office/drawing/2014/main" id="{83A1C6D4-621C-486E-813D-BC5F06838827}"/>
+                <a16:creationId xmlns:a16="http://schemas.microsoft.com/office/drawing/2014/main" id="{30FECDDC-26D0-4F37-A3E1-3841616C95C4}"/>
               </a:ext>
             </a:extLst>
           </p:cNvPr>
@@ -5230,7 +5230,7 @@
           <p:cNvPr id="2" name="">
             <a:extLst xmlns:a="http://schemas.openxmlformats.org/drawingml/2006/main">
               <a:ext uri="{FF2B5EF4-FFF2-40B4-BE49-F238E27FC236}">
-                <a16:creationId xmlns:a16="http://schemas.microsoft.com/office/drawing/2014/main" id="{1A9165C3-20CC-442C-BD5E-2429867BA82A}"/>
+                <a16:creationId xmlns:a16="http://schemas.microsoft.com/office/drawing/2014/main" id="{D99E4711-9E96-4099-97E5-ECB92FC385FA}"/>
               </a:ext>
             </a:extLst>
           </p:cNvPr>
@@ -5280,7 +5280,7 @@
           <p:cNvPr id="3" name="">
             <a:extLst xmlns:a="http://schemas.openxmlformats.org/drawingml/2006/main">
               <a:ext uri="{FF2B5EF4-FFF2-40B4-BE49-F238E27FC236}">
-                <a16:creationId xmlns:a16="http://schemas.microsoft.com/office/drawing/2014/main" id="{A465C13C-33B8-4667-8411-505FF5E47675}"/>
+                <a16:creationId xmlns:a16="http://schemas.microsoft.com/office/drawing/2014/main" id="{6E29146F-D3CA-41F7-9955-8788BF19020E}"/>
               </a:ext>
             </a:extLst>
           </p:cNvPr>
@@ -5330,7 +5330,7 @@
           <p:cNvPr id="4" name="">
             <a:extLst xmlns:a="http://schemas.openxmlformats.org/drawingml/2006/main">
               <a:ext uri="{FF2B5EF4-FFF2-40B4-BE49-F238E27FC236}">
-                <a16:creationId xmlns:a16="http://schemas.microsoft.com/office/drawing/2014/main" id="{EE124F9F-130A-477D-AEC5-83AC3BB64A44}"/>
+                <a16:creationId xmlns:a16="http://schemas.microsoft.com/office/drawing/2014/main" id="{8AA9F7A3-4054-4A28-94C9-91F3BF883505}"/>
               </a:ext>
             </a:extLst>
           </p:cNvPr>
@@ -5361,7 +5361,7 @@
           <p:cNvPr id="5" name="">
             <a:extLst xmlns:a="http://schemas.openxmlformats.org/drawingml/2006/main">
               <a:ext uri="{FF2B5EF4-FFF2-40B4-BE49-F238E27FC236}">
-                <a16:creationId xmlns:a16="http://schemas.microsoft.com/office/drawing/2014/main" id="{E2E8939F-2D6A-4264-96F0-A6C1CA444C86}"/>
+                <a16:creationId xmlns:a16="http://schemas.microsoft.com/office/drawing/2014/main" id="{79D914D5-5B2B-40AE-BEE3-BF23F0D75503}"/>
               </a:ext>
             </a:extLst>
           </p:cNvPr>
@@ -5411,7 +5411,7 @@
           <p:cNvPr id="6" name="">
             <a:extLst xmlns:a="http://schemas.openxmlformats.org/drawingml/2006/main">
               <a:ext uri="{FF2B5EF4-FFF2-40B4-BE49-F238E27FC236}">
-                <a16:creationId xmlns:a16="http://schemas.microsoft.com/office/drawing/2014/main" id="{F8B097F2-AF62-4468-8787-E7BF26E1EF4B}"/>
+                <a16:creationId xmlns:a16="http://schemas.microsoft.com/office/drawing/2014/main" id="{66A28514-3B66-432F-98E1-A3639707E2D5}"/>
               </a:ext>
             </a:extLst>
           </p:cNvPr>
@@ -5461,7 +5461,7 @@
           <p:cNvPr id="7" name="">
             <a:extLst xmlns:a="http://schemas.openxmlformats.org/drawingml/2006/main">
               <a:ext uri="{FF2B5EF4-FFF2-40B4-BE49-F238E27FC236}">
-                <a16:creationId xmlns:a16="http://schemas.microsoft.com/office/drawing/2014/main" id="{E951CCA3-F37E-40D6-8E99-E62B687DA648}"/>
+                <a16:creationId xmlns:a16="http://schemas.microsoft.com/office/drawing/2014/main" id="{922D2643-F9EA-401A-976D-F9ED1A7393EF}"/>
               </a:ext>
             </a:extLst>
           </p:cNvPr>
@@ -5492,7 +5492,7 @@
           <p:cNvPr id="8" name="">
             <a:extLst xmlns:a="http://schemas.openxmlformats.org/drawingml/2006/main">
               <a:ext uri="{FF2B5EF4-FFF2-40B4-BE49-F238E27FC236}">
-                <a16:creationId xmlns:a16="http://schemas.microsoft.com/office/drawing/2014/main" id="{963FE64D-51A2-4138-811F-CD2E780EC3ED}"/>
+                <a16:creationId xmlns:a16="http://schemas.microsoft.com/office/drawing/2014/main" id="{F01D8017-E0F1-4588-ADDB-45503FB3746C}"/>
               </a:ext>
             </a:extLst>
           </p:cNvPr>
@@ -5542,7 +5542,7 @@
           <p:cNvPr id="9" name="">
             <a:extLst xmlns:a="http://schemas.openxmlformats.org/drawingml/2006/main">
               <a:ext uri="{FF2B5EF4-FFF2-40B4-BE49-F238E27FC236}">
-                <a16:creationId xmlns:a16="http://schemas.microsoft.com/office/drawing/2014/main" id="{699AA7DD-EFD3-4B80-A4A0-D5C0D49519A8}"/>
+                <a16:creationId xmlns:a16="http://schemas.microsoft.com/office/drawing/2014/main" id="{E0E97376-AE9A-4B2E-B783-9923BBF68376}"/>
               </a:ext>
             </a:extLst>
           </p:cNvPr>
@@ -5573,7 +5573,7 @@
           <p:cNvPr id="10" name="">
             <a:extLst xmlns:a="http://schemas.openxmlformats.org/drawingml/2006/main">
               <a:ext uri="{FF2B5EF4-FFF2-40B4-BE49-F238E27FC236}">
-                <a16:creationId xmlns:a16="http://schemas.microsoft.com/office/drawing/2014/main" id="{98A5BAE6-E1DF-4902-ABBA-1E461972A8A8}"/>
+                <a16:creationId xmlns:a16="http://schemas.microsoft.com/office/drawing/2014/main" id="{D45BBEE7-0B55-4114-A217-F50A209461D0}"/>
               </a:ext>
             </a:extLst>
           </p:cNvPr>
@@ -5623,7 +5623,7 @@
           <p:cNvPr id="11" name="">
             <a:extLst xmlns:a="http://schemas.openxmlformats.org/drawingml/2006/main">
               <a:ext uri="{FF2B5EF4-FFF2-40B4-BE49-F238E27FC236}">
-                <a16:creationId xmlns:a16="http://schemas.microsoft.com/office/drawing/2014/main" id="{25449C5C-B325-49B2-9B5B-C04B44FE72FC}"/>
+                <a16:creationId xmlns:a16="http://schemas.microsoft.com/office/drawing/2014/main" id="{8CF00702-B7FA-4D13-AE2D-867AC7DCB96B}"/>
               </a:ext>
             </a:extLst>
           </p:cNvPr>
@@ -5654,7 +5654,7 @@
           <p:cNvPr id="12" name="">
             <a:extLst xmlns:a="http://schemas.openxmlformats.org/drawingml/2006/main">
               <a:ext uri="{FF2B5EF4-FFF2-40B4-BE49-F238E27FC236}">
-                <a16:creationId xmlns:a16="http://schemas.microsoft.com/office/drawing/2014/main" id="{972FEA68-4B2A-47BF-B333-6B82C266037A}"/>
+                <a16:creationId xmlns:a16="http://schemas.microsoft.com/office/drawing/2014/main" id="{907D5101-B8A7-4769-884B-7FB87BFE5976}"/>
               </a:ext>
             </a:extLst>
           </p:cNvPr>
@@ -5704,7 +5704,7 @@
           <p:cNvPr id="13" name="">
             <a:extLst xmlns:a="http://schemas.openxmlformats.org/drawingml/2006/main">
               <a:ext uri="{FF2B5EF4-FFF2-40B4-BE49-F238E27FC236}">
-                <a16:creationId xmlns:a16="http://schemas.microsoft.com/office/drawing/2014/main" id="{8F23FECA-3C56-4279-B499-FAE14EDB215B}"/>
+                <a16:creationId xmlns:a16="http://schemas.microsoft.com/office/drawing/2014/main" id="{B8F522D3-E272-45A8-84E1-405D1BAD3A2C}"/>
               </a:ext>
             </a:extLst>
           </p:cNvPr>
@@ -5735,7 +5735,7 @@
           <p:cNvPr id="14" name="">
             <a:extLst xmlns:a="http://schemas.openxmlformats.org/drawingml/2006/main">
               <a:ext uri="{FF2B5EF4-FFF2-40B4-BE49-F238E27FC236}">
-                <a16:creationId xmlns:a16="http://schemas.microsoft.com/office/drawing/2014/main" id="{87E1F2C3-4EF2-4FC3-8C68-CC185E98ADB7}"/>
+                <a16:creationId xmlns:a16="http://schemas.microsoft.com/office/drawing/2014/main" id="{6DD87FD3-D98C-4D12-AAAC-247B020DCB06}"/>
               </a:ext>
             </a:extLst>
           </p:cNvPr>
@@ -5785,7 +5785,7 @@
           <p:cNvPr id="15" name="">
             <a:extLst xmlns:a="http://schemas.openxmlformats.org/drawingml/2006/main">
               <a:ext uri="{FF2B5EF4-FFF2-40B4-BE49-F238E27FC236}">
-                <a16:creationId xmlns:a16="http://schemas.microsoft.com/office/drawing/2014/main" id="{F6D39181-B905-494E-AF4C-EDE45F47AAE0}"/>
+                <a16:creationId xmlns:a16="http://schemas.microsoft.com/office/drawing/2014/main" id="{064488CA-19E3-4F82-AD5B-88E99C8D9BD9}"/>
               </a:ext>
             </a:extLst>
           </p:cNvPr>
@@ -5814,7 +5814,7 @@
     </p:spTree>
     <p:extLst>
       <p:ext uri="{BB962C8B-B14F-4D97-AF65-F5344CB8AC3E}">
-        <p14:creationId xmlns:p14="http://schemas.microsoft.com/office/powerpoint/2010/main" val="30325168"/>
+        <p14:creationId xmlns:p14="http://schemas.microsoft.com/office/powerpoint/2010/main" val="1608800789"/>
       </p:ext>
     </p:extLst>
   </p:cSld>
@@ -5842,10 +5842,10 @@
       </p:grpSpPr>
       <p:sp>
         <p:nvSpPr>
-          <p:cNvPr id="9" name="">
-            <a:extLst xmlns:a="http://schemas.openxmlformats.org/drawingml/2006/main">
-              <a:ext uri="{FF2B5EF4-FFF2-40B4-BE49-F238E27FC236}">
-                <a16:creationId xmlns:a16="http://schemas.microsoft.com/office/drawing/2014/main" id="{AD9F45C1-D71E-4D19-95DF-2C9BBCAF9C0A}"/>
+          <p:cNvPr id="19" name="">
+            <a:extLst xmlns:a="http://schemas.openxmlformats.org/drawingml/2006/main">
+              <a:ext uri="{FF2B5EF4-FFF2-40B4-BE49-F238E27FC236}">
+                <a16:creationId xmlns:a16="http://schemas.microsoft.com/office/drawing/2014/main" id="{88C70BAA-8170-4B23-88F1-3535E31F5AF1}"/>
               </a:ext>
             </a:extLst>
           </p:cNvPr>
@@ -5895,7 +5895,7 @@
           <p:cNvPr id="2" name="">
             <a:extLst xmlns:a="http://schemas.openxmlformats.org/drawingml/2006/main">
               <a:ext uri="{FF2B5EF4-FFF2-40B4-BE49-F238E27FC236}">
-                <a16:creationId xmlns:a16="http://schemas.microsoft.com/office/drawing/2014/main" id="{5CCE9256-9766-4237-84C3-2C210A919776}"/>
+                <a16:creationId xmlns:a16="http://schemas.microsoft.com/office/drawing/2014/main" id="{9DD36D68-B1D6-4CAC-AF74-D4D70DD68F39}"/>
               </a:ext>
             </a:extLst>
           </p:cNvPr>
@@ -5945,7 +5945,7 @@
           <p:cNvPr id="3" name="">
             <a:extLst xmlns:a="http://schemas.openxmlformats.org/drawingml/2006/main">
               <a:ext uri="{FF2B5EF4-FFF2-40B4-BE49-F238E27FC236}">
-                <a16:creationId xmlns:a16="http://schemas.microsoft.com/office/drawing/2014/main" id="{7457D947-A882-4503-9D92-FB7CFCB685B1}"/>
+                <a16:creationId xmlns:a16="http://schemas.microsoft.com/office/drawing/2014/main" id="{2E4EA899-025D-4506-B139-CD09AFEC5850}"/>
               </a:ext>
             </a:extLst>
           </p:cNvPr>
@@ -5995,7 +5995,7 @@
           <p:cNvPr id="4" name="">
             <a:extLst xmlns:a="http://schemas.openxmlformats.org/drawingml/2006/main">
               <a:ext uri="{FF2B5EF4-FFF2-40B4-BE49-F238E27FC236}">
-                <a16:creationId xmlns:a16="http://schemas.microsoft.com/office/drawing/2014/main" id="{A24ADDBA-02AD-4967-B3E9-F3D08E924800}"/>
+                <a16:creationId xmlns:a16="http://schemas.microsoft.com/office/drawing/2014/main" id="{CD844A95-644D-49C5-9F72-0B41B90D3F1D}"/>
               </a:ext>
             </a:extLst>
           </p:cNvPr>
@@ -6026,19 +6026,19 @@
           <p:cNvPr id="5" name="">
             <a:extLst xmlns:a="http://schemas.openxmlformats.org/drawingml/2006/main">
               <a:ext uri="{FF2B5EF4-FFF2-40B4-BE49-F238E27FC236}">
-                <a16:creationId xmlns:a16="http://schemas.microsoft.com/office/drawing/2014/main" id="{96186566-C43F-4DA6-9996-D8371D0B9F2D}"/>
-              </a:ext>
-            </a:extLst>
-          </p:cNvPr>
-          <p:cNvSpPr>
-            <a:spLocks xmlns:a="http://schemas.openxmlformats.org/drawingml/2006/main" noGrp="1"/>
-          </p:cNvSpPr>
-          <p:nvPr/>
-        </p:nvSpPr>
-        <p:spPr>
-          <a:xfrm xmlns:a="http://schemas.openxmlformats.org/drawingml/2006/main">
-            <a:off x="609600" y="1809750"/>
-            <a:ext cx="9525000" cy="762000"/>
+                <a16:creationId xmlns:a16="http://schemas.microsoft.com/office/drawing/2014/main" id="{B5FA37C5-972A-4F71-9494-535663F49EF4}"/>
+              </a:ext>
+            </a:extLst>
+          </p:cNvPr>
+          <p:cNvSpPr>
+            <a:spLocks xmlns:a="http://schemas.openxmlformats.org/drawingml/2006/main" noGrp="1"/>
+          </p:cNvSpPr>
+          <p:nvPr/>
+        </p:nvSpPr>
+        <p:spPr>
+          <a:xfrm xmlns:a="http://schemas.openxmlformats.org/drawingml/2006/main">
+            <a:off x="609600" y="1714500"/>
+            <a:ext cx="10477500" cy="523875"/>
           </a:xfrm>
           <a:prstGeom xmlns:a="http://schemas.openxmlformats.org/drawingml/2006/main" prst="rect">
             <a:avLst/>
@@ -6066,7 +6066,7 @@
                   <a:srgbClr val="111827"/>
                 </a:solidFill>
               </a:rPr>
-              <a:t>今天不是把工具玩過一次，而是留下可重複使用的流程。</a:t>
+              <a:t>遊戲化簡報的核心，是把教材變成一條學習路徑。</a:t>
             </a:r>
           </a:p>
         </p:txBody>
@@ -6076,19 +6076,19 @@
           <p:cNvPr id="6" name="">
             <a:extLst xmlns:a="http://schemas.openxmlformats.org/drawingml/2006/main">
               <a:ext uri="{FF2B5EF4-FFF2-40B4-BE49-F238E27FC236}">
-                <a16:creationId xmlns:a16="http://schemas.microsoft.com/office/drawing/2014/main" id="{C4399061-2D73-48E5-B922-FEEC99F6DC9B}"/>
-              </a:ext>
-            </a:extLst>
-          </p:cNvPr>
-          <p:cNvSpPr>
-            <a:spLocks xmlns:a="http://schemas.openxmlformats.org/drawingml/2006/main" noGrp="1"/>
-          </p:cNvSpPr>
-          <p:nvPr/>
-        </p:nvSpPr>
-        <p:spPr>
-          <a:xfrm xmlns:a="http://schemas.openxmlformats.org/drawingml/2006/main">
-            <a:off x="647700" y="3429000"/>
-            <a:ext cx="8572500" cy="476250"/>
+                <a16:creationId xmlns:a16="http://schemas.microsoft.com/office/drawing/2014/main" id="{32A5285B-25AB-4C26-9F66-25AD6775738E}"/>
+              </a:ext>
+            </a:extLst>
+          </p:cNvPr>
+          <p:cNvSpPr>
+            <a:spLocks xmlns:a="http://schemas.openxmlformats.org/drawingml/2006/main" noGrp="1"/>
+          </p:cNvSpPr>
+          <p:nvPr/>
+        </p:nvSpPr>
+        <p:spPr>
+          <a:xfrm xmlns:a="http://schemas.openxmlformats.org/drawingml/2006/main">
+            <a:off x="857250" y="2619375"/>
+            <a:ext cx="523875" cy="266700"/>
           </a:xfrm>
           <a:prstGeom xmlns:a="http://schemas.openxmlformats.org/drawingml/2006/main" prst="rect">
             <a:avLst/>
@@ -6104,19 +6104,19 @@
           <a:lstStyle xmlns:a="http://schemas.openxmlformats.org/drawingml/2006/main"/>
           <a:p xmlns:a="http://schemas.openxmlformats.org/drawingml/2006/main">
             <a:pPr>
-              <a:defRPr sz="1950" b="1">
+              <a:defRPr sz="1575" b="1">
                 <a:solidFill>
                   <a:srgbClr val="147D7E"/>
                 </a:solidFill>
               </a:defRPr>
             </a:pPr>
             <a:r>
-              <a:rPr sz="1950" b="1">
+              <a:rPr sz="1575" b="1">
                 <a:solidFill>
                   <a:srgbClr val="147D7E"/>
                 </a:solidFill>
               </a:rPr>
-              <a:t>下一步：把成果放進你的 AI 備課工具箱。</a:t>
+              <a:t>01</a:t>
             </a:r>
           </a:p>
         </p:txBody>
@@ -6126,31 +6126,77 @@
           <p:cNvPr id="7" name="">
             <a:extLst xmlns:a="http://schemas.openxmlformats.org/drawingml/2006/main">
               <a:ext uri="{FF2B5EF4-FFF2-40B4-BE49-F238E27FC236}">
-                <a16:creationId xmlns:a16="http://schemas.microsoft.com/office/drawing/2014/main" id="{894990AE-1BEE-4B32-B804-CDB90BFBC8FD}"/>
-              </a:ext>
-            </a:extLst>
-          </p:cNvPr>
-          <p:cNvSpPr>
-            <a:spLocks xmlns:a="http://schemas.openxmlformats.org/drawingml/2006/main" noGrp="1"/>
-          </p:cNvSpPr>
-          <p:nvPr/>
-        </p:nvSpPr>
-        <p:spPr>
-          <a:xfrm xmlns:a="http://schemas.openxmlformats.org/drawingml/2006/main">
-            <a:off x="8763000" y="1905000"/>
-            <a:ext cx="2095500" cy="2095500"/>
-          </a:xfrm>
-          <a:prstGeom xmlns:a="http://schemas.openxmlformats.org/drawingml/2006/main" prst="roundRect">
-            <a:avLst>
-              <a:gd name="adj" fmla="val 3636"/>
-            </a:avLst>
-          </a:prstGeom>
-          <a:solidFill xmlns:a="http://schemas.openxmlformats.org/drawingml/2006/main">
-            <a:srgbClr val="147D7E"/>
-          </a:solidFill>
+                <a16:creationId xmlns:a16="http://schemas.microsoft.com/office/drawing/2014/main" id="{A92E47A6-21C6-4FF1-B51D-AA0975D1034E}"/>
+              </a:ext>
+            </a:extLst>
+          </p:cNvPr>
+          <p:cNvSpPr>
+            <a:spLocks xmlns:a="http://schemas.openxmlformats.org/drawingml/2006/main" noGrp="1"/>
+          </p:cNvSpPr>
+          <p:nvPr/>
+        </p:nvSpPr>
+        <p:spPr>
+          <a:xfrm xmlns:a="http://schemas.openxmlformats.org/drawingml/2006/main">
+            <a:off x="1619250" y="2619375"/>
+            <a:ext cx="9144000" cy="285750"/>
+          </a:xfrm>
+          <a:prstGeom xmlns:a="http://schemas.openxmlformats.org/drawingml/2006/main" prst="rect">
+            <a:avLst/>
+          </a:prstGeom>
+          <a:noFill xmlns:a="http://schemas.openxmlformats.org/drawingml/2006/main"/>
+          <a:ln xmlns:a="http://schemas.openxmlformats.org/drawingml/2006/main" w="0">
+            <a:noFill/>
+            <a:prstDash val="solid"/>
+          </a:ln>
+        </p:spPr>
+        <p:txBody>
+          <a:bodyPr xmlns:a="http://schemas.openxmlformats.org/drawingml/2006/main"/>
+          <a:lstStyle xmlns:a="http://schemas.openxmlformats.org/drawingml/2006/main"/>
+          <a:p xmlns:a="http://schemas.openxmlformats.org/drawingml/2006/main">
+            <a:pPr>
+              <a:defRPr sz="1650" b="1">
+                <a:solidFill>
+                  <a:srgbClr val="111827"/>
+                </a:solidFill>
+              </a:defRPr>
+            </a:pPr>
+            <a:r>
+              <a:rPr sz="1650" b="1">
+                <a:solidFill>
+                  <a:srgbClr val="111827"/>
+                </a:solidFill>
+              </a:rPr>
+              <a:t>先定義學習目標，再選遊戲形式</a:t>
+            </a:r>
+          </a:p>
+        </p:txBody>
+      </p:sp>
+      <p:sp>
+        <p:nvSpPr>
+          <p:cNvPr id="8" name="">
+            <a:extLst xmlns:a="http://schemas.openxmlformats.org/drawingml/2006/main">
+              <a:ext uri="{FF2B5EF4-FFF2-40B4-BE49-F238E27FC236}">
+                <a16:creationId xmlns:a16="http://schemas.microsoft.com/office/drawing/2014/main" id="{7C8B933E-8B3C-4DB7-A015-963D8270EF27}"/>
+              </a:ext>
+            </a:extLst>
+          </p:cNvPr>
+          <p:cNvSpPr>
+            <a:spLocks xmlns:a="http://schemas.openxmlformats.org/drawingml/2006/main" noGrp="1"/>
+          </p:cNvSpPr>
+          <p:nvPr/>
+        </p:nvSpPr>
+        <p:spPr>
+          <a:xfrm xmlns:a="http://schemas.openxmlformats.org/drawingml/2006/main">
+            <a:off x="1619250" y="3019425"/>
+            <a:ext cx="9048750" cy="0"/>
+          </a:xfrm>
+          <a:prstGeom xmlns:a="http://schemas.openxmlformats.org/drawingml/2006/main" prst="line">
+            <a:avLst/>
+          </a:prstGeom>
+          <a:noFill xmlns:a="http://schemas.openxmlformats.org/drawingml/2006/main"/>
           <a:ln xmlns:a="http://schemas.openxmlformats.org/drawingml/2006/main" w="9525">
             <a:solidFill>
-              <a:srgbClr val="147D7E"/>
+              <a:srgbClr val="D7DEE7"/>
             </a:solidFill>
             <a:prstDash val="solid"/>
           </a:ln>
@@ -6158,50 +6204,443 @@
       </p:sp>
       <p:sp>
         <p:nvSpPr>
-          <p:cNvPr id="8" name="">
-            <a:extLst xmlns:a="http://schemas.openxmlformats.org/drawingml/2006/main">
-              <a:ext uri="{FF2B5EF4-FFF2-40B4-BE49-F238E27FC236}">
-                <a16:creationId xmlns:a16="http://schemas.microsoft.com/office/drawing/2014/main" id="{0927BCB0-B333-4C55-9924-3D2C0EE20216}"/>
-              </a:ext>
-            </a:extLst>
-          </p:cNvPr>
-          <p:cNvSpPr>
-            <a:spLocks xmlns:a="http://schemas.openxmlformats.org/drawingml/2006/main" noGrp="1"/>
-          </p:cNvSpPr>
-          <p:nvPr/>
-        </p:nvSpPr>
-        <p:spPr>
-          <a:xfrm xmlns:a="http://schemas.openxmlformats.org/drawingml/2006/main">
-            <a:off x="9048750" y="2619375"/>
-            <a:ext cx="1524000" cy="523875"/>
-          </a:xfrm>
-          <a:prstGeom xmlns:a="http://schemas.openxmlformats.org/drawingml/2006/main" prst="rect">
-            <a:avLst/>
-          </a:prstGeom>
-          <a:noFill xmlns:a="http://schemas.openxmlformats.org/drawingml/2006/main"/>
-          <a:ln xmlns:a="http://schemas.openxmlformats.org/drawingml/2006/main" w="0">
-            <a:noFill/>
-            <a:prstDash val="solid"/>
-          </a:ln>
-        </p:spPr>
-        <p:txBody>
-          <a:bodyPr xmlns:a="http://schemas.openxmlformats.org/drawingml/2006/main"/>
-          <a:lstStyle xmlns:a="http://schemas.openxmlformats.org/drawingml/2006/main"/>
-          <a:p xmlns:a="http://schemas.openxmlformats.org/drawingml/2006/main">
-            <a:pPr algn="ctr">
-              <a:defRPr sz="3300" b="1">
-                <a:solidFill>
-                  <a:srgbClr val="FFFFFF"/>
-                </a:solidFill>
-              </a:defRPr>
-            </a:pPr>
-            <a:r>
-              <a:rPr sz="3300" b="1">
-                <a:solidFill>
-                  <a:srgbClr val="FFFFFF"/>
-                </a:solidFill>
-              </a:rPr>
-              <a:t>GO</a:t>
+          <p:cNvPr id="9" name="">
+            <a:extLst xmlns:a="http://schemas.openxmlformats.org/drawingml/2006/main">
+              <a:ext uri="{FF2B5EF4-FFF2-40B4-BE49-F238E27FC236}">
+                <a16:creationId xmlns:a16="http://schemas.microsoft.com/office/drawing/2014/main" id="{D90D69F9-146D-481A-B6F6-981D1F3ECCCC}"/>
+              </a:ext>
+            </a:extLst>
+          </p:cNvPr>
+          <p:cNvSpPr>
+            <a:spLocks xmlns:a="http://schemas.openxmlformats.org/drawingml/2006/main" noGrp="1"/>
+          </p:cNvSpPr>
+          <p:nvPr/>
+        </p:nvSpPr>
+        <p:spPr>
+          <a:xfrm xmlns:a="http://schemas.openxmlformats.org/drawingml/2006/main">
+            <a:off x="857250" y="3238500"/>
+            <a:ext cx="523875" cy="266700"/>
+          </a:xfrm>
+          <a:prstGeom xmlns:a="http://schemas.openxmlformats.org/drawingml/2006/main" prst="rect">
+            <a:avLst/>
+          </a:prstGeom>
+          <a:noFill xmlns:a="http://schemas.openxmlformats.org/drawingml/2006/main"/>
+          <a:ln xmlns:a="http://schemas.openxmlformats.org/drawingml/2006/main" w="0">
+            <a:noFill/>
+            <a:prstDash val="solid"/>
+          </a:ln>
+        </p:spPr>
+        <p:txBody>
+          <a:bodyPr xmlns:a="http://schemas.openxmlformats.org/drawingml/2006/main"/>
+          <a:lstStyle xmlns:a="http://schemas.openxmlformats.org/drawingml/2006/main"/>
+          <a:p xmlns:a="http://schemas.openxmlformats.org/drawingml/2006/main">
+            <a:pPr>
+              <a:defRPr sz="1575" b="1">
+                <a:solidFill>
+                  <a:srgbClr val="147D7E"/>
+                </a:solidFill>
+              </a:defRPr>
+            </a:pPr>
+            <a:r>
+              <a:rPr sz="1575" b="1">
+                <a:solidFill>
+                  <a:srgbClr val="147D7E"/>
+                </a:solidFill>
+              </a:rPr>
+              <a:t>02</a:t>
+            </a:r>
+          </a:p>
+        </p:txBody>
+      </p:sp>
+      <p:sp>
+        <p:nvSpPr>
+          <p:cNvPr id="10" name="">
+            <a:extLst xmlns:a="http://schemas.openxmlformats.org/drawingml/2006/main">
+              <a:ext uri="{FF2B5EF4-FFF2-40B4-BE49-F238E27FC236}">
+                <a16:creationId xmlns:a16="http://schemas.microsoft.com/office/drawing/2014/main" id="{758B2D71-36AF-4784-99CE-2C1A9264C6C6}"/>
+              </a:ext>
+            </a:extLst>
+          </p:cNvPr>
+          <p:cNvSpPr>
+            <a:spLocks xmlns:a="http://schemas.openxmlformats.org/drawingml/2006/main" noGrp="1"/>
+          </p:cNvSpPr>
+          <p:nvPr/>
+        </p:nvSpPr>
+        <p:spPr>
+          <a:xfrm xmlns:a="http://schemas.openxmlformats.org/drawingml/2006/main">
+            <a:off x="1619250" y="3238500"/>
+            <a:ext cx="9144000" cy="285750"/>
+          </a:xfrm>
+          <a:prstGeom xmlns:a="http://schemas.openxmlformats.org/drawingml/2006/main" prst="rect">
+            <a:avLst/>
+          </a:prstGeom>
+          <a:noFill xmlns:a="http://schemas.openxmlformats.org/drawingml/2006/main"/>
+          <a:ln xmlns:a="http://schemas.openxmlformats.org/drawingml/2006/main" w="0">
+            <a:noFill/>
+            <a:prstDash val="solid"/>
+          </a:ln>
+        </p:spPr>
+        <p:txBody>
+          <a:bodyPr xmlns:a="http://schemas.openxmlformats.org/drawingml/2006/main"/>
+          <a:lstStyle xmlns:a="http://schemas.openxmlformats.org/drawingml/2006/main"/>
+          <a:p xmlns:a="http://schemas.openxmlformats.org/drawingml/2006/main">
+            <a:pPr>
+              <a:defRPr sz="1650" b="1">
+                <a:solidFill>
+                  <a:srgbClr val="111827"/>
+                </a:solidFill>
+              </a:defRPr>
+            </a:pPr>
+            <a:r>
+              <a:rPr sz="1650" b="1">
+                <a:solidFill>
+                  <a:srgbClr val="111827"/>
+                </a:solidFill>
+              </a:rPr>
+              <a:t>用任務與關卡承載真正的教材內容</a:t>
+            </a:r>
+          </a:p>
+        </p:txBody>
+      </p:sp>
+      <p:sp>
+        <p:nvSpPr>
+          <p:cNvPr id="11" name="">
+            <a:extLst xmlns:a="http://schemas.openxmlformats.org/drawingml/2006/main">
+              <a:ext uri="{FF2B5EF4-FFF2-40B4-BE49-F238E27FC236}">
+                <a16:creationId xmlns:a16="http://schemas.microsoft.com/office/drawing/2014/main" id="{FFEBDF31-0F83-48B6-8776-8BDA86586CBA}"/>
+              </a:ext>
+            </a:extLst>
+          </p:cNvPr>
+          <p:cNvSpPr>
+            <a:spLocks xmlns:a="http://schemas.openxmlformats.org/drawingml/2006/main" noGrp="1"/>
+          </p:cNvSpPr>
+          <p:nvPr/>
+        </p:nvSpPr>
+        <p:spPr>
+          <a:xfrm xmlns:a="http://schemas.openxmlformats.org/drawingml/2006/main">
+            <a:off x="1619250" y="3638550"/>
+            <a:ext cx="9048750" cy="0"/>
+          </a:xfrm>
+          <a:prstGeom xmlns:a="http://schemas.openxmlformats.org/drawingml/2006/main" prst="line">
+            <a:avLst/>
+          </a:prstGeom>
+          <a:noFill xmlns:a="http://schemas.openxmlformats.org/drawingml/2006/main"/>
+          <a:ln xmlns:a="http://schemas.openxmlformats.org/drawingml/2006/main" w="9525">
+            <a:solidFill>
+              <a:srgbClr val="D7DEE7"/>
+            </a:solidFill>
+            <a:prstDash val="solid"/>
+          </a:ln>
+        </p:spPr>
+      </p:sp>
+      <p:sp>
+        <p:nvSpPr>
+          <p:cNvPr id="12" name="">
+            <a:extLst xmlns:a="http://schemas.openxmlformats.org/drawingml/2006/main">
+              <a:ext uri="{FF2B5EF4-FFF2-40B4-BE49-F238E27FC236}">
+                <a16:creationId xmlns:a16="http://schemas.microsoft.com/office/drawing/2014/main" id="{A0AEB4C7-05E8-47A8-9F55-69D8C8E54651}"/>
+              </a:ext>
+            </a:extLst>
+          </p:cNvPr>
+          <p:cNvSpPr>
+            <a:spLocks xmlns:a="http://schemas.openxmlformats.org/drawingml/2006/main" noGrp="1"/>
+          </p:cNvSpPr>
+          <p:nvPr/>
+        </p:nvSpPr>
+        <p:spPr>
+          <a:xfrm xmlns:a="http://schemas.openxmlformats.org/drawingml/2006/main">
+            <a:off x="857250" y="3857625"/>
+            <a:ext cx="523875" cy="266700"/>
+          </a:xfrm>
+          <a:prstGeom xmlns:a="http://schemas.openxmlformats.org/drawingml/2006/main" prst="rect">
+            <a:avLst/>
+          </a:prstGeom>
+          <a:noFill xmlns:a="http://schemas.openxmlformats.org/drawingml/2006/main"/>
+          <a:ln xmlns:a="http://schemas.openxmlformats.org/drawingml/2006/main" w="0">
+            <a:noFill/>
+            <a:prstDash val="solid"/>
+          </a:ln>
+        </p:spPr>
+        <p:txBody>
+          <a:bodyPr xmlns:a="http://schemas.openxmlformats.org/drawingml/2006/main"/>
+          <a:lstStyle xmlns:a="http://schemas.openxmlformats.org/drawingml/2006/main"/>
+          <a:p xmlns:a="http://schemas.openxmlformats.org/drawingml/2006/main">
+            <a:pPr>
+              <a:defRPr sz="1575" b="1">
+                <a:solidFill>
+                  <a:srgbClr val="147D7E"/>
+                </a:solidFill>
+              </a:defRPr>
+            </a:pPr>
+            <a:r>
+              <a:rPr sz="1575" b="1">
+                <a:solidFill>
+                  <a:srgbClr val="147D7E"/>
+                </a:solidFill>
+              </a:rPr>
+              <a:t>03</a:t>
+            </a:r>
+          </a:p>
+        </p:txBody>
+      </p:sp>
+      <p:sp>
+        <p:nvSpPr>
+          <p:cNvPr id="13" name="">
+            <a:extLst xmlns:a="http://schemas.openxmlformats.org/drawingml/2006/main">
+              <a:ext uri="{FF2B5EF4-FFF2-40B4-BE49-F238E27FC236}">
+                <a16:creationId xmlns:a16="http://schemas.microsoft.com/office/drawing/2014/main" id="{989BEFB9-C90E-41BE-9A57-305F2D316A83}"/>
+              </a:ext>
+            </a:extLst>
+          </p:cNvPr>
+          <p:cNvSpPr>
+            <a:spLocks xmlns:a="http://schemas.openxmlformats.org/drawingml/2006/main" noGrp="1"/>
+          </p:cNvSpPr>
+          <p:nvPr/>
+        </p:nvSpPr>
+        <p:spPr>
+          <a:xfrm xmlns:a="http://schemas.openxmlformats.org/drawingml/2006/main">
+            <a:off x="1619250" y="3857625"/>
+            <a:ext cx="9144000" cy="285750"/>
+          </a:xfrm>
+          <a:prstGeom xmlns:a="http://schemas.openxmlformats.org/drawingml/2006/main" prst="rect">
+            <a:avLst/>
+          </a:prstGeom>
+          <a:noFill xmlns:a="http://schemas.openxmlformats.org/drawingml/2006/main"/>
+          <a:ln xmlns:a="http://schemas.openxmlformats.org/drawingml/2006/main" w="0">
+            <a:noFill/>
+            <a:prstDash val="solid"/>
+          </a:ln>
+        </p:spPr>
+        <p:txBody>
+          <a:bodyPr xmlns:a="http://schemas.openxmlformats.org/drawingml/2006/main"/>
+          <a:lstStyle xmlns:a="http://schemas.openxmlformats.org/drawingml/2006/main"/>
+          <a:p xmlns:a="http://schemas.openxmlformats.org/drawingml/2006/main">
+            <a:pPr>
+              <a:defRPr sz="1650" b="1">
+                <a:solidFill>
+                  <a:srgbClr val="111827"/>
+                </a:solidFill>
+              </a:defRPr>
+            </a:pPr>
+            <a:r>
+              <a:rPr sz="1650" b="1">
+                <a:solidFill>
+                  <a:srgbClr val="111827"/>
+                </a:solidFill>
+              </a:rPr>
+              <a:t>用回饋、重試與成長讓學習看得見</a:t>
+            </a:r>
+          </a:p>
+        </p:txBody>
+      </p:sp>
+      <p:sp>
+        <p:nvSpPr>
+          <p:cNvPr id="14" name="">
+            <a:extLst xmlns:a="http://schemas.openxmlformats.org/drawingml/2006/main">
+              <a:ext uri="{FF2B5EF4-FFF2-40B4-BE49-F238E27FC236}">
+                <a16:creationId xmlns:a16="http://schemas.microsoft.com/office/drawing/2014/main" id="{1FAC4B86-AAA1-40DC-AEFA-A1464EE820E5}"/>
+              </a:ext>
+            </a:extLst>
+          </p:cNvPr>
+          <p:cNvSpPr>
+            <a:spLocks xmlns:a="http://schemas.openxmlformats.org/drawingml/2006/main" noGrp="1"/>
+          </p:cNvSpPr>
+          <p:nvPr/>
+        </p:nvSpPr>
+        <p:spPr>
+          <a:xfrm xmlns:a="http://schemas.openxmlformats.org/drawingml/2006/main">
+            <a:off x="1619250" y="4257675"/>
+            <a:ext cx="9048750" cy="0"/>
+          </a:xfrm>
+          <a:prstGeom xmlns:a="http://schemas.openxmlformats.org/drawingml/2006/main" prst="line">
+            <a:avLst/>
+          </a:prstGeom>
+          <a:noFill xmlns:a="http://schemas.openxmlformats.org/drawingml/2006/main"/>
+          <a:ln xmlns:a="http://schemas.openxmlformats.org/drawingml/2006/main" w="9525">
+            <a:solidFill>
+              <a:srgbClr val="D7DEE7"/>
+            </a:solidFill>
+            <a:prstDash val="solid"/>
+          </a:ln>
+        </p:spPr>
+      </p:sp>
+      <p:sp>
+        <p:nvSpPr>
+          <p:cNvPr id="15" name="">
+            <a:extLst xmlns:a="http://schemas.openxmlformats.org/drawingml/2006/main">
+              <a:ext uri="{FF2B5EF4-FFF2-40B4-BE49-F238E27FC236}">
+                <a16:creationId xmlns:a16="http://schemas.microsoft.com/office/drawing/2014/main" id="{7DCDC191-1708-444F-9DB7-6A988D2EDABA}"/>
+              </a:ext>
+            </a:extLst>
+          </p:cNvPr>
+          <p:cNvSpPr>
+            <a:spLocks xmlns:a="http://schemas.openxmlformats.org/drawingml/2006/main" noGrp="1"/>
+          </p:cNvSpPr>
+          <p:nvPr/>
+        </p:nvSpPr>
+        <p:spPr>
+          <a:xfrm xmlns:a="http://schemas.openxmlformats.org/drawingml/2006/main">
+            <a:off x="857250" y="4476750"/>
+            <a:ext cx="523875" cy="266700"/>
+          </a:xfrm>
+          <a:prstGeom xmlns:a="http://schemas.openxmlformats.org/drawingml/2006/main" prst="rect">
+            <a:avLst/>
+          </a:prstGeom>
+          <a:noFill xmlns:a="http://schemas.openxmlformats.org/drawingml/2006/main"/>
+          <a:ln xmlns:a="http://schemas.openxmlformats.org/drawingml/2006/main" w="0">
+            <a:noFill/>
+            <a:prstDash val="solid"/>
+          </a:ln>
+        </p:spPr>
+        <p:txBody>
+          <a:bodyPr xmlns:a="http://schemas.openxmlformats.org/drawingml/2006/main"/>
+          <a:lstStyle xmlns:a="http://schemas.openxmlformats.org/drawingml/2006/main"/>
+          <a:p xmlns:a="http://schemas.openxmlformats.org/drawingml/2006/main">
+            <a:pPr>
+              <a:defRPr sz="1575" b="1">
+                <a:solidFill>
+                  <a:srgbClr val="147D7E"/>
+                </a:solidFill>
+              </a:defRPr>
+            </a:pPr>
+            <a:r>
+              <a:rPr sz="1575" b="1">
+                <a:solidFill>
+                  <a:srgbClr val="147D7E"/>
+                </a:solidFill>
+              </a:rPr>
+              <a:t>04</a:t>
+            </a:r>
+          </a:p>
+        </p:txBody>
+      </p:sp>
+      <p:sp>
+        <p:nvSpPr>
+          <p:cNvPr id="16" name="">
+            <a:extLst xmlns:a="http://schemas.openxmlformats.org/drawingml/2006/main">
+              <a:ext uri="{FF2B5EF4-FFF2-40B4-BE49-F238E27FC236}">
+                <a16:creationId xmlns:a16="http://schemas.microsoft.com/office/drawing/2014/main" id="{DECD3011-1F07-43C8-9DB7-8A1B57B26A52}"/>
+              </a:ext>
+            </a:extLst>
+          </p:cNvPr>
+          <p:cNvSpPr>
+            <a:spLocks xmlns:a="http://schemas.openxmlformats.org/drawingml/2006/main" noGrp="1"/>
+          </p:cNvSpPr>
+          <p:nvPr/>
+        </p:nvSpPr>
+        <p:spPr>
+          <a:xfrm xmlns:a="http://schemas.openxmlformats.org/drawingml/2006/main">
+            <a:off x="1619250" y="4476750"/>
+            <a:ext cx="9144000" cy="285750"/>
+          </a:xfrm>
+          <a:prstGeom xmlns:a="http://schemas.openxmlformats.org/drawingml/2006/main" prst="rect">
+            <a:avLst/>
+          </a:prstGeom>
+          <a:noFill xmlns:a="http://schemas.openxmlformats.org/drawingml/2006/main"/>
+          <a:ln xmlns:a="http://schemas.openxmlformats.org/drawingml/2006/main" w="0">
+            <a:noFill/>
+            <a:prstDash val="solid"/>
+          </a:ln>
+        </p:spPr>
+        <p:txBody>
+          <a:bodyPr xmlns:a="http://schemas.openxmlformats.org/drawingml/2006/main"/>
+          <a:lstStyle xmlns:a="http://schemas.openxmlformats.org/drawingml/2006/main"/>
+          <a:p xmlns:a="http://schemas.openxmlformats.org/drawingml/2006/main">
+            <a:pPr>
+              <a:defRPr sz="1650" b="1">
+                <a:solidFill>
+                  <a:srgbClr val="111827"/>
+                </a:solidFill>
+              </a:defRPr>
+            </a:pPr>
+            <a:r>
+              <a:rPr sz="1650" b="1">
+                <a:solidFill>
+                  <a:srgbClr val="111827"/>
+                </a:solidFill>
+              </a:rPr>
+              <a:t>最後用簡報說清楚規則、流程與學習證據</a:t>
+            </a:r>
+          </a:p>
+        </p:txBody>
+      </p:sp>
+      <p:sp>
+        <p:nvSpPr>
+          <p:cNvPr id="17" name="">
+            <a:extLst xmlns:a="http://schemas.openxmlformats.org/drawingml/2006/main">
+              <a:ext uri="{FF2B5EF4-FFF2-40B4-BE49-F238E27FC236}">
+                <a16:creationId xmlns:a16="http://schemas.microsoft.com/office/drawing/2014/main" id="{8F6EB9F9-DEA3-4F96-BA32-9ED7F3B2EBA2}"/>
+              </a:ext>
+            </a:extLst>
+          </p:cNvPr>
+          <p:cNvSpPr>
+            <a:spLocks xmlns:a="http://schemas.openxmlformats.org/drawingml/2006/main" noGrp="1"/>
+          </p:cNvSpPr>
+          <p:nvPr/>
+        </p:nvSpPr>
+        <p:spPr>
+          <a:xfrm xmlns:a="http://schemas.openxmlformats.org/drawingml/2006/main">
+            <a:off x="1619250" y="4876800"/>
+            <a:ext cx="9048750" cy="0"/>
+          </a:xfrm>
+          <a:prstGeom xmlns:a="http://schemas.openxmlformats.org/drawingml/2006/main" prst="line">
+            <a:avLst/>
+          </a:prstGeom>
+          <a:noFill xmlns:a="http://schemas.openxmlformats.org/drawingml/2006/main"/>
+          <a:ln xmlns:a="http://schemas.openxmlformats.org/drawingml/2006/main" w="9525">
+            <a:solidFill>
+              <a:srgbClr val="D7DEE7"/>
+            </a:solidFill>
+            <a:prstDash val="solid"/>
+          </a:ln>
+        </p:spPr>
+      </p:sp>
+      <p:sp>
+        <p:nvSpPr>
+          <p:cNvPr id="18" name="">
+            <a:extLst xmlns:a="http://schemas.openxmlformats.org/drawingml/2006/main">
+              <a:ext uri="{FF2B5EF4-FFF2-40B4-BE49-F238E27FC236}">
+                <a16:creationId xmlns:a16="http://schemas.microsoft.com/office/drawing/2014/main" id="{080E2F84-9E5D-460A-847D-894B210BA2DD}"/>
+              </a:ext>
+            </a:extLst>
+          </p:cNvPr>
+          <p:cNvSpPr>
+            <a:spLocks xmlns:a="http://schemas.openxmlformats.org/drawingml/2006/main" noGrp="1"/>
+          </p:cNvSpPr>
+          <p:nvPr/>
+        </p:nvSpPr>
+        <p:spPr>
+          <a:xfrm xmlns:a="http://schemas.openxmlformats.org/drawingml/2006/main">
+            <a:off x="609600" y="5476875"/>
+            <a:ext cx="10668000" cy="323850"/>
+          </a:xfrm>
+          <a:prstGeom xmlns:a="http://schemas.openxmlformats.org/drawingml/2006/main" prst="rect">
+            <a:avLst/>
+          </a:prstGeom>
+          <a:noFill xmlns:a="http://schemas.openxmlformats.org/drawingml/2006/main"/>
+          <a:ln xmlns:a="http://schemas.openxmlformats.org/drawingml/2006/main" w="0">
+            <a:noFill/>
+            <a:prstDash val="solid"/>
+          </a:ln>
+        </p:spPr>
+        <p:txBody>
+          <a:bodyPr xmlns:a="http://schemas.openxmlformats.org/drawingml/2006/main"/>
+          <a:lstStyle xmlns:a="http://schemas.openxmlformats.org/drawingml/2006/main"/>
+          <a:p xmlns:a="http://schemas.openxmlformats.org/drawingml/2006/main">
+            <a:pPr>
+              <a:defRPr sz="1575" b="1">
+                <a:solidFill>
+                  <a:srgbClr val="147D7E"/>
+                </a:solidFill>
+              </a:defRPr>
+            </a:pPr>
+            <a:r>
+              <a:rPr sz="1575" b="1">
+                <a:solidFill>
+                  <a:srgbClr val="147D7E"/>
+                </a:solidFill>
+              </a:rPr>
+              <a:t>今天的產出：一份有來源、有規則、能實際進行的遊戲化 RPG 簡報。</a:t>
             </a:r>
           </a:p>
         </p:txBody>
@@ -6209,7 +6648,7 @@
     </p:spTree>
     <p:extLst>
       <p:ext uri="{BB962C8B-B14F-4D97-AF65-F5344CB8AC3E}">
-        <p14:creationId xmlns:p14="http://schemas.microsoft.com/office/powerpoint/2010/main" val="596404953"/>
+        <p14:creationId xmlns:p14="http://schemas.microsoft.com/office/powerpoint/2010/main" val="2040015817"/>
       </p:ext>
     </p:extLst>
   </p:cSld>

</xml_diff>

<commit_message>
Add advanced single file campus RPG prompt
</commit_message>
<xml_diff>
--- a/class/ppt/lesson-01.pptx
+++ b/class/ppt/lesson-01.pptx
@@ -2,20 +2,20 @@
 <file path=ppt/presentation.xml><?xml version="1.0" encoding="utf-8"?>
 <p:presentation xmlns:p="http://schemas.openxmlformats.org/presentationml/2006/main">
   <p:sldMasterIdLst>
-    <p:sldMasterId xmlns:r="http://schemas.openxmlformats.org/officeDocument/2006/relationships" id="2147483648" r:id="R198dbb8d95254504"/>
+    <p:sldMasterId xmlns:r="http://schemas.openxmlformats.org/officeDocument/2006/relationships" id="2147483648" r:id="Rcb6982be26f74924"/>
   </p:sldMasterIdLst>
   <p:notesMasterIdLst>
-    <p:notesMasterId xmlns:r="http://schemas.openxmlformats.org/officeDocument/2006/relationships" r:id="R1e9de1d1048846de"/>
+    <p:notesMasterId xmlns:r="http://schemas.openxmlformats.org/officeDocument/2006/relationships" r:id="Rb7843602ad5f48d4"/>
   </p:notesMasterIdLst>
   <p:sldIdLst>
-    <p:sldId xmlns:r="http://schemas.openxmlformats.org/officeDocument/2006/relationships" id="256" r:id="R7e2b05b67afc4051"/>
-    <p:sldId xmlns:r="http://schemas.openxmlformats.org/officeDocument/2006/relationships" id="257" r:id="R03dc28d89c544117"/>
-    <p:sldId xmlns:r="http://schemas.openxmlformats.org/officeDocument/2006/relationships" id="258" r:id="R82ba9e5ada8b4144"/>
-    <p:sldId xmlns:r="http://schemas.openxmlformats.org/officeDocument/2006/relationships" id="259" r:id="R2f098fedc0374991"/>
-    <p:sldId xmlns:r="http://schemas.openxmlformats.org/officeDocument/2006/relationships" id="260" r:id="Rf7a6b971cc664c04"/>
-    <p:sldId xmlns:r="http://schemas.openxmlformats.org/officeDocument/2006/relationships" id="261" r:id="Rb3a8da30562f44f7"/>
-    <p:sldId xmlns:r="http://schemas.openxmlformats.org/officeDocument/2006/relationships" id="262" r:id="Rfdfcf33edeb44fcf"/>
-    <p:sldId xmlns:r="http://schemas.openxmlformats.org/officeDocument/2006/relationships" id="263" r:id="Rc0e34d672d264011"/>
+    <p:sldId xmlns:r="http://schemas.openxmlformats.org/officeDocument/2006/relationships" id="256" r:id="R4e1a405bffca407e"/>
+    <p:sldId xmlns:r="http://schemas.openxmlformats.org/officeDocument/2006/relationships" id="257" r:id="Rb2b85c59bdc84374"/>
+    <p:sldId xmlns:r="http://schemas.openxmlformats.org/officeDocument/2006/relationships" id="258" r:id="R10c9fab4d7c940af"/>
+    <p:sldId xmlns:r="http://schemas.openxmlformats.org/officeDocument/2006/relationships" id="259" r:id="Rd30f7db5cb024e3d"/>
+    <p:sldId xmlns:r="http://schemas.openxmlformats.org/officeDocument/2006/relationships" id="260" r:id="Rc8ec3b3107b844b8"/>
+    <p:sldId xmlns:r="http://schemas.openxmlformats.org/officeDocument/2006/relationships" id="261" r:id="R7ee150dfdf8248ab"/>
+    <p:sldId xmlns:r="http://schemas.openxmlformats.org/officeDocument/2006/relationships" id="262" r:id="R768586a20f2c4dd0"/>
+    <p:sldId xmlns:r="http://schemas.openxmlformats.org/officeDocument/2006/relationships" id="263" r:id="R6245117a801e41b7"/>
   </p:sldIdLst>
   <p:sldSz cx="12192000" cy="6858000"/>
   <p:notesSz cx="6858000" cy="9144000"/>
@@ -1127,7 +1127,7 @@
   </p:cSld>
   <p:clrMap bg1="lt1" tx1="dk1" bg2="lt2" tx2="dk2" accent1="accent1" accent2="accent2" accent3="accent3" accent4="accent4" accent5="accent5" accent6="accent6" hlink="hlink" folHlink="folHlink"/>
   <p:sldLayoutIdLst>
-    <p:sldLayoutId xmlns:r="http://schemas.openxmlformats.org/officeDocument/2006/relationships" id="2147483649" r:id="Rda66842d355a41c5"/>
+    <p:sldLayoutId xmlns:r="http://schemas.openxmlformats.org/officeDocument/2006/relationships" id="2147483649" r:id="Rbfbb072b0fc343d0"/>
   </p:sldLayoutIdLst>
   <p:txStyles>
     <p:titleStyle>
@@ -1678,7 +1678,7 @@
           <p:cNvPr id="8" name="">
             <a:extLst xmlns:a="http://schemas.openxmlformats.org/drawingml/2006/main">
               <a:ext uri="{FF2B5EF4-FFF2-40B4-BE49-F238E27FC236}">
-                <a16:creationId xmlns:a16="http://schemas.microsoft.com/office/drawing/2014/main" id="{B068327F-8E72-4148-980D-1F97FE4C220B}"/>
+                <a16:creationId xmlns:a16="http://schemas.microsoft.com/office/drawing/2014/main" id="{AAFA2475-E072-4525-8E35-BF3B46A81D7D}"/>
               </a:ext>
             </a:extLst>
           </p:cNvPr>
@@ -1711,7 +1711,7 @@
           <p:cNvPr id="2" name="">
             <a:extLst xmlns:a="http://schemas.openxmlformats.org/drawingml/2006/main">
               <a:ext uri="{FF2B5EF4-FFF2-40B4-BE49-F238E27FC236}">
-                <a16:creationId xmlns:a16="http://schemas.microsoft.com/office/drawing/2014/main" id="{C8D6EBB5-5471-4EAC-A3E1-5C1D2414A085}"/>
+                <a16:creationId xmlns:a16="http://schemas.microsoft.com/office/drawing/2014/main" id="{8EF09322-87FB-422C-9B3B-68A2CE6874FA}"/>
               </a:ext>
             </a:extLst>
           </p:cNvPr>
@@ -1761,7 +1761,7 @@
           <p:cNvPr id="3" name="">
             <a:extLst xmlns:a="http://schemas.openxmlformats.org/drawingml/2006/main">
               <a:ext uri="{FF2B5EF4-FFF2-40B4-BE49-F238E27FC236}">
-                <a16:creationId xmlns:a16="http://schemas.microsoft.com/office/drawing/2014/main" id="{CE0C1836-7EA8-4F3A-AE2A-C1F32A7CAAE4}"/>
+                <a16:creationId xmlns:a16="http://schemas.microsoft.com/office/drawing/2014/main" id="{CDFBF2A3-9517-4284-95F3-4AFF34828265}"/>
               </a:ext>
             </a:extLst>
           </p:cNvPr>
@@ -1811,7 +1811,7 @@
           <p:cNvPr id="4" name="">
             <a:extLst xmlns:a="http://schemas.openxmlformats.org/drawingml/2006/main">
               <a:ext uri="{FF2B5EF4-FFF2-40B4-BE49-F238E27FC236}">
-                <a16:creationId xmlns:a16="http://schemas.microsoft.com/office/drawing/2014/main" id="{A746C3F0-2795-4117-9428-F00EF596D6E4}"/>
+                <a16:creationId xmlns:a16="http://schemas.microsoft.com/office/drawing/2014/main" id="{C7B69B6D-4B03-4A84-B9B0-A533396B5824}"/>
               </a:ext>
             </a:extLst>
           </p:cNvPr>
@@ -1861,7 +1861,7 @@
           <p:cNvPr id="5" name="">
             <a:extLst xmlns:a="http://schemas.openxmlformats.org/drawingml/2006/main">
               <a:ext uri="{FF2B5EF4-FFF2-40B4-BE49-F238E27FC236}">
-                <a16:creationId xmlns:a16="http://schemas.microsoft.com/office/drawing/2014/main" id="{727891FD-B7BE-43F3-86D9-D9F61DD465D1}"/>
+                <a16:creationId xmlns:a16="http://schemas.microsoft.com/office/drawing/2014/main" id="{692D4F4D-976B-4293-BAED-E0199E15FCB5}"/>
               </a:ext>
             </a:extLst>
           </p:cNvPr>
@@ -1896,7 +1896,7 @@
           <p:cNvPr id="6" name="">
             <a:extLst xmlns:a="http://schemas.openxmlformats.org/drawingml/2006/main">
               <a:ext uri="{FF2B5EF4-FFF2-40B4-BE49-F238E27FC236}">
-                <a16:creationId xmlns:a16="http://schemas.microsoft.com/office/drawing/2014/main" id="{CFF74D2F-B297-4037-B493-5D87F5CD787D}"/>
+                <a16:creationId xmlns:a16="http://schemas.microsoft.com/office/drawing/2014/main" id="{A00E66D9-E625-4F71-AF88-9B5B2D5194E8}"/>
               </a:ext>
             </a:extLst>
           </p:cNvPr>
@@ -1946,7 +1946,7 @@
           <p:cNvPr id="7" name="">
             <a:extLst xmlns:a="http://schemas.openxmlformats.org/drawingml/2006/main">
               <a:ext uri="{FF2B5EF4-FFF2-40B4-BE49-F238E27FC236}">
-                <a16:creationId xmlns:a16="http://schemas.microsoft.com/office/drawing/2014/main" id="{3F0BD888-1281-465A-B0AA-F13D0A0BF692}"/>
+                <a16:creationId xmlns:a16="http://schemas.microsoft.com/office/drawing/2014/main" id="{1ACC7E9D-93D2-4ED5-A9BD-E9612124C357}"/>
               </a:ext>
             </a:extLst>
           </p:cNvPr>
@@ -2011,7 +2011,7 @@
     </p:spTree>
     <p:extLst>
       <p:ext uri="{BB962C8B-B14F-4D97-AF65-F5344CB8AC3E}">
-        <p14:creationId xmlns:p14="http://schemas.microsoft.com/office/powerpoint/2010/main" val="164951980"/>
+        <p14:creationId xmlns:p14="http://schemas.microsoft.com/office/powerpoint/2010/main" val="1825308774"/>
       </p:ext>
     </p:extLst>
   </p:cSld>
@@ -2042,7 +2042,7 @@
           <p:cNvPr id="12" name="">
             <a:extLst xmlns:a="http://schemas.openxmlformats.org/drawingml/2006/main">
               <a:ext uri="{FF2B5EF4-FFF2-40B4-BE49-F238E27FC236}">
-                <a16:creationId xmlns:a16="http://schemas.microsoft.com/office/drawing/2014/main" id="{4F57948F-D20F-4540-AEB2-3A0851134559}"/>
+                <a16:creationId xmlns:a16="http://schemas.microsoft.com/office/drawing/2014/main" id="{7E7D24CC-BD35-4A41-A1DE-A57A8858CE04}"/>
               </a:ext>
             </a:extLst>
           </p:cNvPr>
@@ -2092,7 +2092,7 @@
           <p:cNvPr id="2" name="">
             <a:extLst xmlns:a="http://schemas.openxmlformats.org/drawingml/2006/main">
               <a:ext uri="{FF2B5EF4-FFF2-40B4-BE49-F238E27FC236}">
-                <a16:creationId xmlns:a16="http://schemas.microsoft.com/office/drawing/2014/main" id="{16CD6040-355E-46CE-8A9D-C1267D549ABC}"/>
+                <a16:creationId xmlns:a16="http://schemas.microsoft.com/office/drawing/2014/main" id="{B6D15696-DB49-4882-944B-4FAA57FA29F3}"/>
               </a:ext>
             </a:extLst>
           </p:cNvPr>
@@ -2142,7 +2142,7 @@
           <p:cNvPr id="3" name="">
             <a:extLst xmlns:a="http://schemas.openxmlformats.org/drawingml/2006/main">
               <a:ext uri="{FF2B5EF4-FFF2-40B4-BE49-F238E27FC236}">
-                <a16:creationId xmlns:a16="http://schemas.microsoft.com/office/drawing/2014/main" id="{8F656918-6D80-40CD-AE1A-C7C66BC345CA}"/>
+                <a16:creationId xmlns:a16="http://schemas.microsoft.com/office/drawing/2014/main" id="{ABE2413F-7526-4C4C-A96C-DA760DF84DD6}"/>
               </a:ext>
             </a:extLst>
           </p:cNvPr>
@@ -2192,7 +2192,7 @@
           <p:cNvPr id="4" name="">
             <a:extLst xmlns:a="http://schemas.openxmlformats.org/drawingml/2006/main">
               <a:ext uri="{FF2B5EF4-FFF2-40B4-BE49-F238E27FC236}">
-                <a16:creationId xmlns:a16="http://schemas.microsoft.com/office/drawing/2014/main" id="{BACC5AAC-F00D-42D1-B69A-1B310B17FA03}"/>
+                <a16:creationId xmlns:a16="http://schemas.microsoft.com/office/drawing/2014/main" id="{3EAAE5E7-AC45-4855-8B4C-C4373E452B69}"/>
               </a:ext>
             </a:extLst>
           </p:cNvPr>
@@ -2223,7 +2223,7 @@
           <p:cNvPr id="5" name="">
             <a:extLst xmlns:a="http://schemas.openxmlformats.org/drawingml/2006/main">
               <a:ext uri="{FF2B5EF4-FFF2-40B4-BE49-F238E27FC236}">
-                <a16:creationId xmlns:a16="http://schemas.microsoft.com/office/drawing/2014/main" id="{165645F4-E604-42A6-B3A2-99BE6E4F203C}"/>
+                <a16:creationId xmlns:a16="http://schemas.microsoft.com/office/drawing/2014/main" id="{4633DDFA-78D2-46E8-A267-6527733E2774}"/>
               </a:ext>
             </a:extLst>
           </p:cNvPr>
@@ -2273,7 +2273,7 @@
           <p:cNvPr id="6" name="">
             <a:extLst xmlns:a="http://schemas.openxmlformats.org/drawingml/2006/main">
               <a:ext uri="{FF2B5EF4-FFF2-40B4-BE49-F238E27FC236}">
-                <a16:creationId xmlns:a16="http://schemas.microsoft.com/office/drawing/2014/main" id="{1C2A499C-4AE4-4FF8-86BA-CC75CF999A0C}"/>
+                <a16:creationId xmlns:a16="http://schemas.microsoft.com/office/drawing/2014/main" id="{DA3A7AA1-DDEC-4260-90DB-5CF7F5E045E2}"/>
               </a:ext>
             </a:extLst>
           </p:cNvPr>
@@ -2323,7 +2323,7 @@
           <p:cNvPr id="7" name="">
             <a:extLst xmlns:a="http://schemas.openxmlformats.org/drawingml/2006/main">
               <a:ext uri="{FF2B5EF4-FFF2-40B4-BE49-F238E27FC236}">
-                <a16:creationId xmlns:a16="http://schemas.microsoft.com/office/drawing/2014/main" id="{7F9C7CE1-E959-4E09-A68A-C97989133511}"/>
+                <a16:creationId xmlns:a16="http://schemas.microsoft.com/office/drawing/2014/main" id="{B9ACC031-5B45-40B3-B8E6-27954C0BF7F8}"/>
               </a:ext>
             </a:extLst>
           </p:cNvPr>
@@ -2373,7 +2373,7 @@
           <p:cNvPr id="8" name="">
             <a:extLst xmlns:a="http://schemas.openxmlformats.org/drawingml/2006/main">
               <a:ext uri="{FF2B5EF4-FFF2-40B4-BE49-F238E27FC236}">
-                <a16:creationId xmlns:a16="http://schemas.microsoft.com/office/drawing/2014/main" id="{547462D1-BE65-425C-BCE5-97C72F40FF87}"/>
+                <a16:creationId xmlns:a16="http://schemas.microsoft.com/office/drawing/2014/main" id="{539F00CE-7744-4F7F-8F3F-16C7BC59B29C}"/>
               </a:ext>
             </a:extLst>
           </p:cNvPr>
@@ -2423,7 +2423,7 @@
           <p:cNvPr id="9" name="">
             <a:extLst xmlns:a="http://schemas.openxmlformats.org/drawingml/2006/main">
               <a:ext uri="{FF2B5EF4-FFF2-40B4-BE49-F238E27FC236}">
-                <a16:creationId xmlns:a16="http://schemas.microsoft.com/office/drawing/2014/main" id="{E06E9D46-EBF4-40B1-B50A-45E1CEC02BC7}"/>
+                <a16:creationId xmlns:a16="http://schemas.microsoft.com/office/drawing/2014/main" id="{1AF6D74E-D6ED-43E9-A32A-5A1B90D2120F}"/>
               </a:ext>
             </a:extLst>
           </p:cNvPr>
@@ -2460,7 +2460,7 @@
           <p:cNvPr id="10" name="">
             <a:extLst xmlns:a="http://schemas.openxmlformats.org/drawingml/2006/main">
               <a:ext uri="{FF2B5EF4-FFF2-40B4-BE49-F238E27FC236}">
-                <a16:creationId xmlns:a16="http://schemas.microsoft.com/office/drawing/2014/main" id="{FD73A021-4EAD-4A78-9A60-73777C952254}"/>
+                <a16:creationId xmlns:a16="http://schemas.microsoft.com/office/drawing/2014/main" id="{650AA651-F8FE-43C6-A072-C57037DFCED4}"/>
               </a:ext>
             </a:extLst>
           </p:cNvPr>
@@ -2510,7 +2510,7 @@
           <p:cNvPr id="11" name="">
             <a:extLst xmlns:a="http://schemas.openxmlformats.org/drawingml/2006/main">
               <a:ext uri="{FF2B5EF4-FFF2-40B4-BE49-F238E27FC236}">
-                <a16:creationId xmlns:a16="http://schemas.microsoft.com/office/drawing/2014/main" id="{9A4EB3C2-D939-4113-9F66-47041837906B}"/>
+                <a16:creationId xmlns:a16="http://schemas.microsoft.com/office/drawing/2014/main" id="{5DE95C05-EDD0-491D-B8CB-35495D04BFE7}"/>
               </a:ext>
             </a:extLst>
           </p:cNvPr>
@@ -2558,7 +2558,7 @@
     </p:spTree>
     <p:extLst>
       <p:ext uri="{BB962C8B-B14F-4D97-AF65-F5344CB8AC3E}">
-        <p14:creationId xmlns:p14="http://schemas.microsoft.com/office/powerpoint/2010/main" val="1616496519"/>
+        <p14:creationId xmlns:p14="http://schemas.microsoft.com/office/powerpoint/2010/main" val="312077048"/>
       </p:ext>
     </p:extLst>
   </p:cSld>
@@ -2589,7 +2589,7 @@
           <p:cNvPr id="15" name="">
             <a:extLst xmlns:a="http://schemas.openxmlformats.org/drawingml/2006/main">
               <a:ext uri="{FF2B5EF4-FFF2-40B4-BE49-F238E27FC236}">
-                <a16:creationId xmlns:a16="http://schemas.microsoft.com/office/drawing/2014/main" id="{AB8F92F8-B29A-4892-A0AA-C3E93107382F}"/>
+                <a16:creationId xmlns:a16="http://schemas.microsoft.com/office/drawing/2014/main" id="{BC7A3C37-8D67-435B-A2E7-9EB5EEC3CB1B}"/>
               </a:ext>
             </a:extLst>
           </p:cNvPr>
@@ -2639,7 +2639,7 @@
           <p:cNvPr id="2" name="">
             <a:extLst xmlns:a="http://schemas.openxmlformats.org/drawingml/2006/main">
               <a:ext uri="{FF2B5EF4-FFF2-40B4-BE49-F238E27FC236}">
-                <a16:creationId xmlns:a16="http://schemas.microsoft.com/office/drawing/2014/main" id="{FC6AA630-DDF2-4B67-ADB6-F5F36C427227}"/>
+                <a16:creationId xmlns:a16="http://schemas.microsoft.com/office/drawing/2014/main" id="{C06916A6-45FA-4B5D-86D6-5AE1309C154E}"/>
               </a:ext>
             </a:extLst>
           </p:cNvPr>
@@ -2689,7 +2689,7 @@
           <p:cNvPr id="3" name="">
             <a:extLst xmlns:a="http://schemas.openxmlformats.org/drawingml/2006/main">
               <a:ext uri="{FF2B5EF4-FFF2-40B4-BE49-F238E27FC236}">
-                <a16:creationId xmlns:a16="http://schemas.microsoft.com/office/drawing/2014/main" id="{D03DEF1A-D490-4217-ADCA-AABB1205932C}"/>
+                <a16:creationId xmlns:a16="http://schemas.microsoft.com/office/drawing/2014/main" id="{1702B8BF-F509-47B0-A8D2-294B289EA474}"/>
               </a:ext>
             </a:extLst>
           </p:cNvPr>
@@ -2739,7 +2739,7 @@
           <p:cNvPr id="4" name="">
             <a:extLst xmlns:a="http://schemas.openxmlformats.org/drawingml/2006/main">
               <a:ext uri="{FF2B5EF4-FFF2-40B4-BE49-F238E27FC236}">
-                <a16:creationId xmlns:a16="http://schemas.microsoft.com/office/drawing/2014/main" id="{C63717E6-8694-4CB5-B217-6A6FD9C1B9AE}"/>
+                <a16:creationId xmlns:a16="http://schemas.microsoft.com/office/drawing/2014/main" id="{83AC2BC6-DCD6-4E96-905C-E5F9A9D1D0B3}"/>
               </a:ext>
             </a:extLst>
           </p:cNvPr>
@@ -2770,7 +2770,7 @@
           <p:cNvPr id="5" name="">
             <a:extLst xmlns:a="http://schemas.openxmlformats.org/drawingml/2006/main">
               <a:ext uri="{FF2B5EF4-FFF2-40B4-BE49-F238E27FC236}">
-                <a16:creationId xmlns:a16="http://schemas.microsoft.com/office/drawing/2014/main" id="{CFA5FEAA-44E1-4E5A-A305-DA2CA2E6EBBA}"/>
+                <a16:creationId xmlns:a16="http://schemas.microsoft.com/office/drawing/2014/main" id="{59E60DF7-C263-41FE-81A0-37C6315FBC6D}"/>
               </a:ext>
             </a:extLst>
           </p:cNvPr>
@@ -2820,7 +2820,7 @@
           <p:cNvPr id="6" name="">
             <a:extLst xmlns:a="http://schemas.openxmlformats.org/drawingml/2006/main">
               <a:ext uri="{FF2B5EF4-FFF2-40B4-BE49-F238E27FC236}">
-                <a16:creationId xmlns:a16="http://schemas.microsoft.com/office/drawing/2014/main" id="{B20D9699-BD52-4C33-B8D7-18DB16CF62CD}"/>
+                <a16:creationId xmlns:a16="http://schemas.microsoft.com/office/drawing/2014/main" id="{110AA03B-310F-4EDC-8955-DD852E166772}"/>
               </a:ext>
             </a:extLst>
           </p:cNvPr>
@@ -2857,7 +2857,7 @@
           <p:cNvPr id="7" name="">
             <a:extLst xmlns:a="http://schemas.openxmlformats.org/drawingml/2006/main">
               <a:ext uri="{FF2B5EF4-FFF2-40B4-BE49-F238E27FC236}">
-                <a16:creationId xmlns:a16="http://schemas.microsoft.com/office/drawing/2014/main" id="{DBA4B84D-400B-4D3C-8F52-F9DCFB45E304}"/>
+                <a16:creationId xmlns:a16="http://schemas.microsoft.com/office/drawing/2014/main" id="{D2F4E6A8-C799-41D3-B885-4323744F271F}"/>
               </a:ext>
             </a:extLst>
           </p:cNvPr>
@@ -2907,7 +2907,7 @@
           <p:cNvPr id="8" name="">
             <a:extLst xmlns:a="http://schemas.openxmlformats.org/drawingml/2006/main">
               <a:ext uri="{FF2B5EF4-FFF2-40B4-BE49-F238E27FC236}">
-                <a16:creationId xmlns:a16="http://schemas.microsoft.com/office/drawing/2014/main" id="{4C9A5503-8773-4A06-8A8C-C4A2CEBBC8FE}"/>
+                <a16:creationId xmlns:a16="http://schemas.microsoft.com/office/drawing/2014/main" id="{BAC076D7-4650-4E87-BBC5-DF71665B947F}"/>
               </a:ext>
             </a:extLst>
           </p:cNvPr>
@@ -2947,7 +2947,7 @@
                   <a:srgbClr val="111827"/>
                 </a:solidFill>
               </a:rPr>
-              <a:t>遊戲服務學習目標</a:t>
+              <a:t>RPG 是扮演角色，在任務中學習與成長</a:t>
             </a:r>
           </a:p>
         </p:txBody>
@@ -2957,7 +2957,7 @@
           <p:cNvPr id="9" name="">
             <a:extLst xmlns:a="http://schemas.openxmlformats.org/drawingml/2006/main">
               <a:ext uri="{FF2B5EF4-FFF2-40B4-BE49-F238E27FC236}">
-                <a16:creationId xmlns:a16="http://schemas.microsoft.com/office/drawing/2014/main" id="{28F2DD5C-C3EA-4FD1-A96F-D1601BE4ED70}"/>
+                <a16:creationId xmlns:a16="http://schemas.microsoft.com/office/drawing/2014/main" id="{B67B2AD5-1508-4E58-8418-F7ACDBAD996B}"/>
               </a:ext>
             </a:extLst>
           </p:cNvPr>
@@ -2992,7 +2992,7 @@
           <p:cNvPr id="10" name="">
             <a:extLst xmlns:a="http://schemas.openxmlformats.org/drawingml/2006/main">
               <a:ext uri="{FF2B5EF4-FFF2-40B4-BE49-F238E27FC236}">
-                <a16:creationId xmlns:a16="http://schemas.microsoft.com/office/drawing/2014/main" id="{259D61F9-344F-4898-9B60-9516E198F27B}"/>
+                <a16:creationId xmlns:a16="http://schemas.microsoft.com/office/drawing/2014/main" id="{4B94860A-5639-485C-836C-EF368E4FA07A}"/>
               </a:ext>
             </a:extLst>
           </p:cNvPr>
@@ -3042,7 +3042,7 @@
           <p:cNvPr id="11" name="">
             <a:extLst xmlns:a="http://schemas.openxmlformats.org/drawingml/2006/main">
               <a:ext uri="{FF2B5EF4-FFF2-40B4-BE49-F238E27FC236}">
-                <a16:creationId xmlns:a16="http://schemas.microsoft.com/office/drawing/2014/main" id="{B44E3196-9BC6-41EF-A540-7821FD66FEFA}"/>
+                <a16:creationId xmlns:a16="http://schemas.microsoft.com/office/drawing/2014/main" id="{26C4BB8D-C221-46F1-8C41-B86A1F8A6E80}"/>
               </a:ext>
             </a:extLst>
           </p:cNvPr>
@@ -3082,7 +3082,7 @@
                   <a:srgbClr val="111827"/>
                 </a:solidFill>
               </a:rPr>
-              <a:t>RPG 用角色、任務與關卡串起成長</a:t>
+              <a:t>RPG 用角色、任務、關卡、回饋串起學習</a:t>
             </a:r>
           </a:p>
         </p:txBody>
@@ -3092,7 +3092,7 @@
           <p:cNvPr id="12" name="">
             <a:extLst xmlns:a="http://schemas.openxmlformats.org/drawingml/2006/main">
               <a:ext uri="{FF2B5EF4-FFF2-40B4-BE49-F238E27FC236}">
-                <a16:creationId xmlns:a16="http://schemas.microsoft.com/office/drawing/2014/main" id="{427F7D08-734E-42D4-9E40-D904180422C7}"/>
+                <a16:creationId xmlns:a16="http://schemas.microsoft.com/office/drawing/2014/main" id="{51323D92-9C73-4F9F-B37F-D1437F9326D8}"/>
               </a:ext>
             </a:extLst>
           </p:cNvPr>
@@ -3129,7 +3129,7 @@
           <p:cNvPr id="13" name="">
             <a:extLst xmlns:a="http://schemas.openxmlformats.org/drawingml/2006/main">
               <a:ext uri="{FF2B5EF4-FFF2-40B4-BE49-F238E27FC236}">
-                <a16:creationId xmlns:a16="http://schemas.microsoft.com/office/drawing/2014/main" id="{AD41BF50-CA9B-439E-BF53-B0BFDD81EED6}"/>
+                <a16:creationId xmlns:a16="http://schemas.microsoft.com/office/drawing/2014/main" id="{FFB78B91-D701-4DD5-8F5F-96AD3E8A8C94}"/>
               </a:ext>
             </a:extLst>
           </p:cNvPr>
@@ -3179,7 +3179,7 @@
           <p:cNvPr id="14" name="">
             <a:extLst xmlns:a="http://schemas.openxmlformats.org/drawingml/2006/main">
               <a:ext uri="{FF2B5EF4-FFF2-40B4-BE49-F238E27FC236}">
-                <a16:creationId xmlns:a16="http://schemas.microsoft.com/office/drawing/2014/main" id="{59C831F5-390A-4CA1-8174-412803FC7018}"/>
+                <a16:creationId xmlns:a16="http://schemas.microsoft.com/office/drawing/2014/main" id="{ABCE7D4A-604B-45C5-B55D-FD460DE33B65}"/>
               </a:ext>
             </a:extLst>
           </p:cNvPr>
@@ -3227,7 +3227,7 @@
     </p:spTree>
     <p:extLst>
       <p:ext uri="{BB962C8B-B14F-4D97-AF65-F5344CB8AC3E}">
-        <p14:creationId xmlns:p14="http://schemas.microsoft.com/office/powerpoint/2010/main" val="2045091359"/>
+        <p14:creationId xmlns:p14="http://schemas.microsoft.com/office/powerpoint/2010/main" val="782279585"/>
       </p:ext>
     </p:extLst>
   </p:cSld>
@@ -3258,7 +3258,7 @@
           <p:cNvPr id="21" name="">
             <a:extLst xmlns:a="http://schemas.openxmlformats.org/drawingml/2006/main">
               <a:ext uri="{FF2B5EF4-FFF2-40B4-BE49-F238E27FC236}">
-                <a16:creationId xmlns:a16="http://schemas.microsoft.com/office/drawing/2014/main" id="{E2D400EF-CBD3-42AB-BAB6-F19BA5F7CCC0}"/>
+                <a16:creationId xmlns:a16="http://schemas.microsoft.com/office/drawing/2014/main" id="{F97CCDEB-7D7B-4164-ABA5-BDE3FD71BDB7}"/>
               </a:ext>
             </a:extLst>
           </p:cNvPr>
@@ -3308,7 +3308,7 @@
           <p:cNvPr id="2" name="">
             <a:extLst xmlns:a="http://schemas.openxmlformats.org/drawingml/2006/main">
               <a:ext uri="{FF2B5EF4-FFF2-40B4-BE49-F238E27FC236}">
-                <a16:creationId xmlns:a16="http://schemas.microsoft.com/office/drawing/2014/main" id="{924F3505-0E7C-45C8-949C-35C180BBEB1C}"/>
+                <a16:creationId xmlns:a16="http://schemas.microsoft.com/office/drawing/2014/main" id="{8E099476-4B16-472F-888B-1B09CF4A8EAF}"/>
               </a:ext>
             </a:extLst>
           </p:cNvPr>
@@ -3358,7 +3358,7 @@
           <p:cNvPr id="3" name="">
             <a:extLst xmlns:a="http://schemas.openxmlformats.org/drawingml/2006/main">
               <a:ext uri="{FF2B5EF4-FFF2-40B4-BE49-F238E27FC236}">
-                <a16:creationId xmlns:a16="http://schemas.microsoft.com/office/drawing/2014/main" id="{07F3327C-3BA0-4B55-A706-0CC010DA1D31}"/>
+                <a16:creationId xmlns:a16="http://schemas.microsoft.com/office/drawing/2014/main" id="{CE5DED50-2643-4F5D-993F-588D5808F7A4}"/>
               </a:ext>
             </a:extLst>
           </p:cNvPr>
@@ -3408,7 +3408,7 @@
           <p:cNvPr id="4" name="">
             <a:extLst xmlns:a="http://schemas.openxmlformats.org/drawingml/2006/main">
               <a:ext uri="{FF2B5EF4-FFF2-40B4-BE49-F238E27FC236}">
-                <a16:creationId xmlns:a16="http://schemas.microsoft.com/office/drawing/2014/main" id="{B1F9B3E4-6AC8-4247-902E-F26AAD63226A}"/>
+                <a16:creationId xmlns:a16="http://schemas.microsoft.com/office/drawing/2014/main" id="{4066CB17-C204-453E-9570-F768AE248184}"/>
               </a:ext>
             </a:extLst>
           </p:cNvPr>
@@ -3439,7 +3439,7 @@
           <p:cNvPr id="5" name="">
             <a:extLst xmlns:a="http://schemas.openxmlformats.org/drawingml/2006/main">
               <a:ext uri="{FF2B5EF4-FFF2-40B4-BE49-F238E27FC236}">
-                <a16:creationId xmlns:a16="http://schemas.microsoft.com/office/drawing/2014/main" id="{6F09FB64-5AEB-4570-AF9B-A922B0B7A7BD}"/>
+                <a16:creationId xmlns:a16="http://schemas.microsoft.com/office/drawing/2014/main" id="{D53A079E-9895-4D33-9603-CFD7BC6CA2FD}"/>
               </a:ext>
             </a:extLst>
           </p:cNvPr>
@@ -3489,7 +3489,7 @@
           <p:cNvPr id="6" name="">
             <a:extLst xmlns:a="http://schemas.openxmlformats.org/drawingml/2006/main">
               <a:ext uri="{FF2B5EF4-FFF2-40B4-BE49-F238E27FC236}">
-                <a16:creationId xmlns:a16="http://schemas.microsoft.com/office/drawing/2014/main" id="{102FB240-54EB-4F53-A43B-3A4D4902F181}"/>
+                <a16:creationId xmlns:a16="http://schemas.microsoft.com/office/drawing/2014/main" id="{BFFE51FA-CDA2-47CA-934F-B9344A437427}"/>
               </a:ext>
             </a:extLst>
           </p:cNvPr>
@@ -3526,7 +3526,7 @@
           <p:cNvPr id="7" name="">
             <a:extLst xmlns:a="http://schemas.openxmlformats.org/drawingml/2006/main">
               <a:ext uri="{FF2B5EF4-FFF2-40B4-BE49-F238E27FC236}">
-                <a16:creationId xmlns:a16="http://schemas.microsoft.com/office/drawing/2014/main" id="{B73C371C-F034-42FA-9CAC-2DD80F1E8E6F}"/>
+                <a16:creationId xmlns:a16="http://schemas.microsoft.com/office/drawing/2014/main" id="{7F99E964-8904-4443-89AE-86E3DBF27FF3}"/>
               </a:ext>
             </a:extLst>
           </p:cNvPr>
@@ -3576,7 +3576,7 @@
           <p:cNvPr id="8" name="">
             <a:extLst xmlns:a="http://schemas.openxmlformats.org/drawingml/2006/main">
               <a:ext uri="{FF2B5EF4-FFF2-40B4-BE49-F238E27FC236}">
-                <a16:creationId xmlns:a16="http://schemas.microsoft.com/office/drawing/2014/main" id="{0C56F257-E316-486C-90F2-0653243E0E88}"/>
+                <a16:creationId xmlns:a16="http://schemas.microsoft.com/office/drawing/2014/main" id="{8D49FEC8-9F3A-427C-8C33-BE81221A9A71}"/>
               </a:ext>
             </a:extLst>
           </p:cNvPr>
@@ -3626,7 +3626,7 @@
           <p:cNvPr id="9" name="">
             <a:extLst xmlns:a="http://schemas.openxmlformats.org/drawingml/2006/main">
               <a:ext uri="{FF2B5EF4-FFF2-40B4-BE49-F238E27FC236}">
-                <a16:creationId xmlns:a16="http://schemas.microsoft.com/office/drawing/2014/main" id="{9ABA888D-BF19-4FCC-92C9-11A9674B3A2D}"/>
+                <a16:creationId xmlns:a16="http://schemas.microsoft.com/office/drawing/2014/main" id="{B8F7EF88-EF1A-4FBC-97EC-C2E3EE5B118F}"/>
               </a:ext>
             </a:extLst>
           </p:cNvPr>
@@ -3663,7 +3663,7 @@
           <p:cNvPr id="10" name="">
             <a:extLst xmlns:a="http://schemas.openxmlformats.org/drawingml/2006/main">
               <a:ext uri="{FF2B5EF4-FFF2-40B4-BE49-F238E27FC236}">
-                <a16:creationId xmlns:a16="http://schemas.microsoft.com/office/drawing/2014/main" id="{1659277D-D4B0-4FB8-BAEE-8DF6C920C197}"/>
+                <a16:creationId xmlns:a16="http://schemas.microsoft.com/office/drawing/2014/main" id="{768B7032-50E6-49BF-A58E-7BA637EB78F0}"/>
               </a:ext>
             </a:extLst>
           </p:cNvPr>
@@ -3713,7 +3713,7 @@
           <p:cNvPr id="11" name="">
             <a:extLst xmlns:a="http://schemas.openxmlformats.org/drawingml/2006/main">
               <a:ext uri="{FF2B5EF4-FFF2-40B4-BE49-F238E27FC236}">
-                <a16:creationId xmlns:a16="http://schemas.microsoft.com/office/drawing/2014/main" id="{EFB5AB5E-92BF-41E5-B73E-01E3F0F6D615}"/>
+                <a16:creationId xmlns:a16="http://schemas.microsoft.com/office/drawing/2014/main" id="{502F9558-6D4F-4F38-9C93-A4114F773843}"/>
               </a:ext>
             </a:extLst>
           </p:cNvPr>
@@ -3763,7 +3763,7 @@
           <p:cNvPr id="12" name="">
             <a:extLst xmlns:a="http://schemas.openxmlformats.org/drawingml/2006/main">
               <a:ext uri="{FF2B5EF4-FFF2-40B4-BE49-F238E27FC236}">
-                <a16:creationId xmlns:a16="http://schemas.microsoft.com/office/drawing/2014/main" id="{28AC9BD5-4AEA-4818-887C-264C0D1E860D}"/>
+                <a16:creationId xmlns:a16="http://schemas.microsoft.com/office/drawing/2014/main" id="{AC6B6284-0387-451C-B53B-8A910C4A1695}"/>
               </a:ext>
             </a:extLst>
           </p:cNvPr>
@@ -3800,7 +3800,7 @@
           <p:cNvPr id="13" name="">
             <a:extLst xmlns:a="http://schemas.openxmlformats.org/drawingml/2006/main">
               <a:ext uri="{FF2B5EF4-FFF2-40B4-BE49-F238E27FC236}">
-                <a16:creationId xmlns:a16="http://schemas.microsoft.com/office/drawing/2014/main" id="{E197CA6E-8F05-4309-AB32-A42FD2E2A457}"/>
+                <a16:creationId xmlns:a16="http://schemas.microsoft.com/office/drawing/2014/main" id="{012136F1-CC16-4BEF-B5F1-D6CF384FB793}"/>
               </a:ext>
             </a:extLst>
           </p:cNvPr>
@@ -3850,7 +3850,7 @@
           <p:cNvPr id="14" name="">
             <a:extLst xmlns:a="http://schemas.openxmlformats.org/drawingml/2006/main">
               <a:ext uri="{FF2B5EF4-FFF2-40B4-BE49-F238E27FC236}">
-                <a16:creationId xmlns:a16="http://schemas.microsoft.com/office/drawing/2014/main" id="{6971F78C-E738-48D4-9133-7CAC943C8D6E}"/>
+                <a16:creationId xmlns:a16="http://schemas.microsoft.com/office/drawing/2014/main" id="{D9930D2B-88D8-4DA4-BB07-6E0E153CCCFA}"/>
               </a:ext>
             </a:extLst>
           </p:cNvPr>
@@ -3900,7 +3900,7 @@
           <p:cNvPr id="15" name="">
             <a:extLst xmlns:a="http://schemas.openxmlformats.org/drawingml/2006/main">
               <a:ext uri="{FF2B5EF4-FFF2-40B4-BE49-F238E27FC236}">
-                <a16:creationId xmlns:a16="http://schemas.microsoft.com/office/drawing/2014/main" id="{6086F9F8-5A20-4B4C-9BF9-EC74AC4BD6EF}"/>
+                <a16:creationId xmlns:a16="http://schemas.microsoft.com/office/drawing/2014/main" id="{6E4B0AE5-D1AB-493A-9759-945536DC2B7F}"/>
               </a:ext>
             </a:extLst>
           </p:cNvPr>
@@ -3937,7 +3937,7 @@
           <p:cNvPr id="16" name="">
             <a:extLst xmlns:a="http://schemas.openxmlformats.org/drawingml/2006/main">
               <a:ext uri="{FF2B5EF4-FFF2-40B4-BE49-F238E27FC236}">
-                <a16:creationId xmlns:a16="http://schemas.microsoft.com/office/drawing/2014/main" id="{0BD4CEAC-8DDE-4B5F-BFB3-6E1821FC4B5A}"/>
+                <a16:creationId xmlns:a16="http://schemas.microsoft.com/office/drawing/2014/main" id="{B8241D08-80EA-41D1-8E9B-94B6635E8CE5}"/>
               </a:ext>
             </a:extLst>
           </p:cNvPr>
@@ -3987,7 +3987,7 @@
           <p:cNvPr id="17" name="">
             <a:extLst xmlns:a="http://schemas.openxmlformats.org/drawingml/2006/main">
               <a:ext uri="{FF2B5EF4-FFF2-40B4-BE49-F238E27FC236}">
-                <a16:creationId xmlns:a16="http://schemas.microsoft.com/office/drawing/2014/main" id="{42B56846-E552-4A85-B1BB-274A7B193A07}"/>
+                <a16:creationId xmlns:a16="http://schemas.microsoft.com/office/drawing/2014/main" id="{7112DF7A-832C-4F78-B6C4-6966FD4FA816}"/>
               </a:ext>
             </a:extLst>
           </p:cNvPr>
@@ -4037,7 +4037,7 @@
           <p:cNvPr id="18" name="">
             <a:extLst xmlns:a="http://schemas.openxmlformats.org/drawingml/2006/main">
               <a:ext uri="{FF2B5EF4-FFF2-40B4-BE49-F238E27FC236}">
-                <a16:creationId xmlns:a16="http://schemas.microsoft.com/office/drawing/2014/main" id="{06660057-8156-47D4-9EEB-440CAEBF54A4}"/>
+                <a16:creationId xmlns:a16="http://schemas.microsoft.com/office/drawing/2014/main" id="{DCFC5226-D261-4B77-92AB-35A28824134E}"/>
               </a:ext>
             </a:extLst>
           </p:cNvPr>
@@ -4074,7 +4074,7 @@
           <p:cNvPr id="19" name="">
             <a:extLst xmlns:a="http://schemas.openxmlformats.org/drawingml/2006/main">
               <a:ext uri="{FF2B5EF4-FFF2-40B4-BE49-F238E27FC236}">
-                <a16:creationId xmlns:a16="http://schemas.microsoft.com/office/drawing/2014/main" id="{13534E71-4FEB-45A2-9F9F-F2503C4FAB85}"/>
+                <a16:creationId xmlns:a16="http://schemas.microsoft.com/office/drawing/2014/main" id="{B5DF0252-0D21-4822-BB1B-73B0ADECF45E}"/>
               </a:ext>
             </a:extLst>
           </p:cNvPr>
@@ -4124,7 +4124,7 @@
           <p:cNvPr id="20" name="">
             <a:extLst xmlns:a="http://schemas.openxmlformats.org/drawingml/2006/main">
               <a:ext uri="{FF2B5EF4-FFF2-40B4-BE49-F238E27FC236}">
-                <a16:creationId xmlns:a16="http://schemas.microsoft.com/office/drawing/2014/main" id="{B178F9F2-B959-4BFE-B005-AC5A6A6C43AD}"/>
+                <a16:creationId xmlns:a16="http://schemas.microsoft.com/office/drawing/2014/main" id="{9453BB4D-3BA2-4B5D-88C8-B644CFF00637}"/>
               </a:ext>
             </a:extLst>
           </p:cNvPr>
@@ -4172,7 +4172,7 @@
     </p:spTree>
     <p:extLst>
       <p:ext uri="{BB962C8B-B14F-4D97-AF65-F5344CB8AC3E}">
-        <p14:creationId xmlns:p14="http://schemas.microsoft.com/office/powerpoint/2010/main" val="792222316"/>
+        <p14:creationId xmlns:p14="http://schemas.microsoft.com/office/powerpoint/2010/main" val="411857737"/>
       </p:ext>
     </p:extLst>
   </p:cSld>
@@ -4203,7 +4203,7 @@
           <p:cNvPr id="8" name="">
             <a:extLst xmlns:a="http://schemas.openxmlformats.org/drawingml/2006/main">
               <a:ext uri="{FF2B5EF4-FFF2-40B4-BE49-F238E27FC236}">
-                <a16:creationId xmlns:a16="http://schemas.microsoft.com/office/drawing/2014/main" id="{4FE2E68C-A0B1-4169-B453-46DD63BA625A}"/>
+                <a16:creationId xmlns:a16="http://schemas.microsoft.com/office/drawing/2014/main" id="{C88E54B7-9A53-46E1-9C1C-5C0E5A7418D5}"/>
               </a:ext>
             </a:extLst>
           </p:cNvPr>
@@ -4253,7 +4253,7 @@
           <p:cNvPr id="2" name="">
             <a:extLst xmlns:a="http://schemas.openxmlformats.org/drawingml/2006/main">
               <a:ext uri="{FF2B5EF4-FFF2-40B4-BE49-F238E27FC236}">
-                <a16:creationId xmlns:a16="http://schemas.microsoft.com/office/drawing/2014/main" id="{7AC51DD2-2701-46C9-8E40-E67C134AC1E1}"/>
+                <a16:creationId xmlns:a16="http://schemas.microsoft.com/office/drawing/2014/main" id="{01FB2C9E-0837-4161-A8FD-755E83C23B30}"/>
               </a:ext>
             </a:extLst>
           </p:cNvPr>
@@ -4303,7 +4303,7 @@
           <p:cNvPr id="3" name="">
             <a:extLst xmlns:a="http://schemas.openxmlformats.org/drawingml/2006/main">
               <a:ext uri="{FF2B5EF4-FFF2-40B4-BE49-F238E27FC236}">
-                <a16:creationId xmlns:a16="http://schemas.microsoft.com/office/drawing/2014/main" id="{FF656241-100A-4197-B917-BEB333096B46}"/>
+                <a16:creationId xmlns:a16="http://schemas.microsoft.com/office/drawing/2014/main" id="{82731AF0-2845-4C20-823E-9098DE80E376}"/>
               </a:ext>
             </a:extLst>
           </p:cNvPr>
@@ -4353,7 +4353,7 @@
           <p:cNvPr id="4" name="">
             <a:extLst xmlns:a="http://schemas.openxmlformats.org/drawingml/2006/main">
               <a:ext uri="{FF2B5EF4-FFF2-40B4-BE49-F238E27FC236}">
-                <a16:creationId xmlns:a16="http://schemas.microsoft.com/office/drawing/2014/main" id="{B58C8DC3-A5E3-47DE-B33E-C53AB0DA5A13}"/>
+                <a16:creationId xmlns:a16="http://schemas.microsoft.com/office/drawing/2014/main" id="{C0442DF2-A7ED-4D4B-9243-9DDE642EA229}"/>
               </a:ext>
             </a:extLst>
           </p:cNvPr>
@@ -4384,7 +4384,7 @@
           <p:cNvPr id="5" name="">
             <a:extLst xmlns:a="http://schemas.openxmlformats.org/drawingml/2006/main">
               <a:ext uri="{FF2B5EF4-FFF2-40B4-BE49-F238E27FC236}">
-                <a16:creationId xmlns:a16="http://schemas.microsoft.com/office/drawing/2014/main" id="{37317916-0DCF-4D92-BE09-DC70CACC0672}"/>
+                <a16:creationId xmlns:a16="http://schemas.microsoft.com/office/drawing/2014/main" id="{12D52EBE-6BA8-4EF4-9E6D-B9CD16ED8784}"/>
               </a:ext>
             </a:extLst>
           </p:cNvPr>
@@ -4419,7 +4419,7 @@
           <p:cNvPr id="6" name="">
             <a:extLst xmlns:a="http://schemas.openxmlformats.org/drawingml/2006/main">
               <a:ext uri="{FF2B5EF4-FFF2-40B4-BE49-F238E27FC236}">
-                <a16:creationId xmlns:a16="http://schemas.microsoft.com/office/drawing/2014/main" id="{00EFA389-9C18-40A1-B53C-9561B49B7141}"/>
+                <a16:creationId xmlns:a16="http://schemas.microsoft.com/office/drawing/2014/main" id="{8A836A4B-B376-48F0-ABEF-7BFFF6C0E123}"/>
               </a:ext>
             </a:extLst>
           </p:cNvPr>
@@ -4469,7 +4469,7 @@
           <p:cNvPr id="7" name="">
             <a:extLst xmlns:a="http://schemas.openxmlformats.org/drawingml/2006/main">
               <a:ext uri="{FF2B5EF4-FFF2-40B4-BE49-F238E27FC236}">
-                <a16:creationId xmlns:a16="http://schemas.microsoft.com/office/drawing/2014/main" id="{CA236637-956C-4504-85E4-F466C485C16F}"/>
+                <a16:creationId xmlns:a16="http://schemas.microsoft.com/office/drawing/2014/main" id="{D16DACCA-D707-4CEB-949E-C623E2A3620E}"/>
               </a:ext>
             </a:extLst>
           </p:cNvPr>
@@ -4517,7 +4517,7 @@
     </p:spTree>
     <p:extLst>
       <p:ext uri="{BB962C8B-B14F-4D97-AF65-F5344CB8AC3E}">
-        <p14:creationId xmlns:p14="http://schemas.microsoft.com/office/powerpoint/2010/main" val="400046977"/>
+        <p14:creationId xmlns:p14="http://schemas.microsoft.com/office/powerpoint/2010/main" val="1841875382"/>
       </p:ext>
     </p:extLst>
   </p:cSld>
@@ -4548,7 +4548,7 @@
           <p:cNvPr id="14" name="">
             <a:extLst xmlns:a="http://schemas.openxmlformats.org/drawingml/2006/main">
               <a:ext uri="{FF2B5EF4-FFF2-40B4-BE49-F238E27FC236}">
-                <a16:creationId xmlns:a16="http://schemas.microsoft.com/office/drawing/2014/main" id="{32BB0D2D-0B57-4035-84DA-9273CE92C846}"/>
+                <a16:creationId xmlns:a16="http://schemas.microsoft.com/office/drawing/2014/main" id="{A11FBF76-F8E7-4A44-B2A8-E9439CDA5F5F}"/>
               </a:ext>
             </a:extLst>
           </p:cNvPr>
@@ -4598,7 +4598,7 @@
           <p:cNvPr id="2" name="">
             <a:extLst xmlns:a="http://schemas.openxmlformats.org/drawingml/2006/main">
               <a:ext uri="{FF2B5EF4-FFF2-40B4-BE49-F238E27FC236}">
-                <a16:creationId xmlns:a16="http://schemas.microsoft.com/office/drawing/2014/main" id="{EC9642D8-76AE-4419-8C7F-D36814803E2C}"/>
+                <a16:creationId xmlns:a16="http://schemas.microsoft.com/office/drawing/2014/main" id="{5428C5D2-61BA-4395-8AB4-F9F2C6DDB250}"/>
               </a:ext>
             </a:extLst>
           </p:cNvPr>
@@ -4648,7 +4648,7 @@
           <p:cNvPr id="3" name="">
             <a:extLst xmlns:a="http://schemas.openxmlformats.org/drawingml/2006/main">
               <a:ext uri="{FF2B5EF4-FFF2-40B4-BE49-F238E27FC236}">
-                <a16:creationId xmlns:a16="http://schemas.microsoft.com/office/drawing/2014/main" id="{509CCCA1-0BCE-4EBE-98BB-120552013B62}"/>
+                <a16:creationId xmlns:a16="http://schemas.microsoft.com/office/drawing/2014/main" id="{E295EA55-B1A1-4282-A20A-301C40E82B19}"/>
               </a:ext>
             </a:extLst>
           </p:cNvPr>
@@ -4698,7 +4698,7 @@
           <p:cNvPr id="4" name="">
             <a:extLst xmlns:a="http://schemas.openxmlformats.org/drawingml/2006/main">
               <a:ext uri="{FF2B5EF4-FFF2-40B4-BE49-F238E27FC236}">
-                <a16:creationId xmlns:a16="http://schemas.microsoft.com/office/drawing/2014/main" id="{B6120DFE-69AE-461C-83F1-5930412A2D4D}"/>
+                <a16:creationId xmlns:a16="http://schemas.microsoft.com/office/drawing/2014/main" id="{E8493AE6-3FB0-44B7-BC5E-242F687375FF}"/>
               </a:ext>
             </a:extLst>
           </p:cNvPr>
@@ -4729,7 +4729,7 @@
           <p:cNvPr id="5" name="">
             <a:extLst xmlns:a="http://schemas.openxmlformats.org/drawingml/2006/main">
               <a:ext uri="{FF2B5EF4-FFF2-40B4-BE49-F238E27FC236}">
-                <a16:creationId xmlns:a16="http://schemas.microsoft.com/office/drawing/2014/main" id="{79B080BB-734A-411F-834C-AE9E5310F022}"/>
+                <a16:creationId xmlns:a16="http://schemas.microsoft.com/office/drawing/2014/main" id="{68F9866F-12A4-44DD-870E-5CFFC96628AD}"/>
               </a:ext>
             </a:extLst>
           </p:cNvPr>
@@ -4779,7 +4779,7 @@
           <p:cNvPr id="6" name="">
             <a:extLst xmlns:a="http://schemas.openxmlformats.org/drawingml/2006/main">
               <a:ext uri="{FF2B5EF4-FFF2-40B4-BE49-F238E27FC236}">
-                <a16:creationId xmlns:a16="http://schemas.microsoft.com/office/drawing/2014/main" id="{C2660902-4673-4049-A149-817CEEB5AB5F}"/>
+                <a16:creationId xmlns:a16="http://schemas.microsoft.com/office/drawing/2014/main" id="{EB2FFE78-A05F-4ABB-B7DA-8FC155132CC5}"/>
               </a:ext>
             </a:extLst>
           </p:cNvPr>
@@ -4814,7 +4814,7 @@
           <p:cNvPr id="7" name="">
             <a:extLst xmlns:a="http://schemas.openxmlformats.org/drawingml/2006/main">
               <a:ext uri="{FF2B5EF4-FFF2-40B4-BE49-F238E27FC236}">
-                <a16:creationId xmlns:a16="http://schemas.microsoft.com/office/drawing/2014/main" id="{055A31B9-A7A1-4850-B11C-DCC6CAD652A0}"/>
+                <a16:creationId xmlns:a16="http://schemas.microsoft.com/office/drawing/2014/main" id="{3BAF6B1A-5B67-4975-89CE-5E1048121661}"/>
               </a:ext>
             </a:extLst>
           </p:cNvPr>
@@ -4864,7 +4864,7 @@
           <p:cNvPr id="8" name="">
             <a:extLst xmlns:a="http://schemas.openxmlformats.org/drawingml/2006/main">
               <a:ext uri="{FF2B5EF4-FFF2-40B4-BE49-F238E27FC236}">
-                <a16:creationId xmlns:a16="http://schemas.microsoft.com/office/drawing/2014/main" id="{2AE7EBEE-092B-4539-B0E5-2D5E0380A6F8}"/>
+                <a16:creationId xmlns:a16="http://schemas.microsoft.com/office/drawing/2014/main" id="{BC102A6F-65D6-44B1-A3AE-C19BA2001234}"/>
               </a:ext>
             </a:extLst>
           </p:cNvPr>
@@ -4901,7 +4901,7 @@
           <p:cNvPr id="9" name="">
             <a:extLst xmlns:a="http://schemas.openxmlformats.org/drawingml/2006/main">
               <a:ext uri="{FF2B5EF4-FFF2-40B4-BE49-F238E27FC236}">
-                <a16:creationId xmlns:a16="http://schemas.microsoft.com/office/drawing/2014/main" id="{74060F69-F4EE-49C7-984A-A00D53BD1B7B}"/>
+                <a16:creationId xmlns:a16="http://schemas.microsoft.com/office/drawing/2014/main" id="{6C2B313B-5677-473E-A974-F68D004F3D7E}"/>
               </a:ext>
             </a:extLst>
           </p:cNvPr>
@@ -4951,7 +4951,7 @@
           <p:cNvPr id="10" name="">
             <a:extLst xmlns:a="http://schemas.openxmlformats.org/drawingml/2006/main">
               <a:ext uri="{FF2B5EF4-FFF2-40B4-BE49-F238E27FC236}">
-                <a16:creationId xmlns:a16="http://schemas.microsoft.com/office/drawing/2014/main" id="{EEE19CEB-3729-4484-9E59-F5A09F686FB5}"/>
+                <a16:creationId xmlns:a16="http://schemas.microsoft.com/office/drawing/2014/main" id="{BDC37633-B6DF-4B20-9109-099CB1FD10AB}"/>
               </a:ext>
             </a:extLst>
           </p:cNvPr>
@@ -5001,7 +5001,7 @@
           <p:cNvPr id="11" name="">
             <a:extLst xmlns:a="http://schemas.openxmlformats.org/drawingml/2006/main">
               <a:ext uri="{FF2B5EF4-FFF2-40B4-BE49-F238E27FC236}">
-                <a16:creationId xmlns:a16="http://schemas.microsoft.com/office/drawing/2014/main" id="{F539674C-C79E-44E6-A834-D7F965A93554}"/>
+                <a16:creationId xmlns:a16="http://schemas.microsoft.com/office/drawing/2014/main" id="{59B43855-119E-49AC-8516-545C8B3A7B7D}"/>
               </a:ext>
             </a:extLst>
           </p:cNvPr>
@@ -5051,7 +5051,7 @@
           <p:cNvPr id="12" name="">
             <a:extLst xmlns:a="http://schemas.openxmlformats.org/drawingml/2006/main">
               <a:ext uri="{FF2B5EF4-FFF2-40B4-BE49-F238E27FC236}">
-                <a16:creationId xmlns:a16="http://schemas.microsoft.com/office/drawing/2014/main" id="{618322BB-3FB5-4D25-AF01-886F615D8897}"/>
+                <a16:creationId xmlns:a16="http://schemas.microsoft.com/office/drawing/2014/main" id="{7636CCBA-8E36-4A9A-948D-AB2B9559B880}"/>
               </a:ext>
             </a:extLst>
           </p:cNvPr>
@@ -5101,7 +5101,7 @@
           <p:cNvPr id="13" name="">
             <a:extLst xmlns:a="http://schemas.openxmlformats.org/drawingml/2006/main">
               <a:ext uri="{FF2B5EF4-FFF2-40B4-BE49-F238E27FC236}">
-                <a16:creationId xmlns:a16="http://schemas.microsoft.com/office/drawing/2014/main" id="{C6CDE18F-3ABC-4A2C-9D50-D428854B6080}"/>
+                <a16:creationId xmlns:a16="http://schemas.microsoft.com/office/drawing/2014/main" id="{6D550A52-4DE3-497F-B48B-26D40184BEAB}"/>
               </a:ext>
             </a:extLst>
           </p:cNvPr>
@@ -5149,7 +5149,7 @@
     </p:spTree>
     <p:extLst>
       <p:ext uri="{BB962C8B-B14F-4D97-AF65-F5344CB8AC3E}">
-        <p14:creationId xmlns:p14="http://schemas.microsoft.com/office/powerpoint/2010/main" val="1126377463"/>
+        <p14:creationId xmlns:p14="http://schemas.microsoft.com/office/powerpoint/2010/main" val="461803229"/>
       </p:ext>
     </p:extLst>
   </p:cSld>
@@ -5180,7 +5180,7 @@
           <p:cNvPr id="16" name="">
             <a:extLst xmlns:a="http://schemas.openxmlformats.org/drawingml/2006/main">
               <a:ext uri="{FF2B5EF4-FFF2-40B4-BE49-F238E27FC236}">
-                <a16:creationId xmlns:a16="http://schemas.microsoft.com/office/drawing/2014/main" id="{30FECDDC-26D0-4F37-A3E1-3841616C95C4}"/>
+                <a16:creationId xmlns:a16="http://schemas.microsoft.com/office/drawing/2014/main" id="{3D39AFE7-CF8E-423E-A6D8-7211B0CC4C41}"/>
               </a:ext>
             </a:extLst>
           </p:cNvPr>
@@ -5230,7 +5230,7 @@
           <p:cNvPr id="2" name="">
             <a:extLst xmlns:a="http://schemas.openxmlformats.org/drawingml/2006/main">
               <a:ext uri="{FF2B5EF4-FFF2-40B4-BE49-F238E27FC236}">
-                <a16:creationId xmlns:a16="http://schemas.microsoft.com/office/drawing/2014/main" id="{D99E4711-9E96-4099-97E5-ECB92FC385FA}"/>
+                <a16:creationId xmlns:a16="http://schemas.microsoft.com/office/drawing/2014/main" id="{9936A23A-9414-489C-8C92-965719B83213}"/>
               </a:ext>
             </a:extLst>
           </p:cNvPr>
@@ -5280,7 +5280,7 @@
           <p:cNvPr id="3" name="">
             <a:extLst xmlns:a="http://schemas.openxmlformats.org/drawingml/2006/main">
               <a:ext uri="{FF2B5EF4-FFF2-40B4-BE49-F238E27FC236}">
-                <a16:creationId xmlns:a16="http://schemas.microsoft.com/office/drawing/2014/main" id="{6E29146F-D3CA-41F7-9955-8788BF19020E}"/>
+                <a16:creationId xmlns:a16="http://schemas.microsoft.com/office/drawing/2014/main" id="{A80C7981-D330-4181-920E-34870D8F91C0}"/>
               </a:ext>
             </a:extLst>
           </p:cNvPr>
@@ -5330,7 +5330,7 @@
           <p:cNvPr id="4" name="">
             <a:extLst xmlns:a="http://schemas.openxmlformats.org/drawingml/2006/main">
               <a:ext uri="{FF2B5EF4-FFF2-40B4-BE49-F238E27FC236}">
-                <a16:creationId xmlns:a16="http://schemas.microsoft.com/office/drawing/2014/main" id="{8AA9F7A3-4054-4A28-94C9-91F3BF883505}"/>
+                <a16:creationId xmlns:a16="http://schemas.microsoft.com/office/drawing/2014/main" id="{41236F1D-4481-4E53-89B4-C47F72D23A80}"/>
               </a:ext>
             </a:extLst>
           </p:cNvPr>
@@ -5361,7 +5361,7 @@
           <p:cNvPr id="5" name="">
             <a:extLst xmlns:a="http://schemas.openxmlformats.org/drawingml/2006/main">
               <a:ext uri="{FF2B5EF4-FFF2-40B4-BE49-F238E27FC236}">
-                <a16:creationId xmlns:a16="http://schemas.microsoft.com/office/drawing/2014/main" id="{79D914D5-5B2B-40AE-BEE3-BF23F0D75503}"/>
+                <a16:creationId xmlns:a16="http://schemas.microsoft.com/office/drawing/2014/main" id="{DA5F489B-68AF-48A8-A936-848A35E992FA}"/>
               </a:ext>
             </a:extLst>
           </p:cNvPr>
@@ -5411,7 +5411,7 @@
           <p:cNvPr id="6" name="">
             <a:extLst xmlns:a="http://schemas.openxmlformats.org/drawingml/2006/main">
               <a:ext uri="{FF2B5EF4-FFF2-40B4-BE49-F238E27FC236}">
-                <a16:creationId xmlns:a16="http://schemas.microsoft.com/office/drawing/2014/main" id="{66A28514-3B66-432F-98E1-A3639707E2D5}"/>
+                <a16:creationId xmlns:a16="http://schemas.microsoft.com/office/drawing/2014/main" id="{081C5EFE-90F0-46A7-8C67-ED8570D9BD31}"/>
               </a:ext>
             </a:extLst>
           </p:cNvPr>
@@ -5461,7 +5461,7 @@
           <p:cNvPr id="7" name="">
             <a:extLst xmlns:a="http://schemas.openxmlformats.org/drawingml/2006/main">
               <a:ext uri="{FF2B5EF4-FFF2-40B4-BE49-F238E27FC236}">
-                <a16:creationId xmlns:a16="http://schemas.microsoft.com/office/drawing/2014/main" id="{922D2643-F9EA-401A-976D-F9ED1A7393EF}"/>
+                <a16:creationId xmlns:a16="http://schemas.microsoft.com/office/drawing/2014/main" id="{D9BD5665-2E1B-43EC-BF80-6BD8A36E9F75}"/>
               </a:ext>
             </a:extLst>
           </p:cNvPr>
@@ -5492,7 +5492,7 @@
           <p:cNvPr id="8" name="">
             <a:extLst xmlns:a="http://schemas.openxmlformats.org/drawingml/2006/main">
               <a:ext uri="{FF2B5EF4-FFF2-40B4-BE49-F238E27FC236}">
-                <a16:creationId xmlns:a16="http://schemas.microsoft.com/office/drawing/2014/main" id="{F01D8017-E0F1-4588-ADDB-45503FB3746C}"/>
+                <a16:creationId xmlns:a16="http://schemas.microsoft.com/office/drawing/2014/main" id="{443CFF1D-380C-4EAF-93FF-6862537C32B4}"/>
               </a:ext>
             </a:extLst>
           </p:cNvPr>
@@ -5542,7 +5542,7 @@
           <p:cNvPr id="9" name="">
             <a:extLst xmlns:a="http://schemas.openxmlformats.org/drawingml/2006/main">
               <a:ext uri="{FF2B5EF4-FFF2-40B4-BE49-F238E27FC236}">
-                <a16:creationId xmlns:a16="http://schemas.microsoft.com/office/drawing/2014/main" id="{E0E97376-AE9A-4B2E-B783-9923BBF68376}"/>
+                <a16:creationId xmlns:a16="http://schemas.microsoft.com/office/drawing/2014/main" id="{B1F6C3CE-067E-476B-8B98-C0ADF7C4D896}"/>
               </a:ext>
             </a:extLst>
           </p:cNvPr>
@@ -5573,7 +5573,7 @@
           <p:cNvPr id="10" name="">
             <a:extLst xmlns:a="http://schemas.openxmlformats.org/drawingml/2006/main">
               <a:ext uri="{FF2B5EF4-FFF2-40B4-BE49-F238E27FC236}">
-                <a16:creationId xmlns:a16="http://schemas.microsoft.com/office/drawing/2014/main" id="{D45BBEE7-0B55-4114-A217-F50A209461D0}"/>
+                <a16:creationId xmlns:a16="http://schemas.microsoft.com/office/drawing/2014/main" id="{7523F1A2-B2D4-41EF-A8FA-0E8F69F1120A}"/>
               </a:ext>
             </a:extLst>
           </p:cNvPr>
@@ -5623,7 +5623,7 @@
           <p:cNvPr id="11" name="">
             <a:extLst xmlns:a="http://schemas.openxmlformats.org/drawingml/2006/main">
               <a:ext uri="{FF2B5EF4-FFF2-40B4-BE49-F238E27FC236}">
-                <a16:creationId xmlns:a16="http://schemas.microsoft.com/office/drawing/2014/main" id="{8CF00702-B7FA-4D13-AE2D-867AC7DCB96B}"/>
+                <a16:creationId xmlns:a16="http://schemas.microsoft.com/office/drawing/2014/main" id="{8341288F-3665-498B-A4DB-AA3D025773AF}"/>
               </a:ext>
             </a:extLst>
           </p:cNvPr>
@@ -5654,7 +5654,7 @@
           <p:cNvPr id="12" name="">
             <a:extLst xmlns:a="http://schemas.openxmlformats.org/drawingml/2006/main">
               <a:ext uri="{FF2B5EF4-FFF2-40B4-BE49-F238E27FC236}">
-                <a16:creationId xmlns:a16="http://schemas.microsoft.com/office/drawing/2014/main" id="{907D5101-B8A7-4769-884B-7FB87BFE5976}"/>
+                <a16:creationId xmlns:a16="http://schemas.microsoft.com/office/drawing/2014/main" id="{303B9DFE-F674-4242-B177-C739A5F94119}"/>
               </a:ext>
             </a:extLst>
           </p:cNvPr>
@@ -5704,7 +5704,7 @@
           <p:cNvPr id="13" name="">
             <a:extLst xmlns:a="http://schemas.openxmlformats.org/drawingml/2006/main">
               <a:ext uri="{FF2B5EF4-FFF2-40B4-BE49-F238E27FC236}">
-                <a16:creationId xmlns:a16="http://schemas.microsoft.com/office/drawing/2014/main" id="{B8F522D3-E272-45A8-84E1-405D1BAD3A2C}"/>
+                <a16:creationId xmlns:a16="http://schemas.microsoft.com/office/drawing/2014/main" id="{542750AB-131A-48D6-ADCE-216ED8C357D3}"/>
               </a:ext>
             </a:extLst>
           </p:cNvPr>
@@ -5735,7 +5735,7 @@
           <p:cNvPr id="14" name="">
             <a:extLst xmlns:a="http://schemas.openxmlformats.org/drawingml/2006/main">
               <a:ext uri="{FF2B5EF4-FFF2-40B4-BE49-F238E27FC236}">
-                <a16:creationId xmlns:a16="http://schemas.microsoft.com/office/drawing/2014/main" id="{6DD87FD3-D98C-4D12-AAAC-247B020DCB06}"/>
+                <a16:creationId xmlns:a16="http://schemas.microsoft.com/office/drawing/2014/main" id="{E0EACDDE-3434-4D03-B933-3A998E97AA8B}"/>
               </a:ext>
             </a:extLst>
           </p:cNvPr>
@@ -5785,7 +5785,7 @@
           <p:cNvPr id="15" name="">
             <a:extLst xmlns:a="http://schemas.openxmlformats.org/drawingml/2006/main">
               <a:ext uri="{FF2B5EF4-FFF2-40B4-BE49-F238E27FC236}">
-                <a16:creationId xmlns:a16="http://schemas.microsoft.com/office/drawing/2014/main" id="{064488CA-19E3-4F82-AD5B-88E99C8D9BD9}"/>
+                <a16:creationId xmlns:a16="http://schemas.microsoft.com/office/drawing/2014/main" id="{EB95B2E4-6F9F-43E5-8919-6FA6637C9923}"/>
               </a:ext>
             </a:extLst>
           </p:cNvPr>
@@ -5814,7 +5814,7 @@
     </p:spTree>
     <p:extLst>
       <p:ext uri="{BB962C8B-B14F-4D97-AF65-F5344CB8AC3E}">
-        <p14:creationId xmlns:p14="http://schemas.microsoft.com/office/powerpoint/2010/main" val="1608800789"/>
+        <p14:creationId xmlns:p14="http://schemas.microsoft.com/office/powerpoint/2010/main" val="648090529"/>
       </p:ext>
     </p:extLst>
   </p:cSld>
@@ -5845,7 +5845,7 @@
           <p:cNvPr id="19" name="">
             <a:extLst xmlns:a="http://schemas.openxmlformats.org/drawingml/2006/main">
               <a:ext uri="{FF2B5EF4-FFF2-40B4-BE49-F238E27FC236}">
-                <a16:creationId xmlns:a16="http://schemas.microsoft.com/office/drawing/2014/main" id="{88C70BAA-8170-4B23-88F1-3535E31F5AF1}"/>
+                <a16:creationId xmlns:a16="http://schemas.microsoft.com/office/drawing/2014/main" id="{FC71A354-429F-45CB-9DC5-BE98328D7C57}"/>
               </a:ext>
             </a:extLst>
           </p:cNvPr>
@@ -5895,7 +5895,7 @@
           <p:cNvPr id="2" name="">
             <a:extLst xmlns:a="http://schemas.openxmlformats.org/drawingml/2006/main">
               <a:ext uri="{FF2B5EF4-FFF2-40B4-BE49-F238E27FC236}">
-                <a16:creationId xmlns:a16="http://schemas.microsoft.com/office/drawing/2014/main" id="{9DD36D68-B1D6-4CAC-AF74-D4D70DD68F39}"/>
+                <a16:creationId xmlns:a16="http://schemas.microsoft.com/office/drawing/2014/main" id="{19008CCE-B68B-4989-997F-98CDAD68C8F6}"/>
               </a:ext>
             </a:extLst>
           </p:cNvPr>
@@ -5945,7 +5945,7 @@
           <p:cNvPr id="3" name="">
             <a:extLst xmlns:a="http://schemas.openxmlformats.org/drawingml/2006/main">
               <a:ext uri="{FF2B5EF4-FFF2-40B4-BE49-F238E27FC236}">
-                <a16:creationId xmlns:a16="http://schemas.microsoft.com/office/drawing/2014/main" id="{2E4EA899-025D-4506-B139-CD09AFEC5850}"/>
+                <a16:creationId xmlns:a16="http://schemas.microsoft.com/office/drawing/2014/main" id="{8EF6C215-7F87-4FD5-BD25-FCF685E8228A}"/>
               </a:ext>
             </a:extLst>
           </p:cNvPr>
@@ -5995,7 +5995,7 @@
           <p:cNvPr id="4" name="">
             <a:extLst xmlns:a="http://schemas.openxmlformats.org/drawingml/2006/main">
               <a:ext uri="{FF2B5EF4-FFF2-40B4-BE49-F238E27FC236}">
-                <a16:creationId xmlns:a16="http://schemas.microsoft.com/office/drawing/2014/main" id="{CD844A95-644D-49C5-9F72-0B41B90D3F1D}"/>
+                <a16:creationId xmlns:a16="http://schemas.microsoft.com/office/drawing/2014/main" id="{E37371D9-690B-4043-8C16-F9F96AE106BC}"/>
               </a:ext>
             </a:extLst>
           </p:cNvPr>
@@ -6026,7 +6026,7 @@
           <p:cNvPr id="5" name="">
             <a:extLst xmlns:a="http://schemas.openxmlformats.org/drawingml/2006/main">
               <a:ext uri="{FF2B5EF4-FFF2-40B4-BE49-F238E27FC236}">
-                <a16:creationId xmlns:a16="http://schemas.microsoft.com/office/drawing/2014/main" id="{B5FA37C5-972A-4F71-9494-535663F49EF4}"/>
+                <a16:creationId xmlns:a16="http://schemas.microsoft.com/office/drawing/2014/main" id="{C86C79BB-F31A-4495-A9D2-D7596210C494}"/>
               </a:ext>
             </a:extLst>
           </p:cNvPr>
@@ -6076,7 +6076,7 @@
           <p:cNvPr id="6" name="">
             <a:extLst xmlns:a="http://schemas.openxmlformats.org/drawingml/2006/main">
               <a:ext uri="{FF2B5EF4-FFF2-40B4-BE49-F238E27FC236}">
-                <a16:creationId xmlns:a16="http://schemas.microsoft.com/office/drawing/2014/main" id="{32A5285B-25AB-4C26-9F66-25AD6775738E}"/>
+                <a16:creationId xmlns:a16="http://schemas.microsoft.com/office/drawing/2014/main" id="{FB31937C-1CF3-4DFF-9554-DF39C3F524DA}"/>
               </a:ext>
             </a:extLst>
           </p:cNvPr>
@@ -6126,7 +6126,7 @@
           <p:cNvPr id="7" name="">
             <a:extLst xmlns:a="http://schemas.openxmlformats.org/drawingml/2006/main">
               <a:ext uri="{FF2B5EF4-FFF2-40B4-BE49-F238E27FC236}">
-                <a16:creationId xmlns:a16="http://schemas.microsoft.com/office/drawing/2014/main" id="{A92E47A6-21C6-4FF1-B51D-AA0975D1034E}"/>
+                <a16:creationId xmlns:a16="http://schemas.microsoft.com/office/drawing/2014/main" id="{63227B20-C0B5-4F51-888C-7BE7F3710906}"/>
               </a:ext>
             </a:extLst>
           </p:cNvPr>
@@ -6176,7 +6176,7 @@
           <p:cNvPr id="8" name="">
             <a:extLst xmlns:a="http://schemas.openxmlformats.org/drawingml/2006/main">
               <a:ext uri="{FF2B5EF4-FFF2-40B4-BE49-F238E27FC236}">
-                <a16:creationId xmlns:a16="http://schemas.microsoft.com/office/drawing/2014/main" id="{7C8B933E-8B3C-4DB7-A015-963D8270EF27}"/>
+                <a16:creationId xmlns:a16="http://schemas.microsoft.com/office/drawing/2014/main" id="{4FB3DE95-48C8-4CFE-8A34-A48DD90E061C}"/>
               </a:ext>
             </a:extLst>
           </p:cNvPr>
@@ -6207,7 +6207,7 @@
           <p:cNvPr id="9" name="">
             <a:extLst xmlns:a="http://schemas.openxmlformats.org/drawingml/2006/main">
               <a:ext uri="{FF2B5EF4-FFF2-40B4-BE49-F238E27FC236}">
-                <a16:creationId xmlns:a16="http://schemas.microsoft.com/office/drawing/2014/main" id="{D90D69F9-146D-481A-B6F6-981D1F3ECCCC}"/>
+                <a16:creationId xmlns:a16="http://schemas.microsoft.com/office/drawing/2014/main" id="{269276DC-0F8B-45E7-A0D1-C49AD66E77B3}"/>
               </a:ext>
             </a:extLst>
           </p:cNvPr>
@@ -6257,7 +6257,7 @@
           <p:cNvPr id="10" name="">
             <a:extLst xmlns:a="http://schemas.openxmlformats.org/drawingml/2006/main">
               <a:ext uri="{FF2B5EF4-FFF2-40B4-BE49-F238E27FC236}">
-                <a16:creationId xmlns:a16="http://schemas.microsoft.com/office/drawing/2014/main" id="{758B2D71-36AF-4784-99CE-2C1A9264C6C6}"/>
+                <a16:creationId xmlns:a16="http://schemas.microsoft.com/office/drawing/2014/main" id="{13E39843-810D-4711-B821-951C7C661419}"/>
               </a:ext>
             </a:extLst>
           </p:cNvPr>
@@ -6307,7 +6307,7 @@
           <p:cNvPr id="11" name="">
             <a:extLst xmlns:a="http://schemas.openxmlformats.org/drawingml/2006/main">
               <a:ext uri="{FF2B5EF4-FFF2-40B4-BE49-F238E27FC236}">
-                <a16:creationId xmlns:a16="http://schemas.microsoft.com/office/drawing/2014/main" id="{FFEBDF31-0F83-48B6-8776-8BDA86586CBA}"/>
+                <a16:creationId xmlns:a16="http://schemas.microsoft.com/office/drawing/2014/main" id="{A8ED50AB-071C-4196-926E-E303009E5800}"/>
               </a:ext>
             </a:extLst>
           </p:cNvPr>
@@ -6338,7 +6338,7 @@
           <p:cNvPr id="12" name="">
             <a:extLst xmlns:a="http://schemas.openxmlformats.org/drawingml/2006/main">
               <a:ext uri="{FF2B5EF4-FFF2-40B4-BE49-F238E27FC236}">
-                <a16:creationId xmlns:a16="http://schemas.microsoft.com/office/drawing/2014/main" id="{A0AEB4C7-05E8-47A8-9F55-69D8C8E54651}"/>
+                <a16:creationId xmlns:a16="http://schemas.microsoft.com/office/drawing/2014/main" id="{0908E668-70F5-4C3C-BC13-592ECF47485B}"/>
               </a:ext>
             </a:extLst>
           </p:cNvPr>
@@ -6388,7 +6388,7 @@
           <p:cNvPr id="13" name="">
             <a:extLst xmlns:a="http://schemas.openxmlformats.org/drawingml/2006/main">
               <a:ext uri="{FF2B5EF4-FFF2-40B4-BE49-F238E27FC236}">
-                <a16:creationId xmlns:a16="http://schemas.microsoft.com/office/drawing/2014/main" id="{989BEFB9-C90E-41BE-9A57-305F2D316A83}"/>
+                <a16:creationId xmlns:a16="http://schemas.microsoft.com/office/drawing/2014/main" id="{B54FB93C-3059-4B63-B6EC-30346AFCD074}"/>
               </a:ext>
             </a:extLst>
           </p:cNvPr>
@@ -6438,7 +6438,7 @@
           <p:cNvPr id="14" name="">
             <a:extLst xmlns:a="http://schemas.openxmlformats.org/drawingml/2006/main">
               <a:ext uri="{FF2B5EF4-FFF2-40B4-BE49-F238E27FC236}">
-                <a16:creationId xmlns:a16="http://schemas.microsoft.com/office/drawing/2014/main" id="{1FAC4B86-AAA1-40DC-AEFA-A1464EE820E5}"/>
+                <a16:creationId xmlns:a16="http://schemas.microsoft.com/office/drawing/2014/main" id="{B1853CBD-2BF7-42E2-AE17-F9A5083AA76F}"/>
               </a:ext>
             </a:extLst>
           </p:cNvPr>
@@ -6469,7 +6469,7 @@
           <p:cNvPr id="15" name="">
             <a:extLst xmlns:a="http://schemas.openxmlformats.org/drawingml/2006/main">
               <a:ext uri="{FF2B5EF4-FFF2-40B4-BE49-F238E27FC236}">
-                <a16:creationId xmlns:a16="http://schemas.microsoft.com/office/drawing/2014/main" id="{7DCDC191-1708-444F-9DB7-6A988D2EDABA}"/>
+                <a16:creationId xmlns:a16="http://schemas.microsoft.com/office/drawing/2014/main" id="{A11E0D65-CFDE-4D96-B378-354453A02F71}"/>
               </a:ext>
             </a:extLst>
           </p:cNvPr>
@@ -6519,7 +6519,7 @@
           <p:cNvPr id="16" name="">
             <a:extLst xmlns:a="http://schemas.openxmlformats.org/drawingml/2006/main">
               <a:ext uri="{FF2B5EF4-FFF2-40B4-BE49-F238E27FC236}">
-                <a16:creationId xmlns:a16="http://schemas.microsoft.com/office/drawing/2014/main" id="{DECD3011-1F07-43C8-9DB7-8A1B57B26A52}"/>
+                <a16:creationId xmlns:a16="http://schemas.microsoft.com/office/drawing/2014/main" id="{380BFFFD-C02C-41EF-889A-159567D2F399}"/>
               </a:ext>
             </a:extLst>
           </p:cNvPr>
@@ -6569,7 +6569,7 @@
           <p:cNvPr id="17" name="">
             <a:extLst xmlns:a="http://schemas.openxmlformats.org/drawingml/2006/main">
               <a:ext uri="{FF2B5EF4-FFF2-40B4-BE49-F238E27FC236}">
-                <a16:creationId xmlns:a16="http://schemas.microsoft.com/office/drawing/2014/main" id="{8F6EB9F9-DEA3-4F96-BA32-9ED7F3B2EBA2}"/>
+                <a16:creationId xmlns:a16="http://schemas.microsoft.com/office/drawing/2014/main" id="{219E267A-70EB-46D7-B525-D395056538B6}"/>
               </a:ext>
             </a:extLst>
           </p:cNvPr>
@@ -6600,7 +6600,7 @@
           <p:cNvPr id="18" name="">
             <a:extLst xmlns:a="http://schemas.openxmlformats.org/drawingml/2006/main">
               <a:ext uri="{FF2B5EF4-FFF2-40B4-BE49-F238E27FC236}">
-                <a16:creationId xmlns:a16="http://schemas.microsoft.com/office/drawing/2014/main" id="{080E2F84-9E5D-460A-847D-894B210BA2DD}"/>
+                <a16:creationId xmlns:a16="http://schemas.microsoft.com/office/drawing/2014/main" id="{40028E29-A887-462F-AA13-8EC818655155}"/>
               </a:ext>
             </a:extLst>
           </p:cNvPr>
@@ -6648,7 +6648,7 @@
     </p:spTree>
     <p:extLst>
       <p:ext uri="{BB962C8B-B14F-4D97-AF65-F5344CB8AC3E}">
-        <p14:creationId xmlns:p14="http://schemas.microsoft.com/office/powerpoint/2010/main" val="2040015817"/>
+        <p14:creationId xmlns:p14="http://schemas.microsoft.com/office/powerpoint/2010/main" val="174193006"/>
       </p:ext>
     </p:extLst>
   </p:cSld>

</xml_diff>